<commit_message>
Update slide 1 with yearly activity, conversion funnel and revenue charts
Co-Authored-By: Claude Opus 5.5 <noreply@anthropic.com>
Claude-Session: https://claude.ai/code/session_014bmYQ2fMPYk9mSnunBW5W4
</commit_message>
<xml_diff>
--- a/AX컨설팅팀_27년_중점과제.pptx
+++ b/AX컨설팅팀_27년_중점과제.pptx
@@ -113,41 +113,12 @@
   <c:date1904 val="0"/>
   <c:roundedCorners val="1"/>
   <c:chart>
-    <c:title>
-      <c:tx>
-        <c:rich>
-          <a:bodyPr/>
-          <a:lstStyle/>
-          <a:p>
-            <a:pPr>
-              <a:defRPr sz="1050" b="0" i="0" u="none" strike="noStrike">
-                <a:solidFill>
-                  <a:srgbClr val="5B6B82"/>
-                </a:solidFill>
-                <a:latin typeface="+mn-lt"/>
-              </a:defRPr>
-            </a:pPr>
-            <a:r>
-              <a:rPr sz="1050" b="0" i="0" u="none" strike="noStrike">
-                <a:solidFill>
-                  <a:srgbClr val="5B6B82"/>
-                </a:solidFill>
-                <a:latin typeface="+mn-lt"/>
-              </a:rPr>
-              <a:t>AI과제 Pool 영역별 분포 (총 108건)</a:t>
-            </a:r>
-          </a:p>
-        </c:rich>
-      </c:tx>
-      <c:layout/>
-      <c:overlay val="0"/>
-    </c:title>
-    <c:autoTitleDeleted val="0"/>
+    <c:autoTitleDeleted val="1"/>
     <c:plotArea>
       <c:layout/>
       <c:barChart>
         <c:barDir val="col"/>
-        <c:grouping val="clustered"/>
+        <c:grouping val="stacked"/>
         <c:varyColors val="0"/>
         <c:ser>
           <c:idx val="0"/>
@@ -158,7 +129,7 @@
               <c:strCache>
                 <c:ptCount val="1"/>
                 <c:pt idx="0">
-                  <c:v>AI과제 Pool</c:v>
+                  <c:v>AI컨설팅 그룹사</c:v>
                 </c:pt>
               </c:strCache>
             </c:strRef>
@@ -171,21 +142,22 @@
           </c:spPr>
           <c:invertIfNegative val="0"/>
           <c:dLbls>
-            <c:numFmt formatCode="#,##0" sourceLinked="0"/>
+            <c:numFmt formatCode="0;;" sourceLinked="0"/>
             <c:txPr>
               <a:bodyPr/>
               <a:lstStyle/>
               <a:p>
                 <a:pPr>
-                  <a:defRPr b="0" i="0" strike="noStrike" sz="1000" u="none">
+                  <a:defRPr b="0" i="0" strike="noStrike" sz="900" u="none">
                     <a:solidFill>
-                      <a:srgbClr val="1F2329"/>
+                      <a:srgbClr val="FFFFFF"/>
                     </a:solidFill>
                     <a:latin typeface="+mn-lt"/>
                   </a:defRPr>
                 </a:pPr>
               </a:p>
             </c:txPr>
+            <c:dLblPos val="ctr"/>
             <c:showLegendKey val="0"/>
             <c:showVal val="1"/>
             <c:showCatName val="0"/>
@@ -196,30 +168,17 @@
           </c:dLbls>
           <c:cat>
             <c:multiLvlStrRef>
-              <c:f>Sheet1!$A$2:$A$8</c:f>
+              <c:f>Sheet1!$A$2:$A$3</c:f>
               <c:multiLvlStrCache>
-                <c:ptCount val="7"/>
+                <c:ptCount val="2"/>
                 <c:lvl>
                   <c:pt idx="0">
-                    <c:v>경영관리</c:v>
+                    <c:v>2025년
+과제 77건</c:v>
                   </c:pt>
                   <c:pt idx="1">
-                    <c:v>R&amp;D</c:v>
-                  </c:pt>
-                  <c:pt idx="2">
-                    <c:v>구매</c:v>
-                  </c:pt>
-                  <c:pt idx="3">
-                    <c:v>생산</c:v>
-                  </c:pt>
-                  <c:pt idx="4">
-                    <c:v>물류</c:v>
-                  </c:pt>
-                  <c:pt idx="5">
-                    <c:v>영업</c:v>
-                  </c:pt>
-                  <c:pt idx="6">
-                    <c:v>마케팅</c:v>
+                    <c:v>2026년
+과제 31건</c:v>
                   </c:pt>
                 </c:lvl>
               </c:multiLvlStrCache>
@@ -227,51 +186,277 @@
           </c:cat>
           <c:val>
             <c:numRef>
-              <c:f>Sheet1!$B$2:$B$8</c:f>
+              <c:f>Sheet1!$B$2:$B$3</c:f>
               <c:numCache>
                 <c:formatCode>General</c:formatCode>
-                <c:ptCount val="7"/>
+                <c:ptCount val="2"/>
                 <c:pt idx="0">
-                  <c:v>25</c:v>
+                  <c:v>13</c:v>
                 </c:pt>
                 <c:pt idx="1">
-                  <c:v>11</c:v>
+                  <c:v>4</c:v>
                 </c:pt>
-                <c:pt idx="2">
-                  <c:v>10</c:v>
+              </c:numCache>
+            </c:numRef>
+          </c:val>
+        </c:ser>
+        <c:ser>
+          <c:idx val="1"/>
+          <c:order val="1"/>
+          <c:tx>
+            <c:strRef>
+              <c:f>Sheet1!$C$1</c:f>
+              <c:strCache>
+                <c:ptCount val="1"/>
+                <c:pt idx="0">
+                  <c:v>AI컨설팅 대외</c:v>
                 </c:pt>
-                <c:pt idx="3">
-                  <c:v>9</c:v>
+              </c:strCache>
+            </c:strRef>
+          </c:tx>
+          <c:spPr>
+            <a:solidFill>
+              <a:srgbClr val="7FA1D6"/>
+            </a:solidFill>
+            <a:effectLst/>
+          </c:spPr>
+          <c:invertIfNegative val="0"/>
+          <c:dLbls>
+            <c:numFmt formatCode="0;;" sourceLinked="0"/>
+            <c:txPr>
+              <a:bodyPr/>
+              <a:lstStyle/>
+              <a:p>
+                <a:pPr>
+                  <a:defRPr b="0" i="0" strike="noStrike" sz="900" u="none">
+                    <a:solidFill>
+                      <a:srgbClr val="FFFFFF"/>
+                    </a:solidFill>
+                    <a:latin typeface="+mn-lt"/>
+                  </a:defRPr>
+                </a:pPr>
+              </a:p>
+            </c:txPr>
+            <c:dLblPos val="ctr"/>
+            <c:showLegendKey val="0"/>
+            <c:showVal val="1"/>
+            <c:showCatName val="0"/>
+            <c:showSerName val="0"/>
+            <c:showPercent val="0"/>
+            <c:showBubbleSize val="0"/>
+            <c:showLeaderLines val="0"/>
+          </c:dLbls>
+          <c:cat>
+            <c:multiLvlStrRef>
+              <c:f>Sheet1!$A$2:$A$3</c:f>
+              <c:multiLvlStrCache>
+                <c:ptCount val="2"/>
+                <c:lvl>
+                  <c:pt idx="0">
+                    <c:v>2025년
+과제 77건</c:v>
+                  </c:pt>
+                  <c:pt idx="1">
+                    <c:v>2026년
+과제 31건</c:v>
+                  </c:pt>
+                </c:lvl>
+              </c:multiLvlStrCache>
+            </c:multiLvlStrRef>
+          </c:cat>
+          <c:val>
+            <c:numRef>
+              <c:f>Sheet1!$C$2:$C$3</c:f>
+              <c:numCache>
+                <c:formatCode>General</c:formatCode>
+                <c:ptCount val="2"/>
+                <c:pt idx="0">
+                  <c:v>2</c:v>
                 </c:pt>
-                <c:pt idx="4">
-                  <c:v>13</c:v>
+                <c:pt idx="1">
+                  <c:v>2</c:v>
                 </c:pt>
-                <c:pt idx="5">
-                  <c:v>17</c:v>
+              </c:numCache>
+            </c:numRef>
+          </c:val>
+        </c:ser>
+        <c:ser>
+          <c:idx val="2"/>
+          <c:order val="2"/>
+          <c:tx>
+            <c:strRef>
+              <c:f>Sheet1!$D$1</c:f>
+              <c:strCache>
+                <c:ptCount val="1"/>
+                <c:pt idx="0">
+                  <c:v>교육·Camp 그룹사</c:v>
                 </c:pt>
-                <c:pt idx="6">
-                  <c:v>23</c:v>
+              </c:strCache>
+            </c:strRef>
+          </c:tx>
+          <c:spPr>
+            <a:solidFill>
+              <a:srgbClr val="0F7B6C"/>
+            </a:solidFill>
+            <a:effectLst/>
+          </c:spPr>
+          <c:invertIfNegative val="0"/>
+          <c:dLbls>
+            <c:numFmt formatCode="0;;" sourceLinked="0"/>
+            <c:txPr>
+              <a:bodyPr/>
+              <a:lstStyle/>
+              <a:p>
+                <a:pPr>
+                  <a:defRPr b="0" i="0" strike="noStrike" sz="900" u="none">
+                    <a:solidFill>
+                      <a:srgbClr val="FFFFFF"/>
+                    </a:solidFill>
+                    <a:latin typeface="+mn-lt"/>
+                  </a:defRPr>
+                </a:pPr>
+              </a:p>
+            </c:txPr>
+            <c:dLblPos val="ctr"/>
+            <c:showLegendKey val="0"/>
+            <c:showVal val="1"/>
+            <c:showCatName val="0"/>
+            <c:showSerName val="0"/>
+            <c:showPercent val="0"/>
+            <c:showBubbleSize val="0"/>
+            <c:showLeaderLines val="0"/>
+          </c:dLbls>
+          <c:cat>
+            <c:multiLvlStrRef>
+              <c:f>Sheet1!$A$2:$A$3</c:f>
+              <c:multiLvlStrCache>
+                <c:ptCount val="2"/>
+                <c:lvl>
+                  <c:pt idx="0">
+                    <c:v>2025년
+과제 77건</c:v>
+                  </c:pt>
+                  <c:pt idx="1">
+                    <c:v>2026년
+과제 31건</c:v>
+                  </c:pt>
+                </c:lvl>
+              </c:multiLvlStrCache>
+            </c:multiLvlStrRef>
+          </c:cat>
+          <c:val>
+            <c:numRef>
+              <c:f>Sheet1!$D$2:$D$3</c:f>
+              <c:numCache>
+                <c:formatCode>General</c:formatCode>
+                <c:ptCount val="2"/>
+                <c:pt idx="0">
+                  <c:v>0</c:v>
+                </c:pt>
+                <c:pt idx="1">
+                  <c:v>5</c:v>
+                </c:pt>
+              </c:numCache>
+            </c:numRef>
+          </c:val>
+        </c:ser>
+        <c:ser>
+          <c:idx val="3"/>
+          <c:order val="3"/>
+          <c:tx>
+            <c:strRef>
+              <c:f>Sheet1!$E$1</c:f>
+              <c:strCache>
+                <c:ptCount val="1"/>
+                <c:pt idx="0">
+                  <c:v>교육·Camp 대외</c:v>
+                </c:pt>
+              </c:strCache>
+            </c:strRef>
+          </c:tx>
+          <c:spPr>
+            <a:solidFill>
+              <a:srgbClr val="8CCFC3"/>
+            </a:solidFill>
+            <a:effectLst/>
+          </c:spPr>
+          <c:invertIfNegative val="0"/>
+          <c:dLbls>
+            <c:numFmt formatCode="0;;" sourceLinked="0"/>
+            <c:txPr>
+              <a:bodyPr/>
+              <a:lstStyle/>
+              <a:p>
+                <a:pPr>
+                  <a:defRPr b="0" i="0" strike="noStrike" sz="900" u="none">
+                    <a:solidFill>
+                      <a:srgbClr val="FFFFFF"/>
+                    </a:solidFill>
+                    <a:latin typeface="+mn-lt"/>
+                  </a:defRPr>
+                </a:pPr>
+              </a:p>
+            </c:txPr>
+            <c:dLblPos val="ctr"/>
+            <c:showLegendKey val="0"/>
+            <c:showVal val="1"/>
+            <c:showCatName val="0"/>
+            <c:showSerName val="0"/>
+            <c:showPercent val="0"/>
+            <c:showBubbleSize val="0"/>
+            <c:showLeaderLines val="0"/>
+          </c:dLbls>
+          <c:cat>
+            <c:multiLvlStrRef>
+              <c:f>Sheet1!$A$2:$A$3</c:f>
+              <c:multiLvlStrCache>
+                <c:ptCount val="2"/>
+                <c:lvl>
+                  <c:pt idx="0">
+                    <c:v>2025년
+과제 77건</c:v>
+                  </c:pt>
+                  <c:pt idx="1">
+                    <c:v>2026년
+과제 31건</c:v>
+                  </c:pt>
+                </c:lvl>
+              </c:multiLvlStrCache>
+            </c:multiLvlStrRef>
+          </c:cat>
+          <c:val>
+            <c:numRef>
+              <c:f>Sheet1!$E$2:$E$3</c:f>
+              <c:numCache>
+                <c:formatCode>General</c:formatCode>
+                <c:ptCount val="2"/>
+                <c:pt idx="0">
+                  <c:v>0</c:v>
+                </c:pt>
+                <c:pt idx="1">
+                  <c:v>1</c:v>
                 </c:pt>
               </c:numCache>
             </c:numRef>
           </c:val>
         </c:ser>
         <c:dLbls>
-          <c:numFmt formatCode="#,##0" sourceLinked="0"/>
+          <c:numFmt formatCode="0;;" sourceLinked="0"/>
           <c:txPr>
             <a:bodyPr/>
             <a:lstStyle/>
             <a:p>
               <a:pPr>
-                <a:defRPr b="0" i="0" strike="noStrike" sz="1000" u="none">
+                <a:defRPr b="0" i="0" strike="noStrike" sz="900" u="none">
                   <a:solidFill>
-                    <a:srgbClr val="1F2329"/>
+                    <a:srgbClr val="FFFFFF"/>
                   </a:solidFill>
                   <a:latin typeface="+mn-lt"/>
                 </a:defRPr>
               </a:pPr>
             </a:p>
           </c:txPr>
+          <c:dLblPos val="ctr"/>
           <c:showLegendKey val="0"/>
           <c:showVal val="1"/>
           <c:showCatName val="0"/>
@@ -280,8 +465,8 @@
           <c:showBubbleSize val="0"/>
           <c:showLeaderLines val="0"/>
         </c:dLbls>
-        <c:gapWidth val="60"/>
-        <c:overlap val="0"/>
+        <c:gapWidth val="55"/>
+        <c:overlap val="100"/>
         <c:axId val="2094734554"/>
         <c:axId val="2094734552"/>
         <c:axId val="2094734556"/>
@@ -311,7 +496,7 @@
           <a:lstStyle/>
           <a:p>
             <a:pPr>
-              <a:defRPr sz="1000" b="0" i="0" u="none" strike="noStrike">
+              <a:defRPr sz="900" b="0" i="0" u="none" strike="noStrike">
                 <a:solidFill>
                   <a:srgbClr val="1F2329"/>
                 </a:solidFill>
@@ -331,7 +516,7 @@
         <c:axId val="2094734552"/>
         <c:scaling>
           <c:orientation val="minMax"/>
-          <c:max val="30"/>
+          <c:max val="15"/>
         </c:scaling>
         <c:delete val="1"/>
         <c:axPos val="l"/>
@@ -375,6 +560,362 @@
         <a:effectLst/>
       </c:spPr>
     </c:plotArea>
+    <c:legend>
+      <c:legendPos val="r"/>
+      <c:overlay val="0"/>
+      <c:txPr>
+        <a:bodyPr/>
+        <a:lstStyle/>
+        <a:p>
+          <a:pPr>
+            <a:defRPr sz="800">
+              <a:solidFill>
+                <a:srgbClr val="1F2329"/>
+              </a:solidFill>
+              <a:latin typeface="+mn-lt"/>
+              <a:cs typeface="+mn-lt"/>
+            </a:defRPr>
+          </a:pPr>
+          <a:endParaRPr lang="en-US"/>
+        </a:p>
+      </c:txPr>
+    </c:legend>
+    <c:plotVisOnly val="1"/>
+    <c:dispBlanksAs val="span"/>
+  </c:chart>
+  <c:spPr>
+    <a:noFill/>
+    <a:ln>
+      <a:noFill/>
+    </a:ln>
+    <a:effectLst/>
+  </c:spPr>
+  <c:externalData r:id="rId1">
+    <c:autoUpdate val="0"/>
+  </c:externalData>
+</c:chartSpace>
+</file>
+
+<file path=ppt/charts/chart2.xml><?xml version="1.0" encoding="utf-8"?>
+<c:chartSpace xmlns:c="http://schemas.openxmlformats.org/drawingml/2006/chart" xmlns:a="http://schemas.openxmlformats.org/drawingml/2006/main" xmlns:r="http://schemas.openxmlformats.org/officeDocument/2006/relationships">
+  <c:date1904 val="0"/>
+  <c:roundedCorners val="1"/>
+  <c:chart>
+    <c:autoTitleDeleted val="1"/>
+    <c:plotArea>
+      <c:layout/>
+      <c:barChart>
+        <c:barDir val="bar"/>
+        <c:grouping val="stacked"/>
+        <c:varyColors val="0"/>
+        <c:ser>
+          <c:idx val="0"/>
+          <c:order val="0"/>
+          <c:tx>
+            <c:strRef>
+              <c:f>Sheet1!$B$1</c:f>
+              <c:strCache>
+                <c:ptCount val="1"/>
+                <c:pt idx="0">
+                  <c:v>26년 수주 (AI사업분)</c:v>
+                </c:pt>
+              </c:strCache>
+            </c:strRef>
+          </c:tx>
+          <c:spPr>
+            <a:solidFill>
+              <a:srgbClr val="1F4E9A"/>
+            </a:solidFill>
+            <a:effectLst/>
+          </c:spPr>
+          <c:invertIfNegative val="0"/>
+          <c:dLbls>
+            <c:numFmt formatCode="0.0#;;" sourceLinked="0"/>
+            <c:txPr>
+              <a:bodyPr/>
+              <a:lstStyle/>
+              <a:p>
+                <a:pPr>
+                  <a:defRPr b="0" i="0" strike="noStrike" sz="1000" u="none">
+                    <a:solidFill>
+                      <a:srgbClr val="FFFFFF"/>
+                    </a:solidFill>
+                    <a:latin typeface="+mn-lt"/>
+                  </a:defRPr>
+                </a:pPr>
+              </a:p>
+            </c:txPr>
+            <c:dLblPos val="inEnd"/>
+            <c:showLegendKey val="0"/>
+            <c:showVal val="1"/>
+            <c:showCatName val="0"/>
+            <c:showSerName val="0"/>
+            <c:showPercent val="0"/>
+            <c:showBubbleSize val="0"/>
+            <c:showLeaderLines val="0"/>
+          </c:dLbls>
+          <c:cat>
+            <c:multiLvlStrRef>
+              <c:f>Sheet1!$A$2:$A$4</c:f>
+              <c:multiLvlStrCache>
+                <c:ptCount val="3"/>
+                <c:lvl>
+                  <c:pt idx="0">
+                    <c:v>신분당선</c:v>
+                  </c:pt>
+                  <c:pt idx="1">
+                    <c:v>공항철도</c:v>
+                  </c:pt>
+                  <c:pt idx="2">
+                    <c:v>물산</c:v>
+                  </c:pt>
+                </c:lvl>
+              </c:multiLvlStrCache>
+            </c:multiLvlStrRef>
+          </c:cat>
+          <c:val>
+            <c:numRef>
+              <c:f>Sheet1!$B$2:$B$4</c:f>
+              <c:numCache>
+                <c:formatCode>General</c:formatCode>
+                <c:ptCount val="3"/>
+                <c:pt idx="0">
+                  <c:v>12.5</c:v>
+                </c:pt>
+                <c:pt idx="1">
+                  <c:v>0</c:v>
+                </c:pt>
+                <c:pt idx="2">
+                  <c:v>0</c:v>
+                </c:pt>
+              </c:numCache>
+            </c:numRef>
+          </c:val>
+        </c:ser>
+        <c:ser>
+          <c:idx val="1"/>
+          <c:order val="1"/>
+          <c:tx>
+            <c:strRef>
+              <c:f>Sheet1!$C$1</c:f>
+              <c:strCache>
+                <c:ptCount val="1"/>
+                <c:pt idx="0">
+                  <c:v>27년 수주 인벤토리</c:v>
+                </c:pt>
+              </c:strCache>
+            </c:strRef>
+          </c:tx>
+          <c:spPr>
+            <a:solidFill>
+              <a:srgbClr val="7FA1D6"/>
+            </a:solidFill>
+            <a:effectLst/>
+          </c:spPr>
+          <c:invertIfNegative val="0"/>
+          <c:dLbls>
+            <c:numFmt formatCode="0.0#;;" sourceLinked="0"/>
+            <c:txPr>
+              <a:bodyPr/>
+              <a:lstStyle/>
+              <a:p>
+                <a:pPr>
+                  <a:defRPr b="0" i="0" strike="noStrike" sz="1000" u="none">
+                    <a:solidFill>
+                      <a:srgbClr val="FFFFFF"/>
+                    </a:solidFill>
+                    <a:latin typeface="+mn-lt"/>
+                  </a:defRPr>
+                </a:pPr>
+              </a:p>
+            </c:txPr>
+            <c:dLblPos val="inEnd"/>
+            <c:showLegendKey val="0"/>
+            <c:showVal val="1"/>
+            <c:showCatName val="0"/>
+            <c:showSerName val="0"/>
+            <c:showPercent val="0"/>
+            <c:showBubbleSize val="0"/>
+            <c:showLeaderLines val="0"/>
+          </c:dLbls>
+          <c:cat>
+            <c:multiLvlStrRef>
+              <c:f>Sheet1!$A$2:$A$4</c:f>
+              <c:multiLvlStrCache>
+                <c:ptCount val="3"/>
+                <c:lvl>
+                  <c:pt idx="0">
+                    <c:v>신분당선</c:v>
+                  </c:pt>
+                  <c:pt idx="1">
+                    <c:v>공항철도</c:v>
+                  </c:pt>
+                  <c:pt idx="2">
+                    <c:v>물산</c:v>
+                  </c:pt>
+                </c:lvl>
+              </c:multiLvlStrCache>
+            </c:multiLvlStrRef>
+          </c:cat>
+          <c:val>
+            <c:numRef>
+              <c:f>Sheet1!$C$2:$C$4</c:f>
+              <c:numCache>
+                <c:formatCode>General</c:formatCode>
+                <c:ptCount val="3"/>
+                <c:pt idx="0">
+                  <c:v>0</c:v>
+                </c:pt>
+                <c:pt idx="1">
+                  <c:v>5.71</c:v>
+                </c:pt>
+                <c:pt idx="2">
+                  <c:v>2.89</c:v>
+                </c:pt>
+              </c:numCache>
+            </c:numRef>
+          </c:val>
+        </c:ser>
+        <c:dLbls>
+          <c:numFmt formatCode="0.0#;;" sourceLinked="0"/>
+          <c:txPr>
+            <a:bodyPr/>
+            <a:lstStyle/>
+            <a:p>
+              <a:pPr>
+                <a:defRPr b="0" i="0" strike="noStrike" sz="1000" u="none">
+                  <a:solidFill>
+                    <a:srgbClr val="FFFFFF"/>
+                  </a:solidFill>
+                  <a:latin typeface="+mn-lt"/>
+                </a:defRPr>
+              </a:pPr>
+            </a:p>
+          </c:txPr>
+          <c:dLblPos val="inEnd"/>
+          <c:showLegendKey val="0"/>
+          <c:showVal val="1"/>
+          <c:showCatName val="0"/>
+          <c:showSerName val="0"/>
+          <c:showPercent val="0"/>
+          <c:showBubbleSize val="0"/>
+          <c:showLeaderLines val="0"/>
+        </c:dLbls>
+        <c:gapWidth val="45"/>
+        <c:overlap val="100"/>
+        <c:axId val="2094734554"/>
+        <c:axId val="2094734552"/>
+        <c:axId val="2094734556"/>
+      </c:barChart>
+      <c:catAx>
+        <c:axId val="2094734554"/>
+        <c:scaling>
+          <c:orientation val="maxMin"/>
+        </c:scaling>
+        <c:delete val="0"/>
+        <c:axPos val="l"/>
+        <c:numFmt formatCode="General" sourceLinked="1"/>
+        <c:majorTickMark val="out"/>
+        <c:minorTickMark val="none"/>
+        <c:tickLblPos val="nextTo"/>
+        <c:spPr>
+          <a:ln w="12700" cap="flat">
+            <a:solidFill>
+              <a:srgbClr val="888888"/>
+            </a:solidFill>
+            <a:prstDash val="solid"/>
+            <a:round/>
+          </a:ln>
+        </c:spPr>
+        <c:txPr>
+          <a:bodyPr/>
+          <a:lstStyle/>
+          <a:p>
+            <a:pPr>
+              <a:defRPr sz="1000" b="0" i="0" u="none" strike="noStrike">
+                <a:solidFill>
+                  <a:srgbClr val="1F2329"/>
+                </a:solidFill>
+                <a:latin typeface="+mn-lt"/>
+              </a:defRPr>
+            </a:pPr>
+            <a:endParaRPr lang="en-US"/>
+          </a:p>
+        </c:txPr>
+        <c:crossAx val="2094734552"/>
+        <c:crosses val="autoZero"/>
+        <c:auto val="1"/>
+        <c:lblAlgn val="ctr"/>
+        <c:noMultiLvlLbl val="1"/>
+      </c:catAx>
+      <c:valAx>
+        <c:axId val="2094734552"/>
+        <c:scaling>
+          <c:orientation val="minMax"/>
+          <c:max val="14"/>
+        </c:scaling>
+        <c:delete val="1"/>
+        <c:axPos val="b"/>
+        <c:numFmt formatCode="General" sourceLinked="0"/>
+        <c:majorTickMark val="out"/>
+        <c:minorTickMark val="none"/>
+        <c:tickLblPos val="low"/>
+        <c:spPr>
+          <a:ln w="12700" cap="flat">
+            <a:solidFill>
+              <a:srgbClr val="888888"/>
+            </a:solidFill>
+            <a:prstDash val="solid"/>
+            <a:round/>
+          </a:ln>
+        </c:spPr>
+        <c:txPr>
+          <a:bodyPr/>
+          <a:lstStyle/>
+          <a:p>
+            <a:pPr>
+              <a:defRPr sz="1200" b="0" i="0" u="none" strike="noStrike">
+                <a:solidFill>
+                  <a:srgbClr val="000000"/>
+                </a:solidFill>
+                <a:latin typeface="Arial"/>
+              </a:defRPr>
+            </a:pPr>
+            <a:endParaRPr lang="en-US"/>
+          </a:p>
+        </c:txPr>
+        <c:crossAx val="2094734554"/>
+        <c:crosses val="autoZero"/>
+        <c:crossBetween val="between"/>
+      </c:valAx>
+      <c:spPr>
+        <a:noFill/>
+        <a:ln>
+          <a:noFill/>
+        </a:ln>
+        <a:effectLst/>
+      </c:spPr>
+    </c:plotArea>
+    <c:legend>
+      <c:legendPos val="r"/>
+      <c:overlay val="0"/>
+      <c:txPr>
+        <a:bodyPr/>
+        <a:lstStyle/>
+        <a:p>
+          <a:pPr>
+            <a:defRPr sz="900">
+              <a:solidFill>
+                <a:srgbClr val="1F2329"/>
+              </a:solidFill>
+              <a:latin typeface="+mn-lt"/>
+              <a:cs typeface="+mn-lt"/>
+            </a:defRPr>
+          </a:pPr>
+          <a:endParaRPr lang="en-US"/>
+        </a:p>
+      </c:txPr>
+    </c:legend>
     <c:plotVisOnly val="1"/>
     <c:dispBlanksAs val="span"/>
   </c:chart>
@@ -1634,41 +2175,14 @@
       </p:sp>
       <p:sp>
         <p:nvSpPr>
-          <p:cNvPr id="10" name="stat 제안"/>
-          <p:cNvSpPr/>
-          <p:nvPr/>
-        </p:nvSpPr>
-        <p:spPr>
-          <a:xfrm>
-            <a:off x="502920" y="2011680"/>
-            <a:ext cx="1722120" cy="566928"/>
-          </a:xfrm>
-          <a:prstGeom prst="roundRect">
-            <a:avLst>
-              <a:gd name="adj" fmla="val 9677"/>
-            </a:avLst>
-          </a:prstGeom>
-          <a:solidFill>
-            <a:schemeClr val="accent4"/>
-          </a:solidFill>
-          <a:ln w="12700">
-            <a:solidFill>
-              <a:schemeClr val="accent4"/>
-            </a:solidFill>
-            <a:prstDash val="solid"/>
-          </a:ln>
-        </p:spPr>
-      </p:sp>
-      <p:sp>
-        <p:nvSpPr>
-          <p:cNvPr id="11" name="Text 9"/>
+          <p:cNvPr id="10" name="Text 8"/>
           <p:cNvSpPr txBox="1"/>
           <p:nvPr/>
         </p:nvSpPr>
         <p:spPr>
           <a:xfrm>
-            <a:off x="502920" y="2011680"/>
-            <a:ext cx="1722120" cy="566928"/>
+            <a:off x="502920" y="1956816"/>
+            <a:ext cx="3154680" cy="228600"/>
           </a:xfrm>
           <a:prstGeom prst="rect">
             <a:avLst/>
@@ -1684,205 +2198,26 @@
               <a:buNone/>
             </a:pPr>
             <a:r>
-              <a:rPr lang="en-US" sz="1050" dirty="0">
+              <a:rPr lang="en-US" sz="1000" dirty="0">
                 <a:solidFill>
                   <a:schemeClr val="accent5"/>
                 </a:solidFill>
               </a:rPr>
-              <a:t>제안</a:t>
-            </a:r>
-            <a:endParaRPr lang="en-US" sz="1050" dirty="0"/>
-          </a:p>
-          <a:p>
-            <a:pPr algn="ctr" indent="0" marL="0">
-              <a:buNone/>
-            </a:pPr>
-            <a:r>
-              <a:rPr lang="en-US" sz="1800" b="1" dirty="0">
-                <a:solidFill>
-                  <a:schemeClr val="accent1"/>
-                </a:solidFill>
-              </a:rPr>
-              <a:t>10</a:t>
-            </a:r>
-            <a:endParaRPr lang="en-US" sz="1050" dirty="0"/>
-          </a:p>
-        </p:txBody>
-      </p:sp>
-      <p:sp>
-        <p:nvSpPr>
-          <p:cNvPr id="12" name="stat 프로젝트 수행"/>
-          <p:cNvSpPr/>
-          <p:nvPr/>
-        </p:nvSpPr>
-        <p:spPr>
-          <a:xfrm>
-            <a:off x="2316480" y="2011680"/>
-            <a:ext cx="1722120" cy="566928"/>
-          </a:xfrm>
-          <a:prstGeom prst="roundRect">
-            <a:avLst>
-              <a:gd name="adj" fmla="val 9677"/>
-            </a:avLst>
-          </a:prstGeom>
-          <a:solidFill>
-            <a:schemeClr val="accent4"/>
-          </a:solidFill>
-          <a:ln w="12700">
-            <a:solidFill>
-              <a:schemeClr val="accent4"/>
-            </a:solidFill>
-            <a:prstDash val="solid"/>
-          </a:ln>
-        </p:spPr>
-      </p:sp>
-      <p:sp>
-        <p:nvSpPr>
-          <p:cNvPr id="13" name="Text 11"/>
-          <p:cNvSpPr txBox="1"/>
-          <p:nvPr/>
-        </p:nvSpPr>
-        <p:spPr>
-          <a:xfrm>
-            <a:off x="2316480" y="2011680"/>
-            <a:ext cx="1722120" cy="566928"/>
-          </a:xfrm>
-          <a:prstGeom prst="rect">
-            <a:avLst/>
-          </a:prstGeom>
-          <a:noFill/>
-          <a:ln/>
-        </p:spPr>
-        <p:txBody>
-          <a:bodyPr wrap="square" lIns="0" tIns="0" rIns="0" bIns="0" rtlCol="0" anchor="ctr"/>
-          <a:lstStyle/>
-          <a:p>
-            <a:pPr algn="ctr" indent="0" marL="0">
-              <a:buNone/>
-            </a:pPr>
-            <a:r>
-              <a:rPr lang="en-US" sz="1050" dirty="0">
-                <a:solidFill>
-                  <a:schemeClr val="accent5"/>
-                </a:solidFill>
-              </a:rPr>
-              <a:t>프로젝트 수행</a:t>
-            </a:r>
-            <a:endParaRPr lang="en-US" sz="1050" dirty="0"/>
-          </a:p>
-          <a:p>
-            <a:pPr algn="ctr" indent="0" marL="0">
-              <a:buNone/>
-            </a:pPr>
-            <a:r>
-              <a:rPr lang="en-US" sz="1800" b="1" dirty="0">
-                <a:solidFill>
-                  <a:schemeClr val="accent1"/>
-                </a:solidFill>
-              </a:rPr>
-              <a:t>27</a:t>
-            </a:r>
-            <a:pPr algn="ctr" indent="0" marL="0">
-              <a:buNone/>
-            </a:pPr>
-            <a:r>
-              <a:rPr lang="en-US" sz="950" dirty="0">
-                <a:solidFill>
-                  <a:schemeClr val="accent5"/>
-                </a:solidFill>
-              </a:rPr>
-              <a:t>  (그룹사 22 · 대외 5)</a:t>
-            </a:r>
-            <a:endParaRPr lang="en-US" sz="1050" dirty="0"/>
-          </a:p>
-        </p:txBody>
-      </p:sp>
-      <p:sp>
-        <p:nvSpPr>
-          <p:cNvPr id="14" name="stat AI과제 Pool"/>
-          <p:cNvSpPr/>
-          <p:nvPr/>
-        </p:nvSpPr>
-        <p:spPr>
-          <a:xfrm>
-            <a:off x="4130040" y="2011680"/>
-            <a:ext cx="1722120" cy="566928"/>
-          </a:xfrm>
-          <a:prstGeom prst="roundRect">
-            <a:avLst>
-              <a:gd name="adj" fmla="val 9677"/>
-            </a:avLst>
-          </a:prstGeom>
-          <a:solidFill>
-            <a:schemeClr val="accent4"/>
-          </a:solidFill>
-          <a:ln w="12700">
-            <a:solidFill>
-              <a:schemeClr val="accent4"/>
-            </a:solidFill>
-            <a:prstDash val="solid"/>
-          </a:ln>
-        </p:spPr>
-      </p:sp>
-      <p:sp>
-        <p:nvSpPr>
-          <p:cNvPr id="15" name="Text 13"/>
-          <p:cNvSpPr txBox="1"/>
-          <p:nvPr/>
-        </p:nvSpPr>
-        <p:spPr>
-          <a:xfrm>
-            <a:off x="4130040" y="2011680"/>
-            <a:ext cx="1722120" cy="566928"/>
-          </a:xfrm>
-          <a:prstGeom prst="rect">
-            <a:avLst/>
-          </a:prstGeom>
-          <a:noFill/>
-          <a:ln/>
-        </p:spPr>
-        <p:txBody>
-          <a:bodyPr wrap="square" lIns="0" tIns="0" rIns="0" bIns="0" rtlCol="0" anchor="ctr"/>
-          <a:lstStyle/>
-          <a:p>
-            <a:pPr algn="ctr" indent="0" marL="0">
-              <a:buNone/>
-            </a:pPr>
-            <a:r>
-              <a:rPr lang="en-US" sz="1050" dirty="0">
-                <a:solidFill>
-                  <a:schemeClr val="accent5"/>
-                </a:solidFill>
-              </a:rPr>
-              <a:t>AI과제 Pool</a:t>
-            </a:r>
-            <a:endParaRPr lang="en-US" sz="1050" dirty="0"/>
-          </a:p>
-          <a:p>
-            <a:pPr algn="ctr" indent="0" marL="0">
-              <a:buNone/>
-            </a:pPr>
-            <a:r>
-              <a:rPr lang="en-US" sz="1800" b="1" dirty="0">
-                <a:solidFill>
-                  <a:schemeClr val="accent1"/>
-                </a:solidFill>
-              </a:rPr>
-              <a:t>108</a:t>
-            </a:r>
-            <a:endParaRPr lang="en-US" sz="1050" dirty="0"/>
+              <a:t>연도별 프로젝트 수행 및 과제 발굴</a:t>
+            </a:r>
+            <a:endParaRPr lang="en-US" sz="1000" dirty="0"/>
           </a:p>
         </p:txBody>
       </p:sp>
       <p:graphicFrame>
         <p:nvGraphicFramePr>
-          <p:cNvPr id="16" name="AI과제 Pool 차트" descr=""/>
+          <p:cNvPr id="11" name="연도별 활동 추이 차트" descr=""/>
           <p:cNvGraphicFramePr/>
           <p:nvPr/>
         </p:nvGraphicFramePr>
         <p:xfrm>
-          <a:off x="502920" y="2651760"/>
-          <a:ext cx="5349240" cy="1417320"/>
+          <a:off x="502920" y="2176272"/>
+          <a:ext cx="3154680" cy="1600200"/>
         </p:xfrm>
         <a:graphic xmlns:a="http://schemas.openxmlformats.org/drawingml/2006/main">
           <a:graphicData uri="http://schemas.openxmlformats.org/drawingml/2006/chart">
@@ -1892,14 +2227,316 @@
       </p:graphicFrame>
       <p:sp>
         <p:nvSpPr>
-          <p:cNvPr id="17" name="시사점 box"/>
+          <p:cNvPr id="12" name="Text 9"/>
+          <p:cNvSpPr txBox="1"/>
+          <p:nvPr/>
+        </p:nvSpPr>
+        <p:spPr>
+          <a:xfrm>
+            <a:off x="3794760" y="1956816"/>
+            <a:ext cx="2057400" cy="228600"/>
+          </a:xfrm>
+          <a:prstGeom prst="rect">
+            <a:avLst/>
+          </a:prstGeom>
+          <a:noFill/>
+          <a:ln/>
+        </p:spPr>
+        <p:txBody>
+          <a:bodyPr wrap="square" lIns="0" tIns="0" rIns="0" bIns="0" rtlCol="0" anchor="ctr"/>
+          <a:lstStyle/>
+          <a:p>
+            <a:pPr algn="ctr" indent="0" marL="0">
+              <a:buNone/>
+            </a:pPr>
+            <a:r>
+              <a:rPr lang="en-US" sz="1000" dirty="0">
+                <a:solidFill>
+                  <a:schemeClr val="accent5"/>
+                </a:solidFill>
+              </a:rPr>
+              <a:t>성과 전환 (AI컨설팅 기준)</a:t>
+            </a:r>
+            <a:endParaRPr lang="en-US" sz="1000" dirty="0"/>
+          </a:p>
+        </p:txBody>
+      </p:sp>
+      <p:sp>
+        <p:nvSpPr>
+          <p:cNvPr id="13" name="깔때기 AI컨설팅 수행"/>
           <p:cNvSpPr/>
           <p:nvPr/>
         </p:nvSpPr>
         <p:spPr>
           <a:xfrm>
-            <a:off x="502920" y="4224528"/>
-            <a:ext cx="5349240" cy="804672"/>
+            <a:off x="3794760" y="2240280"/>
+            <a:ext cx="2057400" cy="365760"/>
+          </a:xfrm>
+          <a:prstGeom prst="rect">
+            <a:avLst/>
+          </a:prstGeom>
+          <a:solidFill>
+            <a:schemeClr val="tx2"/>
+          </a:solidFill>
+          <a:ln/>
+        </p:spPr>
+        <p:txBody>
+          <a:bodyPr wrap="square" lIns="0" tIns="0" rIns="0" bIns="0" rtlCol="0" anchor="ctr"/>
+          <a:lstStyle/>
+          <a:p>
+            <a:pPr algn="ctr" indent="0" marL="0">
+              <a:buNone/>
+            </a:pPr>
+            <a:r>
+              <a:rPr lang="en-US" sz="950" dirty="0">
+                <a:solidFill>
+                  <a:schemeClr val="bg1"/>
+                </a:solidFill>
+              </a:rPr>
+              <a:t>AI컨설팅 수행</a:t>
+            </a:r>
+            <a:endParaRPr lang="en-US" sz="950" dirty="0"/>
+          </a:p>
+          <a:p>
+            <a:pPr algn="ctr" indent="0" marL="0">
+              <a:buNone/>
+            </a:pPr>
+            <a:r>
+              <a:rPr lang="en-US" sz="1200" b="1" dirty="0">
+                <a:solidFill>
+                  <a:schemeClr val="bg1"/>
+                </a:solidFill>
+              </a:rPr>
+              <a:t>21건</a:t>
+            </a:r>
+            <a:endParaRPr lang="en-US" sz="950" dirty="0"/>
+          </a:p>
+        </p:txBody>
+      </p:sp>
+      <p:sp>
+        <p:nvSpPr>
+          <p:cNvPr id="14" name="깔때기 후속 사업 연계"/>
+          <p:cNvSpPr/>
+          <p:nvPr/>
+        </p:nvSpPr>
+        <p:spPr>
+          <a:xfrm>
+            <a:off x="4000500" y="2752344"/>
+            <a:ext cx="1645920" cy="365760"/>
+          </a:xfrm>
+          <a:prstGeom prst="rect">
+            <a:avLst/>
+          </a:prstGeom>
+          <a:solidFill>
+            <a:schemeClr val="accent1"/>
+          </a:solidFill>
+          <a:ln/>
+        </p:spPr>
+        <p:txBody>
+          <a:bodyPr wrap="square" lIns="0" tIns="0" rIns="0" bIns="0" rtlCol="0" anchor="ctr"/>
+          <a:lstStyle/>
+          <a:p>
+            <a:pPr algn="ctr" indent="0" marL="0">
+              <a:buNone/>
+            </a:pPr>
+            <a:r>
+              <a:rPr lang="en-US" sz="950" dirty="0">
+                <a:solidFill>
+                  <a:schemeClr val="bg1"/>
+                </a:solidFill>
+              </a:rPr>
+              <a:t>후속 사업 연계</a:t>
+            </a:r>
+            <a:endParaRPr lang="en-US" sz="950" dirty="0"/>
+          </a:p>
+          <a:p>
+            <a:pPr algn="ctr" indent="0" marL="0">
+              <a:buNone/>
+            </a:pPr>
+            <a:r>
+              <a:rPr lang="en-US" sz="1200" b="1" dirty="0">
+                <a:solidFill>
+                  <a:schemeClr val="bg1"/>
+                </a:solidFill>
+              </a:rPr>
+              <a:t>6건 (29%)</a:t>
+            </a:r>
+            <a:endParaRPr lang="en-US" sz="950" dirty="0"/>
+          </a:p>
+        </p:txBody>
+      </p:sp>
+      <p:sp>
+        <p:nvSpPr>
+          <p:cNvPr id="15" name="Text 12"/>
+          <p:cNvSpPr txBox="1"/>
+          <p:nvPr/>
+        </p:nvSpPr>
+        <p:spPr>
+          <a:xfrm>
+            <a:off x="3794760" y="3118104"/>
+            <a:ext cx="2057400" cy="146304"/>
+          </a:xfrm>
+          <a:prstGeom prst="rect">
+            <a:avLst/>
+          </a:prstGeom>
+          <a:noFill/>
+          <a:ln/>
+        </p:spPr>
+        <p:txBody>
+          <a:bodyPr wrap="square" lIns="0" tIns="0" rIns="0" bIns="0" rtlCol="0" anchor="ctr"/>
+          <a:lstStyle/>
+          <a:p>
+            <a:pPr algn="ctr" indent="0" marL="0">
+              <a:buNone/>
+            </a:pPr>
+            <a:r>
+              <a:rPr lang="en-US" sz="750" dirty="0">
+                <a:solidFill>
+                  <a:schemeClr val="accent5"/>
+                </a:solidFill>
+              </a:rPr>
+              <a:t>호텔·백화점·신분당선·KT&amp;G·공항철도·물산</a:t>
+            </a:r>
+            <a:endParaRPr lang="en-US" sz="750" dirty="0"/>
+          </a:p>
+        </p:txBody>
+      </p:sp>
+      <p:sp>
+        <p:nvSpPr>
+          <p:cNvPr id="16" name="깔때기 적용·수주 완료"/>
+          <p:cNvSpPr/>
+          <p:nvPr/>
+        </p:nvSpPr>
+        <p:spPr>
+          <a:xfrm>
+            <a:off x="4206240" y="3264408"/>
+            <a:ext cx="1234440" cy="365760"/>
+          </a:xfrm>
+          <a:prstGeom prst="rect">
+            <a:avLst/>
+          </a:prstGeom>
+          <a:solidFill>
+            <a:schemeClr val="accent2"/>
+          </a:solidFill>
+          <a:ln/>
+        </p:spPr>
+        <p:txBody>
+          <a:bodyPr wrap="square" lIns="0" tIns="0" rIns="0" bIns="0" rtlCol="0" anchor="ctr"/>
+          <a:lstStyle/>
+          <a:p>
+            <a:pPr algn="ctr" indent="0" marL="0">
+              <a:buNone/>
+            </a:pPr>
+            <a:r>
+              <a:rPr lang="en-US" sz="950" dirty="0">
+                <a:solidFill>
+                  <a:schemeClr val="bg1"/>
+                </a:solidFill>
+              </a:rPr>
+              <a:t>적용·수주 완료</a:t>
+            </a:r>
+            <a:endParaRPr lang="en-US" sz="950" dirty="0"/>
+          </a:p>
+          <a:p>
+            <a:pPr algn="ctr" indent="0" marL="0">
+              <a:buNone/>
+            </a:pPr>
+            <a:r>
+              <a:rPr lang="en-US" sz="1200" b="1" dirty="0">
+                <a:solidFill>
+                  <a:schemeClr val="bg1"/>
+                </a:solidFill>
+              </a:rPr>
+              <a:t>2건 (10%)</a:t>
+            </a:r>
+            <a:endParaRPr lang="en-US" sz="950" dirty="0"/>
+          </a:p>
+        </p:txBody>
+      </p:sp>
+      <p:sp>
+        <p:nvSpPr>
+          <p:cNvPr id="17" name="Text 14"/>
+          <p:cNvSpPr txBox="1"/>
+          <p:nvPr/>
+        </p:nvSpPr>
+        <p:spPr>
+          <a:xfrm>
+            <a:off x="3794760" y="3630168"/>
+            <a:ext cx="2057400" cy="146304"/>
+          </a:xfrm>
+          <a:prstGeom prst="rect">
+            <a:avLst/>
+          </a:prstGeom>
+          <a:noFill/>
+          <a:ln/>
+        </p:spPr>
+        <p:txBody>
+          <a:bodyPr wrap="square" lIns="0" tIns="0" rIns="0" bIns="0" rtlCol="0" anchor="ctr"/>
+          <a:lstStyle/>
+          <a:p>
+            <a:pPr algn="ctr" indent="0" marL="0">
+              <a:buNone/>
+            </a:pPr>
+            <a:r>
+              <a:rPr lang="en-US" sz="750" dirty="0">
+                <a:solidFill>
+                  <a:schemeClr val="accent5"/>
+                </a:solidFill>
+              </a:rPr>
+              <a:t>백화점 오픈, 신분당선 수주</a:t>
+            </a:r>
+            <a:endParaRPr lang="en-US" sz="750" dirty="0"/>
+          </a:p>
+        </p:txBody>
+      </p:sp>
+      <p:sp>
+        <p:nvSpPr>
+          <p:cNvPr id="18" name="활동 합계"/>
+          <p:cNvSpPr txBox="1"/>
+          <p:nvPr/>
+        </p:nvSpPr>
+        <p:spPr>
+          <a:xfrm>
+            <a:off x="502920" y="3822192"/>
+            <a:ext cx="5349240" cy="237744"/>
+          </a:xfrm>
+          <a:prstGeom prst="rect">
+            <a:avLst/>
+          </a:prstGeom>
+          <a:solidFill>
+            <a:schemeClr val="accent4"/>
+          </a:solidFill>
+          <a:ln/>
+        </p:spPr>
+        <p:txBody>
+          <a:bodyPr wrap="square" lIns="0" tIns="0" rIns="0" bIns="0" rtlCol="0" anchor="ctr"/>
+          <a:lstStyle/>
+          <a:p>
+            <a:pPr algn="ctr" indent="0" marL="0">
+              <a:buNone/>
+            </a:pPr>
+            <a:r>
+              <a:rPr lang="en-US" sz="1000" b="1" dirty="0">
+                <a:solidFill>
+                  <a:schemeClr val="tx2"/>
+                </a:solidFill>
+              </a:rPr>
+              <a:t>제안 10건  |  프로젝트 27건 (그룹사 22 · 대외 5)  |  AI과제 Pool 108건</a:t>
+            </a:r>
+            <a:endParaRPr lang="en-US" sz="1000" dirty="0"/>
+          </a:p>
+        </p:txBody>
+      </p:sp>
+      <p:sp>
+        <p:nvSpPr>
+          <p:cNvPr id="19" name="시사점 box"/>
+          <p:cNvSpPr/>
+          <p:nvPr/>
+        </p:nvSpPr>
+        <p:spPr>
+          <a:xfrm>
+            <a:off x="502920" y="4297680"/>
+            <a:ext cx="5349240" cy="731520"/>
           </a:xfrm>
           <a:prstGeom prst="rect">
             <a:avLst/>
@@ -1917,18 +2554,18 @@
       </p:sp>
       <p:sp>
         <p:nvSpPr>
-          <p:cNvPr id="18" name="시사점 label"/>
+          <p:cNvPr id="20" name="시사점 label"/>
           <p:cNvSpPr/>
           <p:nvPr/>
         </p:nvSpPr>
         <p:spPr>
           <a:xfrm>
-            <a:off x="594360" y="4114800"/>
-            <a:ext cx="914400" cy="256032"/>
+            <a:off x="594360" y="4178808"/>
+            <a:ext cx="914400" cy="237744"/>
           </a:xfrm>
           <a:prstGeom prst="roundRect">
             <a:avLst>
-              <a:gd name="adj" fmla="val 42857"/>
+              <a:gd name="adj" fmla="val 46154"/>
             </a:avLst>
           </a:prstGeom>
           <a:solidFill>
@@ -1957,14 +2594,14 @@
       </p:sp>
       <p:sp>
         <p:nvSpPr>
-          <p:cNvPr id="19" name="Text 16"/>
+          <p:cNvPr id="21" name="Text 18"/>
           <p:cNvSpPr txBox="1"/>
           <p:nvPr/>
         </p:nvSpPr>
         <p:spPr>
           <a:xfrm>
-            <a:off x="594360" y="4407408"/>
-            <a:ext cx="5166360" cy="585216"/>
+            <a:off x="594360" y="4443984"/>
+            <a:ext cx="5166360" cy="548640"/>
           </a:xfrm>
           <a:prstGeom prst="rect">
             <a:avLst/>
@@ -1984,14 +2621,14 @@
               <a:buChar char="•"/>
             </a:pPr>
             <a:r>
-              <a:rPr lang="en-US" sz="1100" dirty="0">
+              <a:rPr lang="en-US" sz="1050" dirty="0">
                 <a:solidFill>
                   <a:schemeClr val="tx1"/>
                 </a:solidFill>
               </a:rPr>
-              <a:t>17개 그룹사 AI컨설팅 중 실제 적용 2건 (호텔 객실요금최적화, 백화점 브랜드 AI포탈)</a:t>
-            </a:r>
-            <a:endParaRPr lang="en-US" sz="1100" dirty="0"/>
+              <a:t>25년 과제 77건 발굴 → 26년 실행·수주 전환 시작, 단 그룹사 적용 2건</a:t>
+            </a:r>
+            <a:endParaRPr lang="en-US" sz="1050" dirty="0"/>
           </a:p>
           <a:p>
             <a:pPr indent="0" marL="0">
@@ -2001,20 +2638,20 @@
               <a:buNone/>
             </a:pPr>
             <a:r>
-              <a:rPr lang="en-US" sz="1100" b="1" dirty="0">
+              <a:rPr lang="en-US" sz="1050" b="1" dirty="0">
                 <a:solidFill>
                   <a:schemeClr val="accent1"/>
                 </a:solidFill>
               </a:rPr>
               <a:t>→ 컨설팅에서 구현·성과까지 책임지는 현장형 실행 구조(FDE) 필요</a:t>
             </a:r>
-            <a:endParaRPr lang="en-US" sz="1100" dirty="0"/>
+            <a:endParaRPr lang="en-US" sz="1050" dirty="0"/>
           </a:p>
         </p:txBody>
       </p:sp>
       <p:sp>
         <p:nvSpPr>
-          <p:cNvPr id="20" name="bullet Lessons &amp; Learned"/>
+          <p:cNvPr id="22" name="bullet Lessons &amp; Learned"/>
           <p:cNvSpPr/>
           <p:nvPr/>
         </p:nvSpPr>
@@ -2039,7 +2676,7 @@
       </p:sp>
       <p:sp>
         <p:nvSpPr>
-          <p:cNvPr id="21" name="Text 18"/>
+          <p:cNvPr id="23" name="Text 20"/>
           <p:cNvSpPr txBox="1"/>
           <p:nvPr/>
         </p:nvSpPr>
@@ -2075,7 +2712,7 @@
       </p:sp>
       <p:sp>
         <p:nvSpPr>
-          <p:cNvPr id="22" name="LL label 1"/>
+          <p:cNvPr id="24" name="LL label 1"/>
           <p:cNvSpPr txBox="1"/>
           <p:nvPr/>
         </p:nvSpPr>
@@ -2113,7 +2750,7 @@
       </p:sp>
       <p:sp>
         <p:nvSpPr>
-          <p:cNvPr id="23" name="Text 20"/>
+          <p:cNvPr id="25" name="Text 22"/>
           <p:cNvSpPr txBox="1"/>
           <p:nvPr/>
         </p:nvSpPr>
@@ -2162,7 +2799,7 @@
       </p:sp>
       <p:sp>
         <p:nvSpPr>
-          <p:cNvPr id="24" name="LL label 2"/>
+          <p:cNvPr id="26" name="LL label 2"/>
           <p:cNvSpPr txBox="1"/>
           <p:nvPr/>
         </p:nvSpPr>
@@ -2200,7 +2837,7 @@
       </p:sp>
       <p:sp>
         <p:nvSpPr>
-          <p:cNvPr id="25" name="Text 22"/>
+          <p:cNvPr id="27" name="Text 24"/>
           <p:cNvSpPr txBox="1"/>
           <p:nvPr/>
         </p:nvSpPr>
@@ -2249,7 +2886,7 @@
       </p:sp>
       <p:sp>
         <p:nvSpPr>
-          <p:cNvPr id="26" name="LL label 3"/>
+          <p:cNvPr id="28" name="LL label 3"/>
           <p:cNvSpPr txBox="1"/>
           <p:nvPr/>
         </p:nvSpPr>
@@ -2287,7 +2924,7 @@
       </p:sp>
       <p:sp>
         <p:nvSpPr>
-          <p:cNvPr id="27" name="Text 24"/>
+          <p:cNvPr id="29" name="Text 26"/>
           <p:cNvSpPr txBox="1"/>
           <p:nvPr/>
         </p:nvSpPr>
@@ -2336,7 +2973,7 @@
       </p:sp>
       <p:sp>
         <p:nvSpPr>
-          <p:cNvPr id="28" name="LL label 4"/>
+          <p:cNvPr id="30" name="LL label 4"/>
           <p:cNvSpPr txBox="1"/>
           <p:nvPr/>
         </p:nvSpPr>
@@ -2374,7 +3011,7 @@
       </p:sp>
       <p:sp>
         <p:nvSpPr>
-          <p:cNvPr id="29" name="Text 26"/>
+          <p:cNvPr id="31" name="Text 28"/>
           <p:cNvSpPr txBox="1"/>
           <p:nvPr/>
         </p:nvSpPr>
@@ -2423,7 +3060,7 @@
       </p:sp>
       <p:sp>
         <p:nvSpPr>
-          <p:cNvPr id="30" name="bullet 27년 수주 인벤토리 및 연계 기회"/>
+          <p:cNvPr id="32" name="bullet AI 사업 연계 성과 및 27년 인벤토리"/>
           <p:cNvSpPr/>
           <p:nvPr/>
         </p:nvSpPr>
@@ -2448,7 +3085,7 @@
       </p:sp>
       <p:sp>
         <p:nvSpPr>
-          <p:cNvPr id="31" name="Text 28"/>
+          <p:cNvPr id="33" name="Text 30"/>
           <p:cNvSpPr txBox="1"/>
           <p:nvPr/>
         </p:nvSpPr>
@@ -2476,7 +3113,7 @@
                   <a:schemeClr val="tx1"/>
                 </a:solidFill>
               </a:rPr>
-              <a:t>27년 수주 인벤토리 및 연계 기회</a:t>
+              <a:t>AI 사업 연계 성과 및 27년 인벤토리</a:t>
             </a:r>
             <a:endParaRPr lang="en-US" sz="1400" dirty="0"/>
           </a:p>
@@ -2484,7 +3121,7 @@
       </p:sp>
       <p:sp>
         <p:nvSpPr>
-          <p:cNvPr id="32" name="Text 29"/>
+          <p:cNvPr id="34" name="Text 31"/>
           <p:cNvSpPr txBox="1"/>
           <p:nvPr/>
         </p:nvSpPr>
@@ -2520,1430 +3157,30 @@
       </p:sp>
       <p:graphicFrame>
         <p:nvGraphicFramePr>
-          <p:cNvPr id="2" name="수주 인벤토리 표"/>
-          <p:cNvGraphicFramePr>
-            <a:graphicFrameLocks noGrp="1"/>
-          </p:cNvGraphicFramePr>
-          <p:nvPr>
-            <p:extLst>
-              <p:ext uri="{D42A27DB-BD31-4B8C-83A1-F6EECF244321}">
-                <p14:modId xmlns:p14="http://schemas.microsoft.com/office/powerpoint/2010/main" val="1579011935"/>
-              </p:ext>
-            </p:extLst>
-          </p:nvPr>
+          <p:cNvPr id="35" name="AI 사업 연계 금액 차트" descr=""/>
+          <p:cNvGraphicFramePr/>
+          <p:nvPr/>
         </p:nvGraphicFramePr>
         <p:xfrm>
-          <a:off x="6336792" y="2011680"/>
-          <a:ext cx="5349240" cy="914400"/>
+          <a:off x="6336792" y="1938528"/>
+          <a:ext cx="5349240" cy="1325880"/>
         </p:xfrm>
-        <a:graphic>
-          <a:graphicData uri="http://schemas.openxmlformats.org/drawingml/2006/table">
-            <a:tbl>
-              <a:tblPr/>
-              <a:tblGrid>
-                <a:gridCol w="868680"/>
-                <a:gridCol w="2514600"/>
-                <a:gridCol w="1325880"/>
-                <a:gridCol w="640080"/>
-              </a:tblGrid>
-              <a:tr h="274320">
-                <a:tc>
-                  <a:txBody>
-                    <a:bodyPr/>
-                    <a:lstStyle/>
-                    <a:p>
-                      <a:pPr algn="ctr" indent="0" marL="0">
-                        <a:buNone/>
-                      </a:pPr>
-                      <a:r>
-                        <a:rPr lang="en-US" sz="1050" b="1" dirty="0">
-                          <a:solidFill>
-                            <a:srgbClr val="1F2329"/>
-                          </a:solidFill>
-                          <a:latin typeface="맑은 고딕" pitchFamily="34" charset="0"/>
-                          <a:ea typeface="맑은 고딕" pitchFamily="34" charset="-122"/>
-                          <a:cs typeface="맑은 고딕" pitchFamily="34" charset="-120"/>
-                        </a:rPr>
-                        <a:t>구 분</a:t>
-                      </a:r>
-                      <a:endParaRPr lang="en-US" sz="1050" dirty="0">
-                        <a:latin typeface="맑은 고딕" charset="0"/>
-                        <a:ea typeface="맑은 고딕" charset="0"/>
-                        <a:cs typeface="맑은 고딕" charset="0"/>
-                      </a:endParaRPr>
-                    </a:p>
-                  </a:txBody>
-                  <a:tcPr marL="54864" marR="54864" marT="18288" marB="18288" anchor="ctr">
-                    <a:lnL w="9525" cap="flat" cmpd="sng" algn="ctr">
-                      <a:solidFill>
-                        <a:srgbClr val="BFC5CF"/>
-                      </a:solidFill>
-                      <a:prstDash val="solid"/>
-                      <a:round/>
-                      <a:headEnd type="none" w="med" len="med"/>
-                      <a:tailEnd type="none" w="med" len="med"/>
-                    </a:lnL>
-                    <a:lnR w="9525" cap="flat" cmpd="sng" algn="ctr">
-                      <a:solidFill>
-                        <a:srgbClr val="BFC5CF"/>
-                      </a:solidFill>
-                      <a:prstDash val="solid"/>
-                      <a:round/>
-                      <a:headEnd type="none" w="med" len="med"/>
-                      <a:tailEnd type="none" w="med" len="med"/>
-                    </a:lnR>
-                    <a:lnT w="9525" cap="flat" cmpd="sng" algn="ctr">
-                      <a:solidFill>
-                        <a:srgbClr val="BFC5CF"/>
-                      </a:solidFill>
-                      <a:prstDash val="solid"/>
-                      <a:round/>
-                      <a:headEnd type="none" w="med" len="med"/>
-                      <a:tailEnd type="none" w="med" len="med"/>
-                    </a:lnT>
-                    <a:lnB w="9525" cap="flat" cmpd="sng" algn="ctr">
-                      <a:solidFill>
-                        <a:srgbClr val="BFC5CF"/>
-                      </a:solidFill>
-                      <a:prstDash val="solid"/>
-                      <a:round/>
-                      <a:headEnd type="none" w="med" len="med"/>
-                      <a:tailEnd type="none" w="med" len="med"/>
-                    </a:lnB>
-                    <a:solidFill>
-                      <a:srgbClr val="F2F4F7"/>
-                    </a:solidFill>
-                  </a:tcPr>
-                </a:tc>
-                <a:tc>
-                  <a:txBody>
-                    <a:bodyPr/>
-                    <a:lstStyle/>
-                    <a:p>
-                      <a:pPr algn="ctr" indent="0" marL="0">
-                        <a:buNone/>
-                      </a:pPr>
-                      <a:r>
-                        <a:rPr lang="en-US" sz="1050" b="1" dirty="0">
-                          <a:solidFill>
-                            <a:srgbClr val="1F2329"/>
-                          </a:solidFill>
-                          <a:latin typeface="맑은 고딕" pitchFamily="34" charset="0"/>
-                          <a:ea typeface="맑은 고딕" pitchFamily="34" charset="-122"/>
-                          <a:cs typeface="맑은 고딕" pitchFamily="34" charset="-120"/>
-                        </a:rPr>
-                        <a:t>고객사 / 프로젝트</a:t>
-                      </a:r>
-                      <a:endParaRPr lang="en-US" sz="1050" dirty="0">
-                        <a:latin typeface="맑은 고딕" charset="0"/>
-                        <a:ea typeface="맑은 고딕" charset="0"/>
-                        <a:cs typeface="맑은 고딕" charset="0"/>
-                      </a:endParaRPr>
-                    </a:p>
-                  </a:txBody>
-                  <a:tcPr marL="54864" marR="54864" marT="18288" marB="18288" anchor="ctr">
-                    <a:lnL w="9525" cap="flat" cmpd="sng" algn="ctr">
-                      <a:solidFill>
-                        <a:srgbClr val="BFC5CF"/>
-                      </a:solidFill>
-                      <a:prstDash val="solid"/>
-                      <a:round/>
-                      <a:headEnd type="none" w="med" len="med"/>
-                      <a:tailEnd type="none" w="med" len="med"/>
-                    </a:lnL>
-                    <a:lnR w="9525" cap="flat" cmpd="sng" algn="ctr">
-                      <a:solidFill>
-                        <a:srgbClr val="BFC5CF"/>
-                      </a:solidFill>
-                      <a:prstDash val="solid"/>
-                      <a:round/>
-                      <a:headEnd type="none" w="med" len="med"/>
-                      <a:tailEnd type="none" w="med" len="med"/>
-                    </a:lnR>
-                    <a:lnT w="9525" cap="flat" cmpd="sng" algn="ctr">
-                      <a:solidFill>
-                        <a:srgbClr val="BFC5CF"/>
-                      </a:solidFill>
-                      <a:prstDash val="solid"/>
-                      <a:round/>
-                      <a:headEnd type="none" w="med" len="med"/>
-                      <a:tailEnd type="none" w="med" len="med"/>
-                    </a:lnT>
-                    <a:lnB w="9525" cap="flat" cmpd="sng" algn="ctr">
-                      <a:solidFill>
-                        <a:srgbClr val="BFC5CF"/>
-                      </a:solidFill>
-                      <a:prstDash val="solid"/>
-                      <a:round/>
-                      <a:headEnd type="none" w="med" len="med"/>
-                      <a:tailEnd type="none" w="med" len="med"/>
-                    </a:lnB>
-                    <a:solidFill>
-                      <a:srgbClr val="F2F4F7"/>
-                    </a:solidFill>
-                  </a:tcPr>
-                </a:tc>
-                <a:tc>
-                  <a:txBody>
-                    <a:bodyPr/>
-                    <a:lstStyle/>
-                    <a:p>
-                      <a:pPr algn="ctr" indent="0" marL="0">
-                        <a:buNone/>
-                      </a:pPr>
-                      <a:r>
-                        <a:rPr lang="en-US" sz="1050" b="1" dirty="0">
-                          <a:solidFill>
-                            <a:srgbClr val="1F2329"/>
-                          </a:solidFill>
-                          <a:latin typeface="맑은 고딕" pitchFamily="34" charset="0"/>
-                          <a:ea typeface="맑은 고딕" pitchFamily="34" charset="-122"/>
-                          <a:cs typeface="맑은 고딕" pitchFamily="34" charset="-120"/>
-                        </a:rPr>
-                        <a:t>비 고</a:t>
-                      </a:r>
-                      <a:endParaRPr lang="en-US" sz="1050" dirty="0">
-                        <a:latin typeface="맑은 고딕" charset="0"/>
-                        <a:ea typeface="맑은 고딕" charset="0"/>
-                        <a:cs typeface="맑은 고딕" charset="0"/>
-                      </a:endParaRPr>
-                    </a:p>
-                  </a:txBody>
-                  <a:tcPr marL="54864" marR="54864" marT="18288" marB="18288" anchor="ctr">
-                    <a:lnL w="9525" cap="flat" cmpd="sng" algn="ctr">
-                      <a:solidFill>
-                        <a:srgbClr val="BFC5CF"/>
-                      </a:solidFill>
-                      <a:prstDash val="solid"/>
-                      <a:round/>
-                      <a:headEnd type="none" w="med" len="med"/>
-                      <a:tailEnd type="none" w="med" len="med"/>
-                    </a:lnL>
-                    <a:lnR w="9525" cap="flat" cmpd="sng" algn="ctr">
-                      <a:solidFill>
-                        <a:srgbClr val="BFC5CF"/>
-                      </a:solidFill>
-                      <a:prstDash val="solid"/>
-                      <a:round/>
-                      <a:headEnd type="none" w="med" len="med"/>
-                      <a:tailEnd type="none" w="med" len="med"/>
-                    </a:lnR>
-                    <a:lnT w="9525" cap="flat" cmpd="sng" algn="ctr">
-                      <a:solidFill>
-                        <a:srgbClr val="BFC5CF"/>
-                      </a:solidFill>
-                      <a:prstDash val="solid"/>
-                      <a:round/>
-                      <a:headEnd type="none" w="med" len="med"/>
-                      <a:tailEnd type="none" w="med" len="med"/>
-                    </a:lnT>
-                    <a:lnB w="9525" cap="flat" cmpd="sng" algn="ctr">
-                      <a:solidFill>
-                        <a:srgbClr val="BFC5CF"/>
-                      </a:solidFill>
-                      <a:prstDash val="solid"/>
-                      <a:round/>
-                      <a:headEnd type="none" w="med" len="med"/>
-                      <a:tailEnd type="none" w="med" len="med"/>
-                    </a:lnB>
-                    <a:solidFill>
-                      <a:srgbClr val="F2F4F7"/>
-                    </a:solidFill>
-                  </a:tcPr>
-                </a:tc>
-                <a:tc>
-                  <a:txBody>
-                    <a:bodyPr/>
-                    <a:lstStyle/>
-                    <a:p>
-                      <a:pPr algn="ctr" indent="0" marL="0">
-                        <a:buNone/>
-                      </a:pPr>
-                      <a:r>
-                        <a:rPr lang="en-US" sz="1050" b="1" dirty="0">
-                          <a:solidFill>
-                            <a:srgbClr val="1F2329"/>
-                          </a:solidFill>
-                          <a:latin typeface="맑은 고딕" pitchFamily="34" charset="0"/>
-                          <a:ea typeface="맑은 고딕" pitchFamily="34" charset="-122"/>
-                          <a:cs typeface="맑은 고딕" pitchFamily="34" charset="-120"/>
-                        </a:rPr>
-                        <a:t>규모</a:t>
-                      </a:r>
-                      <a:endParaRPr lang="en-US" sz="1050" dirty="0">
-                        <a:latin typeface="맑은 고딕" charset="0"/>
-                        <a:ea typeface="맑은 고딕" charset="0"/>
-                        <a:cs typeface="맑은 고딕" charset="0"/>
-                      </a:endParaRPr>
-                    </a:p>
-                  </a:txBody>
-                  <a:tcPr marL="54864" marR="54864" marT="18288" marB="18288" anchor="ctr">
-                    <a:lnL w="9525" cap="flat" cmpd="sng" algn="ctr">
-                      <a:solidFill>
-                        <a:srgbClr val="BFC5CF"/>
-                      </a:solidFill>
-                      <a:prstDash val="solid"/>
-                      <a:round/>
-                      <a:headEnd type="none" w="med" len="med"/>
-                      <a:tailEnd type="none" w="med" len="med"/>
-                    </a:lnL>
-                    <a:lnR w="9525" cap="flat" cmpd="sng" algn="ctr">
-                      <a:solidFill>
-                        <a:srgbClr val="BFC5CF"/>
-                      </a:solidFill>
-                      <a:prstDash val="solid"/>
-                      <a:round/>
-                      <a:headEnd type="none" w="med" len="med"/>
-                      <a:tailEnd type="none" w="med" len="med"/>
-                    </a:lnR>
-                    <a:lnT w="9525" cap="flat" cmpd="sng" algn="ctr">
-                      <a:solidFill>
-                        <a:srgbClr val="BFC5CF"/>
-                      </a:solidFill>
-                      <a:prstDash val="solid"/>
-                      <a:round/>
-                      <a:headEnd type="none" w="med" len="med"/>
-                      <a:tailEnd type="none" w="med" len="med"/>
-                    </a:lnT>
-                    <a:lnB w="9525" cap="flat" cmpd="sng" algn="ctr">
-                      <a:solidFill>
-                        <a:srgbClr val="BFC5CF"/>
-                      </a:solidFill>
-                      <a:prstDash val="solid"/>
-                      <a:round/>
-                      <a:headEnd type="none" w="med" len="med"/>
-                      <a:tailEnd type="none" w="med" len="med"/>
-                    </a:lnB>
-                    <a:solidFill>
-                      <a:srgbClr val="F2F4F7"/>
-                    </a:solidFill>
-                  </a:tcPr>
-                </a:tc>
-              </a:tr>
-              <a:tr h="274320">
-                <a:tc rowSpan="2">
-                  <a:txBody>
-                    <a:bodyPr/>
-                    <a:lstStyle/>
-                    <a:p>
-                      <a:pPr algn="ctr" indent="0" marL="0">
-                        <a:buNone/>
-                      </a:pPr>
-                      <a:r>
-                        <a:rPr lang="en-US" sz="1050" b="1" dirty="0">
-                          <a:solidFill>
-                            <a:srgbClr val="1F2329"/>
-                          </a:solidFill>
-                          <a:latin typeface="맑은 고딕" pitchFamily="34" charset="0"/>
-                          <a:ea typeface="맑은 고딕" pitchFamily="34" charset="-122"/>
-                          <a:cs typeface="맑은 고딕" pitchFamily="34" charset="-120"/>
-                        </a:rPr>
-                        <a:t>인벤토리</a:t>
-                      </a:r>
-                      <a:endParaRPr lang="en-US" sz="1050" dirty="0">
-                        <a:latin typeface="맑은 고딕" charset="0"/>
-                        <a:ea typeface="맑은 고딕" charset="0"/>
-                        <a:cs typeface="맑은 고딕" charset="0"/>
-                      </a:endParaRPr>
-                    </a:p>
-                    <a:p>
-                      <a:pPr algn="ctr" indent="0" marL="0">
-                        <a:buNone/>
-                      </a:pPr>
-                      <a:r>
-                        <a:rPr lang="en-US" sz="1050" b="1" dirty="0">
-                          <a:solidFill>
-                            <a:srgbClr val="1F2329"/>
-                          </a:solidFill>
-                          <a:latin typeface="맑은 고딕" pitchFamily="34" charset="0"/>
-                          <a:ea typeface="맑은 고딕" pitchFamily="34" charset="-122"/>
-                          <a:cs typeface="맑은 고딕" pitchFamily="34" charset="-120"/>
-                        </a:rPr>
-                        <a:t>확보</a:t>
-                      </a:r>
-                      <a:endParaRPr lang="en-US" sz="1050" dirty="0">
-                        <a:latin typeface="맑은 고딕" charset="0"/>
-                        <a:ea typeface="맑은 고딕" charset="0"/>
-                        <a:cs typeface="맑은 고딕" charset="0"/>
-                      </a:endParaRPr>
-                    </a:p>
-                  </a:txBody>
-                  <a:tcPr marL="54864" marR="54864" marT="18288" marB="18288" anchor="ctr">
-                    <a:lnL w="9525" cap="flat" cmpd="sng" algn="ctr">
-                      <a:solidFill>
-                        <a:srgbClr val="BFC5CF"/>
-                      </a:solidFill>
-                      <a:prstDash val="solid"/>
-                      <a:round/>
-                      <a:headEnd type="none" w="med" len="med"/>
-                      <a:tailEnd type="none" w="med" len="med"/>
-                    </a:lnL>
-                    <a:lnR w="9525" cap="flat" cmpd="sng" algn="ctr">
-                      <a:solidFill>
-                        <a:srgbClr val="BFC5CF"/>
-                      </a:solidFill>
-                      <a:prstDash val="solid"/>
-                      <a:round/>
-                      <a:headEnd type="none" w="med" len="med"/>
-                      <a:tailEnd type="none" w="med" len="med"/>
-                    </a:lnR>
-                    <a:lnT w="9525" cap="flat" cmpd="sng" algn="ctr">
-                      <a:solidFill>
-                        <a:srgbClr val="BFC5CF"/>
-                      </a:solidFill>
-                      <a:prstDash val="solid"/>
-                      <a:round/>
-                      <a:headEnd type="none" w="med" len="med"/>
-                      <a:tailEnd type="none" w="med" len="med"/>
-                    </a:lnT>
-                    <a:lnB w="9525" cap="flat" cmpd="sng" algn="ctr">
-                      <a:solidFill>
-                        <a:srgbClr val="BFC5CF"/>
-                      </a:solidFill>
-                      <a:prstDash val="solid"/>
-                      <a:round/>
-                      <a:headEnd type="none" w="med" len="med"/>
-                      <a:tailEnd type="none" w="med" len="med"/>
-                    </a:lnB>
-                  </a:tcPr>
-                </a:tc>
-                <a:tc>
-                  <a:txBody>
-                    <a:bodyPr/>
-                    <a:lstStyle/>
-                    <a:p>
-                      <a:pPr indent="0" marL="0">
-                        <a:buNone/>
-                      </a:pPr>
-                      <a:r>
-                        <a:rPr lang="en-US" sz="1050" dirty="0">
-                          <a:solidFill>
-                            <a:srgbClr val="1F2329"/>
-                          </a:solidFill>
-                          <a:latin typeface="맑은 고딕" pitchFamily="34" charset="0"/>
-                          <a:ea typeface="맑은 고딕" pitchFamily="34" charset="-122"/>
-                          <a:cs typeface="맑은 고딕" pitchFamily="34" charset="-120"/>
-                        </a:rPr>
-                        <a:t>[공항철도] AX과제이행 프로젝트</a:t>
-                      </a:r>
-                      <a:endParaRPr lang="en-US" sz="1050" dirty="0">
-                        <a:latin typeface="맑은 고딕" charset="0"/>
-                        <a:ea typeface="맑은 고딕" charset="0"/>
-                        <a:cs typeface="맑은 고딕" charset="0"/>
-                      </a:endParaRPr>
-                    </a:p>
-                  </a:txBody>
-                  <a:tcPr marL="54864" marR="54864" marT="18288" marB="18288" anchor="ctr">
-                    <a:lnL w="9525" cap="flat" cmpd="sng" algn="ctr">
-                      <a:solidFill>
-                        <a:srgbClr val="BFC5CF"/>
-                      </a:solidFill>
-                      <a:prstDash val="solid"/>
-                      <a:round/>
-                      <a:headEnd type="none" w="med" len="med"/>
-                      <a:tailEnd type="none" w="med" len="med"/>
-                    </a:lnL>
-                    <a:lnR w="9525" cap="flat" cmpd="sng" algn="ctr">
-                      <a:solidFill>
-                        <a:srgbClr val="BFC5CF"/>
-                      </a:solidFill>
-                      <a:prstDash val="solid"/>
-                      <a:round/>
-                      <a:headEnd type="none" w="med" len="med"/>
-                      <a:tailEnd type="none" w="med" len="med"/>
-                    </a:lnR>
-                    <a:lnT w="9525" cap="flat" cmpd="sng" algn="ctr">
-                      <a:solidFill>
-                        <a:srgbClr val="BFC5CF"/>
-                      </a:solidFill>
-                      <a:prstDash val="solid"/>
-                      <a:round/>
-                      <a:headEnd type="none" w="med" len="med"/>
-                      <a:tailEnd type="none" w="med" len="med"/>
-                    </a:lnT>
-                    <a:lnB w="9525" cap="flat" cmpd="sng" algn="ctr">
-                      <a:solidFill>
-                        <a:srgbClr val="BFC5CF"/>
-                      </a:solidFill>
-                      <a:prstDash val="solid"/>
-                      <a:round/>
-                      <a:headEnd type="none" w="med" len="med"/>
-                      <a:tailEnd type="none" w="med" len="med"/>
-                    </a:lnB>
-                  </a:tcPr>
-                </a:tc>
-                <a:tc>
-                  <a:txBody>
-                    <a:bodyPr/>
-                    <a:lstStyle/>
-                    <a:p>
-                      <a:pPr algn="ctr" indent="0" marL="0">
-                        <a:buNone/>
-                      </a:pPr>
-                      <a:r>
-                        <a:rPr lang="en-US" sz="1050" dirty="0">
-                          <a:solidFill>
-                            <a:srgbClr val="1F2329"/>
-                          </a:solidFill>
-                          <a:latin typeface="맑은 고딕" pitchFamily="34" charset="0"/>
-                          <a:ea typeface="맑은 고딕" pitchFamily="34" charset="-122"/>
-                          <a:cs typeface="맑은 고딕" pitchFamily="34" charset="-120"/>
-                        </a:rPr>
-                        <a:t>27년 수주 예정</a:t>
-                      </a:r>
-                      <a:endParaRPr lang="en-US" sz="1050" dirty="0">
-                        <a:latin typeface="맑은 고딕" charset="0"/>
-                        <a:ea typeface="맑은 고딕" charset="0"/>
-                        <a:cs typeface="맑은 고딕" charset="0"/>
-                      </a:endParaRPr>
-                    </a:p>
-                  </a:txBody>
-                  <a:tcPr marL="54864" marR="54864" marT="18288" marB="18288" anchor="ctr">
-                    <a:lnL w="9525" cap="flat" cmpd="sng" algn="ctr">
-                      <a:solidFill>
-                        <a:srgbClr val="BFC5CF"/>
-                      </a:solidFill>
-                      <a:prstDash val="solid"/>
-                      <a:round/>
-                      <a:headEnd type="none" w="med" len="med"/>
-                      <a:tailEnd type="none" w="med" len="med"/>
-                    </a:lnL>
-                    <a:lnR w="9525" cap="flat" cmpd="sng" algn="ctr">
-                      <a:solidFill>
-                        <a:srgbClr val="BFC5CF"/>
-                      </a:solidFill>
-                      <a:prstDash val="solid"/>
-                      <a:round/>
-                      <a:headEnd type="none" w="med" len="med"/>
-                      <a:tailEnd type="none" w="med" len="med"/>
-                    </a:lnR>
-                    <a:lnT w="9525" cap="flat" cmpd="sng" algn="ctr">
-                      <a:solidFill>
-                        <a:srgbClr val="BFC5CF"/>
-                      </a:solidFill>
-                      <a:prstDash val="solid"/>
-                      <a:round/>
-                      <a:headEnd type="none" w="med" len="med"/>
-                      <a:tailEnd type="none" w="med" len="med"/>
-                    </a:lnT>
-                    <a:lnB w="9525" cap="flat" cmpd="sng" algn="ctr">
-                      <a:solidFill>
-                        <a:srgbClr val="BFC5CF"/>
-                      </a:solidFill>
-                      <a:prstDash val="solid"/>
-                      <a:round/>
-                      <a:headEnd type="none" w="med" len="med"/>
-                      <a:tailEnd type="none" w="med" len="med"/>
-                    </a:lnB>
-                  </a:tcPr>
-                </a:tc>
-                <a:tc>
-                  <a:txBody>
-                    <a:bodyPr/>
-                    <a:lstStyle/>
-                    <a:p>
-                      <a:pPr algn="r" indent="0" marL="0">
-                        <a:buNone/>
-                      </a:pPr>
-                      <a:r>
-                        <a:rPr lang="en-US" sz="1050" dirty="0">
-                          <a:solidFill>
-                            <a:srgbClr val="1F2329"/>
-                          </a:solidFill>
-                          <a:latin typeface="맑은 고딕" pitchFamily="34" charset="0"/>
-                          <a:ea typeface="맑은 고딕" pitchFamily="34" charset="-122"/>
-                          <a:cs typeface="맑은 고딕" pitchFamily="34" charset="-120"/>
-                        </a:rPr>
-                        <a:t>5.71</a:t>
-                      </a:r>
-                      <a:endParaRPr lang="en-US" sz="1050" dirty="0">
-                        <a:latin typeface="맑은 고딕" charset="0"/>
-                        <a:ea typeface="맑은 고딕" charset="0"/>
-                        <a:cs typeface="맑은 고딕" charset="0"/>
-                      </a:endParaRPr>
-                    </a:p>
-                  </a:txBody>
-                  <a:tcPr marL="54864" marR="54864" marT="18288" marB="18288" anchor="ctr">
-                    <a:lnL w="9525" cap="flat" cmpd="sng" algn="ctr">
-                      <a:solidFill>
-                        <a:srgbClr val="BFC5CF"/>
-                      </a:solidFill>
-                      <a:prstDash val="solid"/>
-                      <a:round/>
-                      <a:headEnd type="none" w="med" len="med"/>
-                      <a:tailEnd type="none" w="med" len="med"/>
-                    </a:lnL>
-                    <a:lnR w="9525" cap="flat" cmpd="sng" algn="ctr">
-                      <a:solidFill>
-                        <a:srgbClr val="BFC5CF"/>
-                      </a:solidFill>
-                      <a:prstDash val="solid"/>
-                      <a:round/>
-                      <a:headEnd type="none" w="med" len="med"/>
-                      <a:tailEnd type="none" w="med" len="med"/>
-                    </a:lnR>
-                    <a:lnT w="9525" cap="flat" cmpd="sng" algn="ctr">
-                      <a:solidFill>
-                        <a:srgbClr val="BFC5CF"/>
-                      </a:solidFill>
-                      <a:prstDash val="solid"/>
-                      <a:round/>
-                      <a:headEnd type="none" w="med" len="med"/>
-                      <a:tailEnd type="none" w="med" len="med"/>
-                    </a:lnT>
-                    <a:lnB w="9525" cap="flat" cmpd="sng" algn="ctr">
-                      <a:solidFill>
-                        <a:srgbClr val="BFC5CF"/>
-                      </a:solidFill>
-                      <a:prstDash val="solid"/>
-                      <a:round/>
-                      <a:headEnd type="none" w="med" len="med"/>
-                      <a:tailEnd type="none" w="med" len="med"/>
-                    </a:lnB>
-                  </a:tcPr>
-                </a:tc>
-              </a:tr>
-              <a:tr h="274320">
-                <a:tc vMerge="1">
-                  <a:tcPr/>
-                </a:tc>
-                <a:tc>
-                  <a:txBody>
-                    <a:bodyPr/>
-                    <a:lstStyle/>
-                    <a:p>
-                      <a:pPr indent="0" marL="0">
-                        <a:buNone/>
-                      </a:pPr>
-                      <a:r>
-                        <a:rPr lang="en-US" sz="1050" dirty="0">
-                          <a:solidFill>
-                            <a:srgbClr val="1F2329"/>
-                          </a:solidFill>
-                          <a:latin typeface="맑은 고딕" pitchFamily="34" charset="0"/>
-                          <a:ea typeface="맑은 고딕" pitchFamily="34" charset="-122"/>
-                          <a:cs typeface="맑은 고딕" pitchFamily="34" charset="-120"/>
-                        </a:rPr>
-                        <a:t>[물산] AI 문서탐색플랫폼</a:t>
-                      </a:r>
-                      <a:endParaRPr lang="en-US" sz="1050" dirty="0">
-                        <a:latin typeface="맑은 고딕" charset="0"/>
-                        <a:ea typeface="맑은 고딕" charset="0"/>
-                        <a:cs typeface="맑은 고딕" charset="0"/>
-                      </a:endParaRPr>
-                    </a:p>
-                  </a:txBody>
-                  <a:tcPr marL="54864" marR="54864" marT="18288" marB="18288" anchor="ctr">
-                    <a:lnL w="9525" cap="flat" cmpd="sng" algn="ctr">
-                      <a:solidFill>
-                        <a:srgbClr val="BFC5CF"/>
-                      </a:solidFill>
-                      <a:prstDash val="solid"/>
-                      <a:round/>
-                      <a:headEnd type="none" w="med" len="med"/>
-                      <a:tailEnd type="none" w="med" len="med"/>
-                    </a:lnL>
-                    <a:lnR w="9525" cap="flat" cmpd="sng" algn="ctr">
-                      <a:solidFill>
-                        <a:srgbClr val="BFC5CF"/>
-                      </a:solidFill>
-                      <a:prstDash val="solid"/>
-                      <a:round/>
-                      <a:headEnd type="none" w="med" len="med"/>
-                      <a:tailEnd type="none" w="med" len="med"/>
-                    </a:lnR>
-                    <a:lnT w="9525" cap="flat" cmpd="sng" algn="ctr">
-                      <a:solidFill>
-                        <a:srgbClr val="BFC5CF"/>
-                      </a:solidFill>
-                      <a:prstDash val="solid"/>
-                      <a:round/>
-                      <a:headEnd type="none" w="med" len="med"/>
-                      <a:tailEnd type="none" w="med" len="med"/>
-                    </a:lnT>
-                    <a:lnB w="9525" cap="flat" cmpd="sng" algn="ctr">
-                      <a:solidFill>
-                        <a:srgbClr val="BFC5CF"/>
-                      </a:solidFill>
-                      <a:prstDash val="solid"/>
-                      <a:round/>
-                      <a:headEnd type="none" w="med" len="med"/>
-                      <a:tailEnd type="none" w="med" len="med"/>
-                    </a:lnB>
-                  </a:tcPr>
-                </a:tc>
-                <a:tc>
-                  <a:txBody>
-                    <a:bodyPr/>
-                    <a:lstStyle/>
-                    <a:p>
-                      <a:pPr algn="ctr" indent="0" marL="0">
-                        <a:buNone/>
-                      </a:pPr>
-                      <a:r>
-                        <a:rPr lang="en-US" sz="1050" dirty="0">
-                          <a:solidFill>
-                            <a:srgbClr val="1F2329"/>
-                          </a:solidFill>
-                          <a:latin typeface="맑은 고딕" pitchFamily="34" charset="0"/>
-                          <a:ea typeface="맑은 고딕" pitchFamily="34" charset="-122"/>
-                          <a:cs typeface="맑은 고딕" pitchFamily="34" charset="-120"/>
-                        </a:rPr>
-                        <a:t>27년 수주 예정</a:t>
-                      </a:r>
-                      <a:endParaRPr lang="en-US" sz="1050" dirty="0">
-                        <a:latin typeface="맑은 고딕" charset="0"/>
-                        <a:ea typeface="맑은 고딕" charset="0"/>
-                        <a:cs typeface="맑은 고딕" charset="0"/>
-                      </a:endParaRPr>
-                    </a:p>
-                  </a:txBody>
-                  <a:tcPr marL="54864" marR="54864" marT="18288" marB="18288" anchor="ctr">
-                    <a:lnL w="9525" cap="flat" cmpd="sng" algn="ctr">
-                      <a:solidFill>
-                        <a:srgbClr val="BFC5CF"/>
-                      </a:solidFill>
-                      <a:prstDash val="solid"/>
-                      <a:round/>
-                      <a:headEnd type="none" w="med" len="med"/>
-                      <a:tailEnd type="none" w="med" len="med"/>
-                    </a:lnL>
-                    <a:lnR w="9525" cap="flat" cmpd="sng" algn="ctr">
-                      <a:solidFill>
-                        <a:srgbClr val="BFC5CF"/>
-                      </a:solidFill>
-                      <a:prstDash val="solid"/>
-                      <a:round/>
-                      <a:headEnd type="none" w="med" len="med"/>
-                      <a:tailEnd type="none" w="med" len="med"/>
-                    </a:lnR>
-                    <a:lnT w="9525" cap="flat" cmpd="sng" algn="ctr">
-                      <a:solidFill>
-                        <a:srgbClr val="BFC5CF"/>
-                      </a:solidFill>
-                      <a:prstDash val="solid"/>
-                      <a:round/>
-                      <a:headEnd type="none" w="med" len="med"/>
-                      <a:tailEnd type="none" w="med" len="med"/>
-                    </a:lnT>
-                    <a:lnB w="9525" cap="flat" cmpd="sng" algn="ctr">
-                      <a:solidFill>
-                        <a:srgbClr val="BFC5CF"/>
-                      </a:solidFill>
-                      <a:prstDash val="solid"/>
-                      <a:round/>
-                      <a:headEnd type="none" w="med" len="med"/>
-                      <a:tailEnd type="none" w="med" len="med"/>
-                    </a:lnB>
-                  </a:tcPr>
-                </a:tc>
-                <a:tc>
-                  <a:txBody>
-                    <a:bodyPr/>
-                    <a:lstStyle/>
-                    <a:p>
-                      <a:pPr algn="r" indent="0" marL="0">
-                        <a:buNone/>
-                      </a:pPr>
-                      <a:r>
-                        <a:rPr lang="en-US" sz="1050" dirty="0">
-                          <a:solidFill>
-                            <a:srgbClr val="1F2329"/>
-                          </a:solidFill>
-                          <a:latin typeface="맑은 고딕" pitchFamily="34" charset="0"/>
-                          <a:ea typeface="맑은 고딕" pitchFamily="34" charset="-122"/>
-                          <a:cs typeface="맑은 고딕" pitchFamily="34" charset="-120"/>
-                        </a:rPr>
-                        <a:t>2.89</a:t>
-                      </a:r>
-                      <a:endParaRPr lang="en-US" sz="1050" dirty="0">
-                        <a:latin typeface="맑은 고딕" charset="0"/>
-                        <a:ea typeface="맑은 고딕" charset="0"/>
-                        <a:cs typeface="맑은 고딕" charset="0"/>
-                      </a:endParaRPr>
-                    </a:p>
-                  </a:txBody>
-                  <a:tcPr marL="54864" marR="54864" marT="18288" marB="18288" anchor="ctr">
-                    <a:lnL w="9525" cap="flat" cmpd="sng" algn="ctr">
-                      <a:solidFill>
-                        <a:srgbClr val="BFC5CF"/>
-                      </a:solidFill>
-                      <a:prstDash val="solid"/>
-                      <a:round/>
-                      <a:headEnd type="none" w="med" len="med"/>
-                      <a:tailEnd type="none" w="med" len="med"/>
-                    </a:lnL>
-                    <a:lnR w="9525" cap="flat" cmpd="sng" algn="ctr">
-                      <a:solidFill>
-                        <a:srgbClr val="BFC5CF"/>
-                      </a:solidFill>
-                      <a:prstDash val="solid"/>
-                      <a:round/>
-                      <a:headEnd type="none" w="med" len="med"/>
-                      <a:tailEnd type="none" w="med" len="med"/>
-                    </a:lnR>
-                    <a:lnT w="9525" cap="flat" cmpd="sng" algn="ctr">
-                      <a:solidFill>
-                        <a:srgbClr val="BFC5CF"/>
-                      </a:solidFill>
-                      <a:prstDash val="solid"/>
-                      <a:round/>
-                      <a:headEnd type="none" w="med" len="med"/>
-                      <a:tailEnd type="none" w="med" len="med"/>
-                    </a:lnT>
-                    <a:lnB w="9525" cap="flat" cmpd="sng" algn="ctr">
-                      <a:solidFill>
-                        <a:srgbClr val="BFC5CF"/>
-                      </a:solidFill>
-                      <a:prstDash val="solid"/>
-                      <a:round/>
-                      <a:headEnd type="none" w="med" len="med"/>
-                      <a:tailEnd type="none" w="med" len="med"/>
-                    </a:lnB>
-                  </a:tcPr>
-                </a:tc>
-              </a:tr>
-              <a:tr h="274320">
-                <a:tc rowSpan="2">
-                  <a:txBody>
-                    <a:bodyPr/>
-                    <a:lstStyle/>
-                    <a:p>
-                      <a:pPr algn="ctr" indent="0" marL="0">
-                        <a:buNone/>
-                      </a:pPr>
-                      <a:r>
-                        <a:rPr lang="en-US" sz="1050" b="1" dirty="0">
-                          <a:solidFill>
-                            <a:srgbClr val="1F2329"/>
-                          </a:solidFill>
-                          <a:latin typeface="맑은 고딕" pitchFamily="34" charset="0"/>
-                          <a:ea typeface="맑은 고딕" pitchFamily="34" charset="-122"/>
-                          <a:cs typeface="맑은 고딕" pitchFamily="34" charset="-120"/>
-                        </a:rPr>
-                        <a:t>추가</a:t>
-                      </a:r>
-                      <a:endParaRPr lang="en-US" sz="1050" dirty="0">
-                        <a:latin typeface="맑은 고딕" charset="0"/>
-                        <a:ea typeface="맑은 고딕" charset="0"/>
-                        <a:cs typeface="맑은 고딕" charset="0"/>
-                      </a:endParaRPr>
-                    </a:p>
-                    <a:p>
-                      <a:pPr algn="ctr" indent="0" marL="0">
-                        <a:buNone/>
-                      </a:pPr>
-                      <a:r>
-                        <a:rPr lang="en-US" sz="1050" b="1" dirty="0">
-                          <a:solidFill>
-                            <a:srgbClr val="1F2329"/>
-                          </a:solidFill>
-                          <a:latin typeface="맑은 고딕" pitchFamily="34" charset="0"/>
-                          <a:ea typeface="맑은 고딕" pitchFamily="34" charset="-122"/>
-                          <a:cs typeface="맑은 고딕" pitchFamily="34" charset="-120"/>
-                        </a:rPr>
-                        <a:t>제안</a:t>
-                      </a:r>
-                      <a:endParaRPr lang="en-US" sz="1050" dirty="0">
-                        <a:latin typeface="맑은 고딕" charset="0"/>
-                        <a:ea typeface="맑은 고딕" charset="0"/>
-                        <a:cs typeface="맑은 고딕" charset="0"/>
-                      </a:endParaRPr>
-                    </a:p>
-                  </a:txBody>
-                  <a:tcPr marL="54864" marR="54864" marT="18288" marB="18288" anchor="ctr">
-                    <a:lnL w="9525" cap="flat" cmpd="sng" algn="ctr">
-                      <a:solidFill>
-                        <a:srgbClr val="BFC5CF"/>
-                      </a:solidFill>
-                      <a:prstDash val="solid"/>
-                      <a:round/>
-                      <a:headEnd type="none" w="med" len="med"/>
-                      <a:tailEnd type="none" w="med" len="med"/>
-                    </a:lnL>
-                    <a:lnR w="9525" cap="flat" cmpd="sng" algn="ctr">
-                      <a:solidFill>
-                        <a:srgbClr val="BFC5CF"/>
-                      </a:solidFill>
-                      <a:prstDash val="solid"/>
-                      <a:round/>
-                      <a:headEnd type="none" w="med" len="med"/>
-                      <a:tailEnd type="none" w="med" len="med"/>
-                    </a:lnR>
-                    <a:lnT w="9525" cap="flat" cmpd="sng" algn="ctr">
-                      <a:solidFill>
-                        <a:srgbClr val="BFC5CF"/>
-                      </a:solidFill>
-                      <a:prstDash val="solid"/>
-                      <a:round/>
-                      <a:headEnd type="none" w="med" len="med"/>
-                      <a:tailEnd type="none" w="med" len="med"/>
-                    </a:lnT>
-                    <a:lnB w="9525" cap="flat" cmpd="sng" algn="ctr">
-                      <a:solidFill>
-                        <a:srgbClr val="BFC5CF"/>
-                      </a:solidFill>
-                      <a:prstDash val="solid"/>
-                      <a:round/>
-                      <a:headEnd type="none" w="med" len="med"/>
-                      <a:tailEnd type="none" w="med" len="med"/>
-                    </a:lnB>
-                  </a:tcPr>
-                </a:tc>
-                <a:tc>
-                  <a:txBody>
-                    <a:bodyPr/>
-                    <a:lstStyle/>
-                    <a:p>
-                      <a:pPr indent="0" marL="0">
-                        <a:buNone/>
-                      </a:pPr>
-                      <a:r>
-                        <a:rPr lang="en-US" sz="1050" dirty="0">
-                          <a:solidFill>
-                            <a:srgbClr val="1F2329"/>
-                          </a:solidFill>
-                          <a:latin typeface="맑은 고딕" pitchFamily="34" charset="0"/>
-                          <a:ea typeface="맑은 고딕" pitchFamily="34" charset="-122"/>
-                          <a:cs typeface="맑은 고딕" pitchFamily="34" charset="-120"/>
-                        </a:rPr>
-                        <a:t>[KT&amp;G] 차세대 PLM 시스템 구축</a:t>
-                      </a:r>
-                      <a:endParaRPr lang="en-US" sz="1050" dirty="0">
-                        <a:latin typeface="맑은 고딕" charset="0"/>
-                        <a:ea typeface="맑은 고딕" charset="0"/>
-                        <a:cs typeface="맑은 고딕" charset="0"/>
-                      </a:endParaRPr>
-                    </a:p>
-                  </a:txBody>
-                  <a:tcPr marL="54864" marR="54864" marT="18288" marB="18288" anchor="ctr">
-                    <a:lnL w="9525" cap="flat" cmpd="sng" algn="ctr">
-                      <a:solidFill>
-                        <a:srgbClr val="BFC5CF"/>
-                      </a:solidFill>
-                      <a:prstDash val="solid"/>
-                      <a:round/>
-                      <a:headEnd type="none" w="med" len="med"/>
-                      <a:tailEnd type="none" w="med" len="med"/>
-                    </a:lnL>
-                    <a:lnR w="9525" cap="flat" cmpd="sng" algn="ctr">
-                      <a:solidFill>
-                        <a:srgbClr val="BFC5CF"/>
-                      </a:solidFill>
-                      <a:prstDash val="solid"/>
-                      <a:round/>
-                      <a:headEnd type="none" w="med" len="med"/>
-                      <a:tailEnd type="none" w="med" len="med"/>
-                    </a:lnR>
-                    <a:lnT w="9525" cap="flat" cmpd="sng" algn="ctr">
-                      <a:solidFill>
-                        <a:srgbClr val="BFC5CF"/>
-                      </a:solidFill>
-                      <a:prstDash val="solid"/>
-                      <a:round/>
-                      <a:headEnd type="none" w="med" len="med"/>
-                      <a:tailEnd type="none" w="med" len="med"/>
-                    </a:lnT>
-                    <a:lnB w="9525" cap="flat" cmpd="sng" algn="ctr">
-                      <a:solidFill>
-                        <a:srgbClr val="BFC5CF"/>
-                      </a:solidFill>
-                      <a:prstDash val="solid"/>
-                      <a:round/>
-                      <a:headEnd type="none" w="med" len="med"/>
-                      <a:tailEnd type="none" w="med" len="med"/>
-                    </a:lnB>
-                  </a:tcPr>
-                </a:tc>
-                <a:tc>
-                  <a:txBody>
-                    <a:bodyPr/>
-                    <a:lstStyle/>
-                    <a:p>
-                      <a:pPr algn="ctr" indent="0" marL="0">
-                        <a:buNone/>
-                      </a:pPr>
-                      <a:r>
-                        <a:rPr lang="en-US" sz="1050" dirty="0">
-                          <a:solidFill>
-                            <a:srgbClr val="1F2329"/>
-                          </a:solidFill>
-                          <a:latin typeface="맑은 고딕" pitchFamily="34" charset="0"/>
-                          <a:ea typeface="맑은 고딕" pitchFamily="34" charset="-122"/>
-                          <a:cs typeface="맑은 고딕" pitchFamily="34" charset="-120"/>
-                        </a:rPr>
-                        <a:t>AI컨설팅</a:t>
-                      </a:r>
-                      <a:endParaRPr lang="en-US" sz="1050" dirty="0">
-                        <a:latin typeface="맑은 고딕" charset="0"/>
-                        <a:ea typeface="맑은 고딕" charset="0"/>
-                        <a:cs typeface="맑은 고딕" charset="0"/>
-                      </a:endParaRPr>
-                    </a:p>
-                  </a:txBody>
-                  <a:tcPr marL="54864" marR="54864" marT="18288" marB="18288" anchor="ctr">
-                    <a:lnL w="9525" cap="flat" cmpd="sng" algn="ctr">
-                      <a:solidFill>
-                        <a:srgbClr val="BFC5CF"/>
-                      </a:solidFill>
-                      <a:prstDash val="solid"/>
-                      <a:round/>
-                      <a:headEnd type="none" w="med" len="med"/>
-                      <a:tailEnd type="none" w="med" len="med"/>
-                    </a:lnL>
-                    <a:lnR w="9525" cap="flat" cmpd="sng" algn="ctr">
-                      <a:solidFill>
-                        <a:srgbClr val="BFC5CF"/>
-                      </a:solidFill>
-                      <a:prstDash val="solid"/>
-                      <a:round/>
-                      <a:headEnd type="none" w="med" len="med"/>
-                      <a:tailEnd type="none" w="med" len="med"/>
-                    </a:lnR>
-                    <a:lnT w="9525" cap="flat" cmpd="sng" algn="ctr">
-                      <a:solidFill>
-                        <a:srgbClr val="BFC5CF"/>
-                      </a:solidFill>
-                      <a:prstDash val="solid"/>
-                      <a:round/>
-                      <a:headEnd type="none" w="med" len="med"/>
-                      <a:tailEnd type="none" w="med" len="med"/>
-                    </a:lnT>
-                    <a:lnB w="9525" cap="flat" cmpd="sng" algn="ctr">
-                      <a:solidFill>
-                        <a:srgbClr val="BFC5CF"/>
-                      </a:solidFill>
-                      <a:prstDash val="solid"/>
-                      <a:round/>
-                      <a:headEnd type="none" w="med" len="med"/>
-                      <a:tailEnd type="none" w="med" len="med"/>
-                    </a:lnB>
-                  </a:tcPr>
-                </a:tc>
-                <a:tc>
-                  <a:txBody>
-                    <a:bodyPr/>
-                    <a:lstStyle/>
-                    <a:p>
-                      <a:pPr algn="r" indent="0" marL="0">
-                        <a:buNone/>
-                      </a:pPr>
-                      <a:r>
-                        <a:rPr lang="en-US" sz="1050" dirty="0">
-                          <a:solidFill>
-                            <a:srgbClr val="1F2329"/>
-                          </a:solidFill>
-                          <a:latin typeface="맑은 고딕" pitchFamily="34" charset="0"/>
-                          <a:ea typeface="맑은 고딕" pitchFamily="34" charset="-122"/>
-                          <a:cs typeface="맑은 고딕" pitchFamily="34" charset="-120"/>
-                        </a:rPr>
-                        <a:t>협의</a:t>
-                      </a:r>
-                      <a:endParaRPr lang="en-US" sz="1050" dirty="0">
-                        <a:latin typeface="맑은 고딕" charset="0"/>
-                        <a:ea typeface="맑은 고딕" charset="0"/>
-                        <a:cs typeface="맑은 고딕" charset="0"/>
-                      </a:endParaRPr>
-                    </a:p>
-                  </a:txBody>
-                  <a:tcPr marL="54864" marR="54864" marT="18288" marB="18288" anchor="ctr">
-                    <a:lnL w="9525" cap="flat" cmpd="sng" algn="ctr">
-                      <a:solidFill>
-                        <a:srgbClr val="BFC5CF"/>
-                      </a:solidFill>
-                      <a:prstDash val="solid"/>
-                      <a:round/>
-                      <a:headEnd type="none" w="med" len="med"/>
-                      <a:tailEnd type="none" w="med" len="med"/>
-                    </a:lnL>
-                    <a:lnR w="9525" cap="flat" cmpd="sng" algn="ctr">
-                      <a:solidFill>
-                        <a:srgbClr val="BFC5CF"/>
-                      </a:solidFill>
-                      <a:prstDash val="solid"/>
-                      <a:round/>
-                      <a:headEnd type="none" w="med" len="med"/>
-                      <a:tailEnd type="none" w="med" len="med"/>
-                    </a:lnR>
-                    <a:lnT w="9525" cap="flat" cmpd="sng" algn="ctr">
-                      <a:solidFill>
-                        <a:srgbClr val="BFC5CF"/>
-                      </a:solidFill>
-                      <a:prstDash val="solid"/>
-                      <a:round/>
-                      <a:headEnd type="none" w="med" len="med"/>
-                      <a:tailEnd type="none" w="med" len="med"/>
-                    </a:lnT>
-                    <a:lnB w="9525" cap="flat" cmpd="sng" algn="ctr">
-                      <a:solidFill>
-                        <a:srgbClr val="BFC5CF"/>
-                      </a:solidFill>
-                      <a:prstDash val="solid"/>
-                      <a:round/>
-                      <a:headEnd type="none" w="med" len="med"/>
-                      <a:tailEnd type="none" w="med" len="med"/>
-                    </a:lnB>
-                  </a:tcPr>
-                </a:tc>
-              </a:tr>
-              <a:tr h="274320">
-                <a:tc vMerge="1">
-                  <a:tcPr/>
-                </a:tc>
-                <a:tc>
-                  <a:txBody>
-                    <a:bodyPr/>
-                    <a:lstStyle/>
-                    <a:p>
-                      <a:pPr indent="0" marL="0">
-                        <a:buNone/>
-                      </a:pPr>
-                      <a:r>
-                        <a:rPr lang="en-US" sz="1050" dirty="0">
-                          <a:solidFill>
-                            <a:srgbClr val="1F2329"/>
-                          </a:solidFill>
-                          <a:latin typeface="맑은 고딕" pitchFamily="34" charset="0"/>
-                          <a:ea typeface="맑은 고딕" pitchFamily="34" charset="-122"/>
-                          <a:cs typeface="맑은 고딕" pitchFamily="34" charset="-120"/>
-                        </a:rPr>
-                        <a:t>[유안타증권] ITO 사업</a:t>
-                      </a:r>
-                      <a:endParaRPr lang="en-US" sz="1050" dirty="0">
-                        <a:latin typeface="맑은 고딕" charset="0"/>
-                        <a:ea typeface="맑은 고딕" charset="0"/>
-                        <a:cs typeface="맑은 고딕" charset="0"/>
-                      </a:endParaRPr>
-                    </a:p>
-                  </a:txBody>
-                  <a:tcPr marL="54864" marR="54864" marT="18288" marB="18288" anchor="ctr">
-                    <a:lnL w="9525" cap="flat" cmpd="sng" algn="ctr">
-                      <a:solidFill>
-                        <a:srgbClr val="BFC5CF"/>
-                      </a:solidFill>
-                      <a:prstDash val="solid"/>
-                      <a:round/>
-                      <a:headEnd type="none" w="med" len="med"/>
-                      <a:tailEnd type="none" w="med" len="med"/>
-                    </a:lnL>
-                    <a:lnR w="9525" cap="flat" cmpd="sng" algn="ctr">
-                      <a:solidFill>
-                        <a:srgbClr val="BFC5CF"/>
-                      </a:solidFill>
-                      <a:prstDash val="solid"/>
-                      <a:round/>
-                      <a:headEnd type="none" w="med" len="med"/>
-                      <a:tailEnd type="none" w="med" len="med"/>
-                    </a:lnR>
-                    <a:lnT w="9525" cap="flat" cmpd="sng" algn="ctr">
-                      <a:solidFill>
-                        <a:srgbClr val="BFC5CF"/>
-                      </a:solidFill>
-                      <a:prstDash val="solid"/>
-                      <a:round/>
-                      <a:headEnd type="none" w="med" len="med"/>
-                      <a:tailEnd type="none" w="med" len="med"/>
-                    </a:lnT>
-                    <a:lnB w="9525" cap="flat" cmpd="sng" algn="ctr">
-                      <a:solidFill>
-                        <a:srgbClr val="BFC5CF"/>
-                      </a:solidFill>
-                      <a:prstDash val="solid"/>
-                      <a:round/>
-                      <a:headEnd type="none" w="med" len="med"/>
-                      <a:tailEnd type="none" w="med" len="med"/>
-                    </a:lnB>
-                  </a:tcPr>
-                </a:tc>
-                <a:tc>
-                  <a:txBody>
-                    <a:bodyPr/>
-                    <a:lstStyle/>
-                    <a:p>
-                      <a:pPr algn="ctr" indent="0" marL="0">
-                        <a:buNone/>
-                      </a:pPr>
-                      <a:r>
-                        <a:rPr lang="en-US" sz="1050" dirty="0">
-                          <a:solidFill>
-                            <a:srgbClr val="1F2329"/>
-                          </a:solidFill>
-                          <a:latin typeface="맑은 고딕" pitchFamily="34" charset="0"/>
-                          <a:ea typeface="맑은 고딕" pitchFamily="34" charset="-122"/>
-                          <a:cs typeface="맑은 고딕" pitchFamily="34" charset="-120"/>
-                        </a:rPr>
-                        <a:t>AI컨설팅·교육</a:t>
-                      </a:r>
-                      <a:endParaRPr lang="en-US" sz="1050" dirty="0">
-                        <a:latin typeface="맑은 고딕" charset="0"/>
-                        <a:ea typeface="맑은 고딕" charset="0"/>
-                        <a:cs typeface="맑은 고딕" charset="0"/>
-                      </a:endParaRPr>
-                    </a:p>
-                  </a:txBody>
-                  <a:tcPr marL="54864" marR="54864" marT="18288" marB="18288" anchor="ctr">
-                    <a:lnL w="9525" cap="flat" cmpd="sng" algn="ctr">
-                      <a:solidFill>
-                        <a:srgbClr val="BFC5CF"/>
-                      </a:solidFill>
-                      <a:prstDash val="solid"/>
-                      <a:round/>
-                      <a:headEnd type="none" w="med" len="med"/>
-                      <a:tailEnd type="none" w="med" len="med"/>
-                    </a:lnL>
-                    <a:lnR w="9525" cap="flat" cmpd="sng" algn="ctr">
-                      <a:solidFill>
-                        <a:srgbClr val="BFC5CF"/>
-                      </a:solidFill>
-                      <a:prstDash val="solid"/>
-                      <a:round/>
-                      <a:headEnd type="none" w="med" len="med"/>
-                      <a:tailEnd type="none" w="med" len="med"/>
-                    </a:lnR>
-                    <a:lnT w="9525" cap="flat" cmpd="sng" algn="ctr">
-                      <a:solidFill>
-                        <a:srgbClr val="BFC5CF"/>
-                      </a:solidFill>
-                      <a:prstDash val="solid"/>
-                      <a:round/>
-                      <a:headEnd type="none" w="med" len="med"/>
-                      <a:tailEnd type="none" w="med" len="med"/>
-                    </a:lnT>
-                    <a:lnB w="9525" cap="flat" cmpd="sng" algn="ctr">
-                      <a:solidFill>
-                        <a:srgbClr val="BFC5CF"/>
-                      </a:solidFill>
-                      <a:prstDash val="solid"/>
-                      <a:round/>
-                      <a:headEnd type="none" w="med" len="med"/>
-                      <a:tailEnd type="none" w="med" len="med"/>
-                    </a:lnB>
-                  </a:tcPr>
-                </a:tc>
-                <a:tc>
-                  <a:txBody>
-                    <a:bodyPr/>
-                    <a:lstStyle/>
-                    <a:p>
-                      <a:pPr algn="r" indent="0" marL="0">
-                        <a:buNone/>
-                      </a:pPr>
-                      <a:r>
-                        <a:rPr lang="en-US" sz="1050" dirty="0">
-                          <a:solidFill>
-                            <a:srgbClr val="1F2329"/>
-                          </a:solidFill>
-                          <a:latin typeface="맑은 고딕" pitchFamily="34" charset="0"/>
-                          <a:ea typeface="맑은 고딕" pitchFamily="34" charset="-122"/>
-                          <a:cs typeface="맑은 고딕" pitchFamily="34" charset="-120"/>
-                        </a:rPr>
-                        <a:t>협의</a:t>
-                      </a:r>
-                      <a:endParaRPr lang="en-US" sz="1050" dirty="0">
-                        <a:latin typeface="맑은 고딕" charset="0"/>
-                        <a:ea typeface="맑은 고딕" charset="0"/>
-                        <a:cs typeface="맑은 고딕" charset="0"/>
-                      </a:endParaRPr>
-                    </a:p>
-                  </a:txBody>
-                  <a:tcPr marL="54864" marR="54864" marT="18288" marB="18288" anchor="ctr">
-                    <a:lnL w="9525" cap="flat" cmpd="sng" algn="ctr">
-                      <a:solidFill>
-                        <a:srgbClr val="BFC5CF"/>
-                      </a:solidFill>
-                      <a:prstDash val="solid"/>
-                      <a:round/>
-                      <a:headEnd type="none" w="med" len="med"/>
-                      <a:tailEnd type="none" w="med" len="med"/>
-                    </a:lnL>
-                    <a:lnR w="9525" cap="flat" cmpd="sng" algn="ctr">
-                      <a:solidFill>
-                        <a:srgbClr val="BFC5CF"/>
-                      </a:solidFill>
-                      <a:prstDash val="solid"/>
-                      <a:round/>
-                      <a:headEnd type="none" w="med" len="med"/>
-                      <a:tailEnd type="none" w="med" len="med"/>
-                    </a:lnR>
-                    <a:lnT w="9525" cap="flat" cmpd="sng" algn="ctr">
-                      <a:solidFill>
-                        <a:srgbClr val="BFC5CF"/>
-                      </a:solidFill>
-                      <a:prstDash val="solid"/>
-                      <a:round/>
-                      <a:headEnd type="none" w="med" len="med"/>
-                      <a:tailEnd type="none" w="med" len="med"/>
-                    </a:lnT>
-                    <a:lnB w="9525" cap="flat" cmpd="sng" algn="ctr">
-                      <a:solidFill>
-                        <a:srgbClr val="BFC5CF"/>
-                      </a:solidFill>
-                      <a:prstDash val="solid"/>
-                      <a:round/>
-                      <a:headEnd type="none" w="med" len="med"/>
-                      <a:tailEnd type="none" w="med" len="med"/>
-                    </a:lnB>
-                  </a:tcPr>
-                </a:tc>
-              </a:tr>
-              <a:tr h="274320">
-                <a:tc gridSpan="3">
-                  <a:txBody>
-                    <a:bodyPr/>
-                    <a:lstStyle/>
-                    <a:p>
-                      <a:pPr algn="ctr" indent="0" marL="0">
-                        <a:buNone/>
-                      </a:pPr>
-                      <a:r>
-                        <a:rPr lang="en-US" sz="1050" b="1" dirty="0">
-                          <a:solidFill>
-                            <a:srgbClr val="1F2329"/>
-                          </a:solidFill>
-                          <a:latin typeface="맑은 고딕" pitchFamily="34" charset="0"/>
-                          <a:ea typeface="맑은 고딕" pitchFamily="34" charset="-122"/>
-                          <a:cs typeface="맑은 고딕" pitchFamily="34" charset="-120"/>
-                        </a:rPr>
-                        <a:t>계 (확보 인벤토리)</a:t>
-                      </a:r>
-                      <a:endParaRPr lang="en-US" sz="1050" dirty="0">
-                        <a:latin typeface="맑은 고딕" charset="0"/>
-                        <a:ea typeface="맑은 고딕" charset="0"/>
-                        <a:cs typeface="맑은 고딕" charset="0"/>
-                      </a:endParaRPr>
-                    </a:p>
-                  </a:txBody>
-                  <a:tcPr marL="54864" marR="54864" marT="18288" marB="18288" anchor="ctr">
-                    <a:lnL w="9525" cap="flat" cmpd="sng" algn="ctr">
-                      <a:solidFill>
-                        <a:srgbClr val="BFC5CF"/>
-                      </a:solidFill>
-                      <a:prstDash val="solid"/>
-                      <a:round/>
-                      <a:headEnd type="none" w="med" len="med"/>
-                      <a:tailEnd type="none" w="med" len="med"/>
-                    </a:lnL>
-                    <a:lnR w="9525" cap="flat" cmpd="sng" algn="ctr">
-                      <a:solidFill>
-                        <a:srgbClr val="BFC5CF"/>
-                      </a:solidFill>
-                      <a:prstDash val="solid"/>
-                      <a:round/>
-                      <a:headEnd type="none" w="med" len="med"/>
-                      <a:tailEnd type="none" w="med" len="med"/>
-                    </a:lnR>
-                    <a:lnT w="9525" cap="flat" cmpd="sng" algn="ctr">
-                      <a:solidFill>
-                        <a:srgbClr val="BFC5CF"/>
-                      </a:solidFill>
-                      <a:prstDash val="solid"/>
-                      <a:round/>
-                      <a:headEnd type="none" w="med" len="med"/>
-                      <a:tailEnd type="none" w="med" len="med"/>
-                    </a:lnT>
-                    <a:lnB w="9525" cap="flat" cmpd="sng" algn="ctr">
-                      <a:solidFill>
-                        <a:srgbClr val="BFC5CF"/>
-                      </a:solidFill>
-                      <a:prstDash val="solid"/>
-                      <a:round/>
-                      <a:headEnd type="none" w="med" len="med"/>
-                      <a:tailEnd type="none" w="med" len="med"/>
-                    </a:lnB>
-                    <a:solidFill>
-                      <a:srgbClr val="E4E7EC"/>
-                    </a:solidFill>
-                  </a:tcPr>
-                </a:tc>
-                <a:tc hMerge="1">
-                  <a:tcPr/>
-                </a:tc>
-                <a:tc hMerge="1">
-                  <a:tcPr/>
-                </a:tc>
-                <a:tc>
-                  <a:txBody>
-                    <a:bodyPr/>
-                    <a:lstStyle/>
-                    <a:p>
-                      <a:pPr algn="r" indent="0" marL="0">
-                        <a:buNone/>
-                      </a:pPr>
-                      <a:r>
-                        <a:rPr lang="en-US" sz="1050" b="1" dirty="0">
-                          <a:solidFill>
-                            <a:srgbClr val="1F2329"/>
-                          </a:solidFill>
-                          <a:latin typeface="맑은 고딕" pitchFamily="34" charset="0"/>
-                          <a:ea typeface="맑은 고딕" pitchFamily="34" charset="-122"/>
-                          <a:cs typeface="맑은 고딕" pitchFamily="34" charset="-120"/>
-                        </a:rPr>
-                        <a:t>8.60</a:t>
-                      </a:r>
-                      <a:endParaRPr lang="en-US" sz="1050" dirty="0">
-                        <a:latin typeface="맑은 고딕" charset="0"/>
-                        <a:ea typeface="맑은 고딕" charset="0"/>
-                        <a:cs typeface="맑은 고딕" charset="0"/>
-                      </a:endParaRPr>
-                    </a:p>
-                  </a:txBody>
-                  <a:tcPr marL="54864" marR="54864" marT="18288" marB="18288" anchor="ctr">
-                    <a:lnL w="9525" cap="flat" cmpd="sng" algn="ctr">
-                      <a:solidFill>
-                        <a:srgbClr val="BFC5CF"/>
-                      </a:solidFill>
-                      <a:prstDash val="solid"/>
-                      <a:round/>
-                      <a:headEnd type="none" w="med" len="med"/>
-                      <a:tailEnd type="none" w="med" len="med"/>
-                    </a:lnL>
-                    <a:lnR w="9525" cap="flat" cmpd="sng" algn="ctr">
-                      <a:solidFill>
-                        <a:srgbClr val="BFC5CF"/>
-                      </a:solidFill>
-                      <a:prstDash val="solid"/>
-                      <a:round/>
-                      <a:headEnd type="none" w="med" len="med"/>
-                      <a:tailEnd type="none" w="med" len="med"/>
-                    </a:lnR>
-                    <a:lnT w="9525" cap="flat" cmpd="sng" algn="ctr">
-                      <a:solidFill>
-                        <a:srgbClr val="BFC5CF"/>
-                      </a:solidFill>
-                      <a:prstDash val="solid"/>
-                      <a:round/>
-                      <a:headEnd type="none" w="med" len="med"/>
-                      <a:tailEnd type="none" w="med" len="med"/>
-                    </a:lnT>
-                    <a:lnB w="9525" cap="flat" cmpd="sng" algn="ctr">
-                      <a:solidFill>
-                        <a:srgbClr val="BFC5CF"/>
-                      </a:solidFill>
-                      <a:prstDash val="solid"/>
-                      <a:round/>
-                      <a:headEnd type="none" w="med" len="med"/>
-                      <a:tailEnd type="none" w="med" len="med"/>
-                    </a:lnB>
-                    <a:solidFill>
-                      <a:srgbClr val="E4E7EC"/>
-                    </a:solidFill>
-                  </a:tcPr>
-                </a:tc>
-              </a:tr>
-            </a:tbl>
+        <a:graphic xmlns:a="http://schemas.openxmlformats.org/drawingml/2006/main">
+          <a:graphicData uri="http://schemas.openxmlformats.org/drawingml/2006/chart">
+            <c:chart xmlns:c="http://schemas.openxmlformats.org/drawingml/2006/chart" r:id="rId2"/>
           </a:graphicData>
         </a:graphic>
       </p:graphicFrame>
       <p:sp>
         <p:nvSpPr>
-          <p:cNvPr id="34" name="핵심 방향"/>
+          <p:cNvPr id="36" name="Text 32"/>
           <p:cNvSpPr txBox="1"/>
           <p:nvPr/>
         </p:nvSpPr>
         <p:spPr>
           <a:xfrm>
-            <a:off x="6336792" y="3822192"/>
-            <a:ext cx="5349240" cy="384048"/>
+            <a:off x="6336792" y="3273552"/>
+            <a:ext cx="5349240" cy="219456"/>
           </a:xfrm>
           <a:prstGeom prst="rect">
             <a:avLst/>
@@ -3955,6 +3192,102 @@
           <a:bodyPr wrap="square" lIns="0" tIns="0" rIns="0" bIns="0" rtlCol="0" anchor="ctr"/>
           <a:lstStyle/>
           <a:p>
+            <a:pPr algn="r" indent="0" marL="0">
+              <a:buNone/>
+            </a:pPr>
+            <a:r>
+              <a:rPr lang="en-US" sz="950" b="1" dirty="0">
+                <a:solidFill>
+                  <a:schemeClr val="accent1"/>
+                </a:solidFill>
+              </a:rPr>
+              <a:t>계 21.1억</a:t>
+            </a:r>
+            <a:pPr algn="r" indent="0" marL="0">
+              <a:buNone/>
+            </a:pPr>
+            <a:r>
+              <a:rPr lang="en-US" sz="950" dirty="0">
+                <a:solidFill>
+                  <a:schemeClr val="accent5"/>
+                </a:solidFill>
+              </a:rPr>
+              <a:t>  (수주 12.5억 + 27년 인벤토리 8.6억)  ※ 신분당선 총 사업규모 129억</a:t>
+            </a:r>
+            <a:endParaRPr lang="en-US" sz="950" dirty="0"/>
+          </a:p>
+        </p:txBody>
+      </p:sp>
+      <p:sp>
+        <p:nvSpPr>
+          <p:cNvPr id="37" name="Text 33"/>
+          <p:cNvSpPr txBox="1"/>
+          <p:nvPr/>
+        </p:nvSpPr>
+        <p:spPr>
+          <a:xfrm>
+            <a:off x="6336792" y="3529584"/>
+            <a:ext cx="5349240" cy="237744"/>
+          </a:xfrm>
+          <a:prstGeom prst="rect">
+            <a:avLst/>
+          </a:prstGeom>
+          <a:solidFill>
+            <a:schemeClr val="bg2"/>
+          </a:solidFill>
+          <a:ln/>
+        </p:spPr>
+        <p:txBody>
+          <a:bodyPr wrap="square" lIns="0" tIns="76200" rIns="76200" bIns="0" rtlCol="0" anchor="ctr"/>
+          <a:lstStyle/>
+          <a:p>
+            <a:pPr indent="0" marL="0">
+              <a:buNone/>
+            </a:pPr>
+            <a:r>
+              <a:rPr lang="en-US" sz="1000" b="1" dirty="0">
+                <a:solidFill>
+                  <a:schemeClr val="tx2"/>
+                </a:solidFill>
+              </a:rPr>
+              <a:t>추가 제안</a:t>
+            </a:r>
+            <a:pPr indent="0" marL="0">
+              <a:buNone/>
+            </a:pPr>
+            <a:r>
+              <a:rPr lang="en-US" sz="1000" dirty="0">
+                <a:solidFill>
+                  <a:schemeClr val="tx1"/>
+                </a:solidFill>
+              </a:rPr>
+              <a:t>  KT&amp;G 차세대 PLM (AI컨설팅) · 유안타증권 ITO (AI컨설팅·교육)</a:t>
+            </a:r>
+            <a:endParaRPr lang="en-US" sz="1000" dirty="0"/>
+          </a:p>
+        </p:txBody>
+      </p:sp>
+      <p:sp>
+        <p:nvSpPr>
+          <p:cNvPr id="38" name="핵심 방향"/>
+          <p:cNvSpPr txBox="1"/>
+          <p:nvPr/>
+        </p:nvSpPr>
+        <p:spPr>
+          <a:xfrm>
+            <a:off x="6336792" y="3822192"/>
+            <a:ext cx="5349240" cy="384048"/>
+          </a:xfrm>
+          <a:prstGeom prst="rect">
+            <a:avLst/>
+          </a:prstGeom>
+          <a:noFill/>
+          <a:ln/>
+        </p:spPr>
+        <p:txBody>
+          <a:bodyPr wrap="square" lIns="0" tIns="0" rIns="0" bIns="0" rtlCol="0" anchor="ctr"/>
+          <a:lstStyle/>
+          <a:p>
             <a:pPr algn="ctr" indent="0" marL="0">
               <a:buNone/>
             </a:pPr>
@@ -3972,7 +3305,7 @@
       </p:sp>
       <p:sp>
         <p:nvSpPr>
-          <p:cNvPr id="35" name="핵심 방향 divider"/>
+          <p:cNvPr id="39" name="핵심 방향 divider"/>
           <p:cNvSpPr/>
           <p:nvPr/>
         </p:nvSpPr>
@@ -3995,7 +3328,7 @@
       </p:sp>
       <p:sp>
         <p:nvSpPr>
-          <p:cNvPr id="36" name="전략 번호 1"/>
+          <p:cNvPr id="40" name="전략 번호 1"/>
           <p:cNvSpPr/>
           <p:nvPr/>
         </p:nvSpPr>
@@ -4020,7 +3353,7 @@
       </p:sp>
       <p:sp>
         <p:nvSpPr>
-          <p:cNvPr id="37" name="Text 33"/>
+          <p:cNvPr id="41" name="Text 37"/>
           <p:cNvSpPr txBox="1"/>
           <p:nvPr/>
         </p:nvSpPr>
@@ -4056,7 +3389,7 @@
       </p:sp>
       <p:sp>
         <p:nvSpPr>
-          <p:cNvPr id="38" name="전략 라벨 1"/>
+          <p:cNvPr id="42" name="전략 라벨 1"/>
           <p:cNvSpPr txBox="1"/>
           <p:nvPr/>
         </p:nvSpPr>
@@ -4108,7 +3441,7 @@
       </p:sp>
       <p:sp>
         <p:nvSpPr>
-          <p:cNvPr id="39" name="Text 35"/>
+          <p:cNvPr id="43" name="Text 39"/>
           <p:cNvSpPr txBox="1"/>
           <p:nvPr/>
         </p:nvSpPr>
@@ -4166,7 +3499,7 @@
       </p:sp>
       <p:sp>
         <p:nvSpPr>
-          <p:cNvPr id="40" name="전략 번호 2"/>
+          <p:cNvPr id="44" name="전략 번호 2"/>
           <p:cNvSpPr/>
           <p:nvPr/>
         </p:nvSpPr>
@@ -4191,7 +3524,7 @@
       </p:sp>
       <p:sp>
         <p:nvSpPr>
-          <p:cNvPr id="41" name="Text 37"/>
+          <p:cNvPr id="45" name="Text 41"/>
           <p:cNvSpPr txBox="1"/>
           <p:nvPr/>
         </p:nvSpPr>
@@ -4227,7 +3560,7 @@
       </p:sp>
       <p:sp>
         <p:nvSpPr>
-          <p:cNvPr id="42" name="전략 라벨 2"/>
+          <p:cNvPr id="46" name="전략 라벨 2"/>
           <p:cNvSpPr txBox="1"/>
           <p:nvPr/>
         </p:nvSpPr>
@@ -4279,7 +3612,7 @@
       </p:sp>
       <p:sp>
         <p:nvSpPr>
-          <p:cNvPr id="43" name="Text 39"/>
+          <p:cNvPr id="47" name="Text 43"/>
           <p:cNvSpPr txBox="1"/>
           <p:nvPr/>
         </p:nvSpPr>
@@ -4337,7 +3670,7 @@
       </p:sp>
       <p:sp>
         <p:nvSpPr>
-          <p:cNvPr id="44" name="전략 번호 3"/>
+          <p:cNvPr id="48" name="전략 번호 3"/>
           <p:cNvSpPr/>
           <p:nvPr/>
         </p:nvSpPr>
@@ -4362,7 +3695,7 @@
       </p:sp>
       <p:sp>
         <p:nvSpPr>
-          <p:cNvPr id="45" name="Text 41"/>
+          <p:cNvPr id="49" name="Text 45"/>
           <p:cNvSpPr txBox="1"/>
           <p:nvPr/>
         </p:nvSpPr>
@@ -4398,7 +3731,7 @@
       </p:sp>
       <p:sp>
         <p:nvSpPr>
-          <p:cNvPr id="46" name="전략 라벨 3"/>
+          <p:cNvPr id="50" name="전략 라벨 3"/>
           <p:cNvSpPr txBox="1"/>
           <p:nvPr/>
         </p:nvSpPr>
@@ -4450,7 +3783,7 @@
       </p:sp>
       <p:sp>
         <p:nvSpPr>
-          <p:cNvPr id="47" name="Text 43"/>
+          <p:cNvPr id="51" name="Text 47"/>
           <p:cNvSpPr txBox="1"/>
           <p:nvPr/>
         </p:nvSpPr>

</xml_diff>

<commit_message>
Add track-record slide (25~26 projects by industry and service area)
Co-Authored-By: Claude Opus 5.5 <noreply@anthropic.com>
Claude-Session: https://claude.ai/code/session_014bmYQ2fMPYk9mSnunBW5W4
</commit_message>
<xml_diff>
--- a/AX컨설팅팀_27년_중점과제.pptx
+++ b/AX컨설팅팀_27년_중점과제.pptx
@@ -7,9 +7,10 @@
   <p:sldIdLst>
     <p:sldId id="256" r:id="rId2"/>
     <p:sldId id="257" r:id="rId3"/>
+    <p:sldId id="258" r:id="rId4"/>
   </p:sldIdLst>
   <p:notesMasterIdLst>
-    <p:notesMasterId r:id="rId4"/>
+    <p:notesMasterId r:id="rId5"/>
   </p:notesMasterIdLst>
   <p:sldSz cx="12192000" cy="6858000"/>
   <p:notesSz cx="6858000" cy="12192000"/>
@@ -1457,6 +1458,94 @@
 </p:notes>
 </file>
 
+<file path=ppt/notesSlides/notesSlide3.xml><?xml version="1.0" encoding="utf-8"?>
+<p:notes xmlns:a="http://schemas.openxmlformats.org/drawingml/2006/main" xmlns:r="http://schemas.openxmlformats.org/officeDocument/2006/relationships" xmlns:p="http://schemas.openxmlformats.org/presentationml/2006/main">
+  <p:cSld>
+    <p:spTree>
+      <p:nvGrpSpPr>
+        <p:cNvPr id="1" name=""/>
+        <p:cNvGrpSpPr/>
+        <p:nvPr/>
+      </p:nvGrpSpPr>
+      <p:grpSpPr>
+        <a:xfrm>
+          <a:off x="0" y="0"/>
+          <a:ext cx="0" cy="0"/>
+          <a:chOff x="0" y="0"/>
+          <a:chExt cx="0" cy="0"/>
+        </a:xfrm>
+      </p:grpSpPr>
+      <p:sp>
+        <p:nvSpPr>
+          <p:cNvPr id="2" name="Slide Image Placeholder 1"/>
+          <p:cNvSpPr>
+            <a:spLocks noGrp="1" noRot="1" noChangeAspect="1"/>
+          </p:cNvSpPr>
+          <p:nvPr>
+            <p:ph type="sldImg"/>
+          </p:nvPr>
+        </p:nvSpPr>
+        <p:spPr/>
+      </p:sp>
+      <p:sp>
+        <p:nvSpPr>
+          <p:cNvPr id="3" name="Notes Placeholder 2"/>
+          <p:cNvSpPr>
+            <a:spLocks noGrp="1"/>
+          </p:cNvSpPr>
+          <p:nvPr>
+            <p:ph type="body" idx="1"/>
+          </p:nvPr>
+        </p:nvSpPr>
+        <p:spPr/>
+        <p:txBody>
+          <a:bodyPr/>
+          <a:lstStyle/>
+          <a:p>
+            <a:r>
+              <a:rPr lang="en-US" dirty="0"/>
+              <a:t>25~26 수행 프로젝트(컨설팅 21, 교육 6)를 산업별로 묶고, 서비스 영역별 수행 여부를 표시. 고객사 20개(그룹사 15, 대외 5).</a:t>
+            </a:r>
+            <a:endParaRPr lang="en-US" dirty="0"/>
+          </a:p>
+        </p:txBody>
+      </p:sp>
+      <p:sp>
+        <p:nvSpPr>
+          <p:cNvPr id="4" name="Slide Number Placeholder 3"/>
+          <p:cNvSpPr>
+            <a:spLocks noGrp="1"/>
+          </p:cNvSpPr>
+          <p:nvPr>
+            <p:ph type="sldNum" sz="quarter" idx="10"/>
+          </p:nvPr>
+        </p:nvSpPr>
+        <p:spPr/>
+        <p:txBody>
+          <a:bodyPr/>
+          <a:lstStyle/>
+          <a:p>
+            <a:fld id="{F7021451-1387-4CA6-816F-3879F97B5CBC}" type="slidenum">
+              <a:rPr lang="en-US"/>
+              <a:t>3</a:t>
+            </a:fld>
+            <a:endParaRPr lang="en-US"/>
+          </a:p>
+        </p:txBody>
+      </p:sp>
+    </p:spTree>
+    <p:extLst>
+      <p:ext uri="{BB962C8B-B14F-4D97-AF65-F5344CB8AC3E}">
+        <p14:creationId xmlns:p14="http://schemas.microsoft.com/office/powerpoint/2010/main" val="1024086991"/>
+      </p:ext>
+    </p:extLst>
+  </p:cSld>
+  <p:clrMapOvr>
+    <a:masterClrMapping/>
+  </p:clrMapOvr>
+</p:notes>
+</file>
+
 <file path=ppt/slideLayouts/slideLayout1.xml><?xml version="1.0" encoding="utf-8"?>
 <p:sldLayout xmlns:a="http://schemas.openxmlformats.org/drawingml/2006/main" xmlns:r="http://schemas.openxmlformats.org/officeDocument/2006/relationships" xmlns:p="http://schemas.openxmlformats.org/presentationml/2006/main" preserve="1">
   <p:cSld name="DEFAULT">
@@ -7783,6 +7872,2488 @@
               <a:t>50%↓</a:t>
             </a:r>
             <a:endParaRPr lang="en-US" sz="1150" dirty="0"/>
+          </a:p>
+        </p:txBody>
+      </p:sp>
+    </p:spTree>
+  </p:cSld>
+  <p:clrMapOvr>
+    <a:masterClrMapping/>
+  </p:clrMapOvr>
+</p:sld>
+</file>
+
+<file path=ppt/slides/slide3.xml><?xml version="1.0" encoding="utf-8"?>
+<p:sld xmlns:a="http://schemas.openxmlformats.org/drawingml/2006/main" xmlns:r="http://schemas.openxmlformats.org/officeDocument/2006/relationships" xmlns:p="http://schemas.openxmlformats.org/presentationml/2006/main">
+  <p:cSld name="Slide 3">
+    <p:spTree>
+      <p:nvGrpSpPr>
+        <p:cNvPr id="1" name=""/>
+        <p:cNvGrpSpPr/>
+        <p:nvPr/>
+      </p:nvGrpSpPr>
+      <p:grpSpPr>
+        <a:xfrm>
+          <a:off x="0" y="0"/>
+          <a:ext cx="0" cy="0"/>
+          <a:chOff x="0" y="0"/>
+          <a:chExt cx="0" cy="0"/>
+        </a:xfrm>
+      </p:grpSpPr>
+      <p:sp>
+        <p:nvSpPr>
+          <p:cNvPr id="2" name="Text 1"/>
+          <p:cNvSpPr/>
+          <p:nvPr>
+            <p:ph idx="101" type="title" hasCustomPrompt="1"/>
+          </p:nvPr>
+        </p:nvSpPr>
+        <p:spPr>
+          <a:xfrm>
+            <a:off x="365760" y="228600"/>
+            <a:ext cx="11430000" cy="640080"/>
+          </a:xfrm>
+          <a:prstGeom prst="rect">
+            <a:avLst/>
+          </a:prstGeom>
+          <a:noFill/>
+          <a:ln/>
+        </p:spPr>
+        <p:txBody>
+          <a:bodyPr wrap="square" lIns="0" tIns="0" rIns="0" bIns="0" rtlCol="0" anchor="ctr"/>
+          <a:lstStyle/>
+          <a:p>
+            <a:pPr algn="l" indent="0" marL="0">
+              <a:buNone/>
+            </a:pPr>
+            <a:r>
+              <a:rPr lang="en-US" sz="2600" b="1" dirty="0">
+                <a:solidFill>
+                  <a:schemeClr val="tx1"/>
+                </a:solidFill>
+              </a:rPr>
+              <a:t>AX컨설팅팀 수행 실적 ('25~'26)</a:t>
+            </a:r>
+            <a:endParaRPr lang="en-US" sz="2600" dirty="0"/>
+          </a:p>
+        </p:txBody>
+      </p:sp>
+      <p:sp>
+        <p:nvSpPr>
+          <p:cNvPr id="3" name="헤드 메시지"/>
+          <p:cNvSpPr txBox="1"/>
+          <p:nvPr/>
+        </p:nvSpPr>
+        <p:spPr>
+          <a:xfrm>
+            <a:off x="365760" y="1005840"/>
+            <a:ext cx="11457432" cy="566928"/>
+          </a:xfrm>
+          <a:prstGeom prst="rect">
+            <a:avLst/>
+          </a:prstGeom>
+          <a:noFill/>
+          <a:ln/>
+        </p:spPr>
+        <p:txBody>
+          <a:bodyPr wrap="square" lIns="0" tIns="0" rIns="0" bIns="0" rtlCol="0" anchor="ctr"/>
+          <a:lstStyle/>
+          <a:p>
+            <a:pPr indent="0" marL="0">
+              <a:buNone/>
+            </a:pPr>
+            <a:r>
+              <a:rPr lang="en-US" sz="1400" b="1" dirty="0">
+                <a:solidFill>
+                  <a:schemeClr val="tx2"/>
+                </a:solidFill>
+              </a:rPr>
+              <a:t>AX컨설팅팀은 지난 2년간 그룹사 15개사·대외 5개사의 AX 파트너로서 AI 전략·과제 도출부터 실습교육, 구현 Pilot, 구축 사업 연계까지 27건의 프로젝트를 수행하며 AI과제 108건을 발굴함</a:t>
+            </a:r>
+            <a:endParaRPr lang="en-US" sz="1400" dirty="0"/>
+          </a:p>
+        </p:txBody>
+      </p:sp>
+      <p:sp>
+        <p:nvSpPr>
+          <p:cNvPr id="4" name="열 AI 전략· 과제 도출"/>
+          <p:cNvSpPr/>
+          <p:nvPr/>
+        </p:nvSpPr>
+        <p:spPr>
+          <a:xfrm>
+            <a:off x="7680960" y="1719072"/>
+            <a:ext cx="749808" cy="4663440"/>
+          </a:xfrm>
+          <a:prstGeom prst="roundRect">
+            <a:avLst>
+              <a:gd name="adj" fmla="val 7317"/>
+            </a:avLst>
+          </a:prstGeom>
+          <a:solidFill>
+            <a:srgbClr val="D9DDE3"/>
+          </a:solidFill>
+          <a:ln w="12700">
+            <a:solidFill>
+              <a:srgbClr val="D9DDE3"/>
+            </a:solidFill>
+            <a:prstDash val="solid"/>
+          </a:ln>
+        </p:spPr>
+      </p:sp>
+      <p:sp>
+        <p:nvSpPr>
+          <p:cNvPr id="5" name="Text 3"/>
+          <p:cNvSpPr txBox="1"/>
+          <p:nvPr/>
+        </p:nvSpPr>
+        <p:spPr>
+          <a:xfrm>
+            <a:off x="7680960" y="1719072"/>
+            <a:ext cx="749808" cy="713232"/>
+          </a:xfrm>
+          <a:prstGeom prst="rect">
+            <a:avLst/>
+          </a:prstGeom>
+          <a:noFill/>
+          <a:ln/>
+        </p:spPr>
+        <p:txBody>
+          <a:bodyPr wrap="square" lIns="0" tIns="0" rIns="0" bIns="0" rtlCol="0" anchor="ctr"/>
+          <a:lstStyle/>
+          <a:p>
+            <a:pPr algn="ctr" indent="0" marL="0">
+              <a:buNone/>
+            </a:pPr>
+            <a:r>
+              <a:rPr lang="en-US" sz="1100" b="1" dirty="0">
+                <a:solidFill>
+                  <a:schemeClr val="tx2"/>
+                </a:solidFill>
+              </a:rPr>
+              <a:t>AI 전략·</a:t>
+            </a:r>
+            <a:endParaRPr lang="en-US" sz="1100" dirty="0"/>
+          </a:p>
+          <a:p>
+            <a:pPr algn="ctr" indent="0" marL="0">
+              <a:buNone/>
+            </a:pPr>
+            <a:r>
+              <a:rPr lang="en-US" sz="1100" b="1" dirty="0">
+                <a:solidFill>
+                  <a:schemeClr val="tx2"/>
+                </a:solidFill>
+              </a:rPr>
+              <a:t>과제 도출</a:t>
+            </a:r>
+            <a:endParaRPr lang="en-US" sz="1100" dirty="0"/>
+          </a:p>
+        </p:txBody>
+      </p:sp>
+      <p:sp>
+        <p:nvSpPr>
+          <p:cNvPr id="6" name="열 AX 진단· Blueprint"/>
+          <p:cNvSpPr/>
+          <p:nvPr/>
+        </p:nvSpPr>
+        <p:spPr>
+          <a:xfrm>
+            <a:off x="8522208" y="1719072"/>
+            <a:ext cx="749808" cy="4663440"/>
+          </a:xfrm>
+          <a:prstGeom prst="roundRect">
+            <a:avLst>
+              <a:gd name="adj" fmla="val 7317"/>
+            </a:avLst>
+          </a:prstGeom>
+          <a:solidFill>
+            <a:srgbClr val="D9DDE3"/>
+          </a:solidFill>
+          <a:ln w="12700">
+            <a:solidFill>
+              <a:srgbClr val="D9DDE3"/>
+            </a:solidFill>
+            <a:prstDash val="solid"/>
+          </a:ln>
+        </p:spPr>
+      </p:sp>
+      <p:sp>
+        <p:nvSpPr>
+          <p:cNvPr id="7" name="Text 5"/>
+          <p:cNvSpPr txBox="1"/>
+          <p:nvPr/>
+        </p:nvSpPr>
+        <p:spPr>
+          <a:xfrm>
+            <a:off x="8522208" y="1719072"/>
+            <a:ext cx="749808" cy="713232"/>
+          </a:xfrm>
+          <a:prstGeom prst="rect">
+            <a:avLst/>
+          </a:prstGeom>
+          <a:noFill/>
+          <a:ln/>
+        </p:spPr>
+        <p:txBody>
+          <a:bodyPr wrap="square" lIns="0" tIns="0" rIns="0" bIns="0" rtlCol="0" anchor="ctr"/>
+          <a:lstStyle/>
+          <a:p>
+            <a:pPr algn="ctr" indent="0" marL="0">
+              <a:buNone/>
+            </a:pPr>
+            <a:r>
+              <a:rPr lang="en-US" sz="1100" b="1" dirty="0">
+                <a:solidFill>
+                  <a:schemeClr val="tx2"/>
+                </a:solidFill>
+              </a:rPr>
+              <a:t>AX 진단·</a:t>
+            </a:r>
+            <a:endParaRPr lang="en-US" sz="1100" dirty="0"/>
+          </a:p>
+          <a:p>
+            <a:pPr algn="ctr" indent="0" marL="0">
+              <a:buNone/>
+            </a:pPr>
+            <a:r>
+              <a:rPr lang="en-US" sz="1100" b="1" dirty="0">
+                <a:solidFill>
+                  <a:schemeClr val="tx2"/>
+                </a:solidFill>
+              </a:rPr>
+              <a:t>Blueprint</a:t>
+            </a:r>
+            <a:endParaRPr lang="en-US" sz="1100" dirty="0"/>
+          </a:p>
+        </p:txBody>
+      </p:sp>
+      <p:sp>
+        <p:nvSpPr>
+          <p:cNvPr id="8" name="열 구현방안· Pilot"/>
+          <p:cNvSpPr/>
+          <p:nvPr/>
+        </p:nvSpPr>
+        <p:spPr>
+          <a:xfrm>
+            <a:off x="9363456" y="1719072"/>
+            <a:ext cx="749808" cy="4663440"/>
+          </a:xfrm>
+          <a:prstGeom prst="roundRect">
+            <a:avLst>
+              <a:gd name="adj" fmla="val 7317"/>
+            </a:avLst>
+          </a:prstGeom>
+          <a:solidFill>
+            <a:srgbClr val="D9DDE3"/>
+          </a:solidFill>
+          <a:ln w="12700">
+            <a:solidFill>
+              <a:srgbClr val="D9DDE3"/>
+            </a:solidFill>
+            <a:prstDash val="solid"/>
+          </a:ln>
+        </p:spPr>
+      </p:sp>
+      <p:sp>
+        <p:nvSpPr>
+          <p:cNvPr id="9" name="Text 7"/>
+          <p:cNvSpPr txBox="1"/>
+          <p:nvPr/>
+        </p:nvSpPr>
+        <p:spPr>
+          <a:xfrm>
+            <a:off x="9363456" y="1719072"/>
+            <a:ext cx="749808" cy="713232"/>
+          </a:xfrm>
+          <a:prstGeom prst="rect">
+            <a:avLst/>
+          </a:prstGeom>
+          <a:noFill/>
+          <a:ln/>
+        </p:spPr>
+        <p:txBody>
+          <a:bodyPr wrap="square" lIns="0" tIns="0" rIns="0" bIns="0" rtlCol="0" anchor="ctr"/>
+          <a:lstStyle/>
+          <a:p>
+            <a:pPr algn="ctr" indent="0" marL="0">
+              <a:buNone/>
+            </a:pPr>
+            <a:r>
+              <a:rPr lang="en-US" sz="1100" b="1" dirty="0">
+                <a:solidFill>
+                  <a:schemeClr val="tx2"/>
+                </a:solidFill>
+              </a:rPr>
+              <a:t>구현방안·</a:t>
+            </a:r>
+            <a:endParaRPr lang="en-US" sz="1100" dirty="0"/>
+          </a:p>
+          <a:p>
+            <a:pPr algn="ctr" indent="0" marL="0">
+              <a:buNone/>
+            </a:pPr>
+            <a:r>
+              <a:rPr lang="en-US" sz="1100" b="1" dirty="0">
+                <a:solidFill>
+                  <a:schemeClr val="tx2"/>
+                </a:solidFill>
+              </a:rPr>
+              <a:t>Pilot</a:t>
+            </a:r>
+            <a:endParaRPr lang="en-US" sz="1100" dirty="0"/>
+          </a:p>
+        </p:txBody>
+      </p:sp>
+      <p:sp>
+        <p:nvSpPr>
+          <p:cNvPr id="10" name="열 AI 실습 교육"/>
+          <p:cNvSpPr/>
+          <p:nvPr/>
+        </p:nvSpPr>
+        <p:spPr>
+          <a:xfrm>
+            <a:off x="10204704" y="1719072"/>
+            <a:ext cx="749808" cy="4663440"/>
+          </a:xfrm>
+          <a:prstGeom prst="roundRect">
+            <a:avLst>
+              <a:gd name="adj" fmla="val 7317"/>
+            </a:avLst>
+          </a:prstGeom>
+          <a:solidFill>
+            <a:srgbClr val="D9DDE3"/>
+          </a:solidFill>
+          <a:ln w="12700">
+            <a:solidFill>
+              <a:srgbClr val="D9DDE3"/>
+            </a:solidFill>
+            <a:prstDash val="solid"/>
+          </a:ln>
+        </p:spPr>
+      </p:sp>
+      <p:sp>
+        <p:nvSpPr>
+          <p:cNvPr id="11" name="Text 9"/>
+          <p:cNvSpPr txBox="1"/>
+          <p:nvPr/>
+        </p:nvSpPr>
+        <p:spPr>
+          <a:xfrm>
+            <a:off x="10204704" y="1719072"/>
+            <a:ext cx="749808" cy="713232"/>
+          </a:xfrm>
+          <a:prstGeom prst="rect">
+            <a:avLst/>
+          </a:prstGeom>
+          <a:noFill/>
+          <a:ln/>
+        </p:spPr>
+        <p:txBody>
+          <a:bodyPr wrap="square" lIns="0" tIns="0" rIns="0" bIns="0" rtlCol="0" anchor="ctr"/>
+          <a:lstStyle/>
+          <a:p>
+            <a:pPr algn="ctr" indent="0" marL="0">
+              <a:buNone/>
+            </a:pPr>
+            <a:r>
+              <a:rPr lang="en-US" sz="1100" b="1" dirty="0">
+                <a:solidFill>
+                  <a:schemeClr val="tx2"/>
+                </a:solidFill>
+              </a:rPr>
+              <a:t>AI 실습</a:t>
+            </a:r>
+            <a:endParaRPr lang="en-US" sz="1100" dirty="0"/>
+          </a:p>
+          <a:p>
+            <a:pPr algn="ctr" indent="0" marL="0">
+              <a:buNone/>
+            </a:pPr>
+            <a:r>
+              <a:rPr lang="en-US" sz="1100" b="1" dirty="0">
+                <a:solidFill>
+                  <a:schemeClr val="tx2"/>
+                </a:solidFill>
+              </a:rPr>
+              <a:t>교육</a:t>
+            </a:r>
+            <a:endParaRPr lang="en-US" sz="1100" dirty="0"/>
+          </a:p>
+        </p:txBody>
+      </p:sp>
+      <p:sp>
+        <p:nvSpPr>
+          <p:cNvPr id="12" name="열 구축·수주 연계"/>
+          <p:cNvSpPr/>
+          <p:nvPr/>
+        </p:nvSpPr>
+        <p:spPr>
+          <a:xfrm>
+            <a:off x="11045952" y="1719072"/>
+            <a:ext cx="749808" cy="4663440"/>
+          </a:xfrm>
+          <a:prstGeom prst="roundRect">
+            <a:avLst>
+              <a:gd name="adj" fmla="val 7317"/>
+            </a:avLst>
+          </a:prstGeom>
+          <a:solidFill>
+            <a:srgbClr val="D9DDE3"/>
+          </a:solidFill>
+          <a:ln w="12700">
+            <a:solidFill>
+              <a:srgbClr val="D9DDE3"/>
+            </a:solidFill>
+            <a:prstDash val="solid"/>
+          </a:ln>
+        </p:spPr>
+      </p:sp>
+      <p:sp>
+        <p:nvSpPr>
+          <p:cNvPr id="13" name="Text 11"/>
+          <p:cNvSpPr txBox="1"/>
+          <p:nvPr/>
+        </p:nvSpPr>
+        <p:spPr>
+          <a:xfrm>
+            <a:off x="11045952" y="1719072"/>
+            <a:ext cx="749808" cy="713232"/>
+          </a:xfrm>
+          <a:prstGeom prst="rect">
+            <a:avLst/>
+          </a:prstGeom>
+          <a:noFill/>
+          <a:ln/>
+        </p:spPr>
+        <p:txBody>
+          <a:bodyPr wrap="square" lIns="0" tIns="0" rIns="0" bIns="0" rtlCol="0" anchor="ctr"/>
+          <a:lstStyle/>
+          <a:p>
+            <a:pPr algn="ctr" indent="0" marL="0">
+              <a:buNone/>
+            </a:pPr>
+            <a:r>
+              <a:rPr lang="en-US" sz="1100" b="1" dirty="0">
+                <a:solidFill>
+                  <a:schemeClr val="tx2"/>
+                </a:solidFill>
+              </a:rPr>
+              <a:t>구축·수주</a:t>
+            </a:r>
+            <a:endParaRPr lang="en-US" sz="1100" dirty="0"/>
+          </a:p>
+          <a:p>
+            <a:pPr algn="ctr" indent="0" marL="0">
+              <a:buNone/>
+            </a:pPr>
+            <a:r>
+              <a:rPr lang="en-US" sz="1100" b="1" dirty="0">
+                <a:solidFill>
+                  <a:schemeClr val="tx2"/>
+                </a:solidFill>
+              </a:rPr>
+              <a:t>연계</a:t>
+            </a:r>
+            <a:endParaRPr lang="en-US" sz="1100" dirty="0"/>
+          </a:p>
+        </p:txBody>
+      </p:sp>
+      <p:sp>
+        <p:nvSpPr>
+          <p:cNvPr id="14" name="행 구분 1"/>
+          <p:cNvSpPr/>
+          <p:nvPr/>
+        </p:nvSpPr>
+        <p:spPr>
+          <a:xfrm>
+            <a:off x="365760" y="2468880"/>
+            <a:ext cx="11457432" cy="0"/>
+          </a:xfrm>
+          <a:prstGeom prst="line">
+            <a:avLst/>
+          </a:prstGeom>
+          <a:noFill/>
+          <a:ln w="12700">
+            <a:solidFill>
+              <a:srgbClr val="A6ADB8"/>
+            </a:solidFill>
+            <a:prstDash val="solid"/>
+          </a:ln>
+        </p:spPr>
+      </p:sp>
+      <p:sp>
+        <p:nvSpPr>
+          <p:cNvPr id="15" name="행 라벨 유통"/>
+          <p:cNvSpPr txBox="1"/>
+          <p:nvPr/>
+        </p:nvSpPr>
+        <p:spPr>
+          <a:xfrm>
+            <a:off x="365760" y="2505456"/>
+            <a:ext cx="1417320" cy="485938"/>
+          </a:xfrm>
+          <a:prstGeom prst="rect">
+            <a:avLst/>
+          </a:prstGeom>
+          <a:solidFill>
+            <a:schemeClr val="tx2"/>
+          </a:solidFill>
+          <a:ln/>
+        </p:spPr>
+        <p:txBody>
+          <a:bodyPr wrap="square" lIns="0" tIns="0" rIns="0" bIns="0" rtlCol="0" anchor="ctr"/>
+          <a:lstStyle/>
+          <a:p>
+            <a:pPr algn="ctr" indent="0" marL="0">
+              <a:buNone/>
+            </a:pPr>
+            <a:r>
+              <a:rPr lang="en-US" sz="1300" b="1" dirty="0">
+                <a:solidFill>
+                  <a:schemeClr val="bg1"/>
+                </a:solidFill>
+              </a:rPr>
+              <a:t>유통</a:t>
+            </a:r>
+            <a:endParaRPr lang="en-US" sz="1300" dirty="0"/>
+          </a:p>
+          <a:p>
+            <a:pPr algn="ctr" indent="0" marL="0">
+              <a:buNone/>
+            </a:pPr>
+            <a:r>
+              <a:rPr lang="en-US" sz="1100" b="1" dirty="0">
+                <a:solidFill>
+                  <a:schemeClr val="bg1"/>
+                </a:solidFill>
+              </a:rPr>
+              <a:t>(4개사)</a:t>
+            </a:r>
+            <a:endParaRPr lang="en-US" sz="1300" dirty="0"/>
+          </a:p>
+        </p:txBody>
+      </p:sp>
+      <p:sp>
+        <p:nvSpPr>
+          <p:cNvPr id="16" name="Text 14"/>
+          <p:cNvSpPr txBox="1"/>
+          <p:nvPr/>
+        </p:nvSpPr>
+        <p:spPr>
+          <a:xfrm>
+            <a:off x="1874520" y="2487168"/>
+            <a:ext cx="5715000" cy="522514"/>
+          </a:xfrm>
+          <a:prstGeom prst="rect">
+            <a:avLst/>
+          </a:prstGeom>
+          <a:noFill/>
+          <a:ln/>
+        </p:spPr>
+        <p:txBody>
+          <a:bodyPr wrap="square" lIns="0" tIns="0" rIns="0" bIns="0" rtlCol="0" anchor="ctr"/>
+          <a:lstStyle/>
+          <a:p>
+            <a:pPr marL="342900" indent="-342900">
+              <a:spcAft>
+                <a:spcPts val="200"/>
+              </a:spcAft>
+              <a:buSzPct val="100000"/>
+              <a:buChar char="▶"/>
+            </a:pPr>
+            <a:r>
+              <a:rPr lang="en-US" sz="1050" dirty="0">
+                <a:solidFill>
+                  <a:schemeClr val="tx1"/>
+                </a:solidFill>
+              </a:rPr>
+              <a:t>하이마트·마트/슈퍼·코리아세븐·백화점: AI 추진과제 도출, 수익성 KPI 성과관리 로드맵</a:t>
+            </a:r>
+            <a:endParaRPr lang="en-US" sz="1050" dirty="0"/>
+          </a:p>
+          <a:p>
+            <a:pPr marL="342900" indent="-342900">
+              <a:spcAft>
+                <a:spcPts val="200"/>
+              </a:spcAft>
+              <a:buSzPct val="100000"/>
+              <a:buChar char="▶"/>
+            </a:pPr>
+            <a:r>
+              <a:rPr lang="en-US" sz="1050" dirty="0">
+                <a:solidFill>
+                  <a:schemeClr val="tx1"/>
+                </a:solidFill>
+              </a:rPr>
+              <a:t>AI 점포관리 개선·AX SPOT Blueprint, 이커머스 실무 AI 실습, 브랜드 AI포탈 구축 外</a:t>
+            </a:r>
+            <a:endParaRPr lang="en-US" sz="1050" dirty="0"/>
+          </a:p>
+        </p:txBody>
+      </p:sp>
+      <p:sp>
+        <p:nvSpPr>
+          <p:cNvPr id="17" name="표시 유통 1"/>
+          <p:cNvSpPr/>
+          <p:nvPr/>
+        </p:nvSpPr>
+        <p:spPr>
+          <a:xfrm>
+            <a:off x="7918704" y="2611265"/>
+            <a:ext cx="274320" cy="274320"/>
+          </a:xfrm>
+          <a:prstGeom prst="ellipse">
+            <a:avLst/>
+          </a:prstGeom>
+          <a:solidFill>
+            <a:srgbClr val="1F4E9A"/>
+          </a:solidFill>
+          <a:ln w="15875">
+            <a:solidFill>
+              <a:srgbClr val="1F4E9A"/>
+            </a:solidFill>
+            <a:prstDash val="solid"/>
+          </a:ln>
+        </p:spPr>
+      </p:sp>
+      <p:sp>
+        <p:nvSpPr>
+          <p:cNvPr id="18" name="표시 유통 2"/>
+          <p:cNvSpPr/>
+          <p:nvPr/>
+        </p:nvSpPr>
+        <p:spPr>
+          <a:xfrm>
+            <a:off x="8759952" y="2611265"/>
+            <a:ext cx="274320" cy="274320"/>
+          </a:xfrm>
+          <a:prstGeom prst="ellipse">
+            <a:avLst/>
+          </a:prstGeom>
+          <a:solidFill>
+            <a:srgbClr val="1F4E9A"/>
+          </a:solidFill>
+          <a:ln w="15875">
+            <a:solidFill>
+              <a:srgbClr val="1F4E9A"/>
+            </a:solidFill>
+            <a:prstDash val="solid"/>
+          </a:ln>
+        </p:spPr>
+      </p:sp>
+      <p:sp>
+        <p:nvSpPr>
+          <p:cNvPr id="19" name="표시 유통 3"/>
+          <p:cNvSpPr/>
+          <p:nvPr/>
+        </p:nvSpPr>
+        <p:spPr>
+          <a:xfrm>
+            <a:off x="9601200" y="2611265"/>
+            <a:ext cx="274320" cy="274320"/>
+          </a:xfrm>
+          <a:prstGeom prst="ellipse">
+            <a:avLst/>
+          </a:prstGeom>
+          <a:solidFill>
+            <a:srgbClr val="1F4E9A"/>
+          </a:solidFill>
+          <a:ln w="15875">
+            <a:solidFill>
+              <a:srgbClr val="1F4E9A"/>
+            </a:solidFill>
+            <a:prstDash val="solid"/>
+          </a:ln>
+        </p:spPr>
+      </p:sp>
+      <p:sp>
+        <p:nvSpPr>
+          <p:cNvPr id="20" name="표시 유통 4"/>
+          <p:cNvSpPr/>
+          <p:nvPr/>
+        </p:nvSpPr>
+        <p:spPr>
+          <a:xfrm>
+            <a:off x="10442448" y="2611265"/>
+            <a:ext cx="274320" cy="274320"/>
+          </a:xfrm>
+          <a:prstGeom prst="ellipse">
+            <a:avLst/>
+          </a:prstGeom>
+          <a:solidFill>
+            <a:srgbClr val="1F4E9A"/>
+          </a:solidFill>
+          <a:ln w="15875">
+            <a:solidFill>
+              <a:srgbClr val="1F4E9A"/>
+            </a:solidFill>
+            <a:prstDash val="solid"/>
+          </a:ln>
+        </p:spPr>
+      </p:sp>
+      <p:sp>
+        <p:nvSpPr>
+          <p:cNvPr id="21" name="표시 유통 5"/>
+          <p:cNvSpPr/>
+          <p:nvPr/>
+        </p:nvSpPr>
+        <p:spPr>
+          <a:xfrm>
+            <a:off x="11283696" y="2611265"/>
+            <a:ext cx="274320" cy="274320"/>
+          </a:xfrm>
+          <a:prstGeom prst="ellipse">
+            <a:avLst/>
+          </a:prstGeom>
+          <a:solidFill>
+            <a:srgbClr val="1F4E9A"/>
+          </a:solidFill>
+          <a:ln w="15875">
+            <a:solidFill>
+              <a:srgbClr val="1F4E9A"/>
+            </a:solidFill>
+            <a:prstDash val="solid"/>
+          </a:ln>
+        </p:spPr>
+      </p:sp>
+      <p:sp>
+        <p:nvSpPr>
+          <p:cNvPr id="22" name="행 구분 2"/>
+          <p:cNvSpPr/>
+          <p:nvPr/>
+        </p:nvSpPr>
+        <p:spPr>
+          <a:xfrm>
+            <a:off x="365760" y="3027970"/>
+            <a:ext cx="11457432" cy="0"/>
+          </a:xfrm>
+          <a:prstGeom prst="line">
+            <a:avLst/>
+          </a:prstGeom>
+          <a:noFill/>
+          <a:ln w="12700">
+            <a:solidFill>
+              <a:srgbClr val="A6ADB8"/>
+            </a:solidFill>
+            <a:prstDash val="solid"/>
+          </a:ln>
+        </p:spPr>
+      </p:sp>
+      <p:sp>
+        <p:nvSpPr>
+          <p:cNvPr id="23" name="행 라벨 식품·외식"/>
+          <p:cNvSpPr txBox="1"/>
+          <p:nvPr/>
+        </p:nvSpPr>
+        <p:spPr>
+          <a:xfrm>
+            <a:off x="365760" y="3064546"/>
+            <a:ext cx="1417320" cy="485938"/>
+          </a:xfrm>
+          <a:prstGeom prst="rect">
+            <a:avLst/>
+          </a:prstGeom>
+          <a:solidFill>
+            <a:schemeClr val="tx2"/>
+          </a:solidFill>
+          <a:ln/>
+        </p:spPr>
+        <p:txBody>
+          <a:bodyPr wrap="square" lIns="0" tIns="0" rIns="0" bIns="0" rtlCol="0" anchor="ctr"/>
+          <a:lstStyle/>
+          <a:p>
+            <a:pPr algn="ctr" indent="0" marL="0">
+              <a:buNone/>
+            </a:pPr>
+            <a:r>
+              <a:rPr lang="en-US" sz="1300" b="1" dirty="0">
+                <a:solidFill>
+                  <a:schemeClr val="bg1"/>
+                </a:solidFill>
+              </a:rPr>
+              <a:t>식품·외식</a:t>
+            </a:r>
+            <a:endParaRPr lang="en-US" sz="1300" dirty="0"/>
+          </a:p>
+          <a:p>
+            <a:pPr algn="ctr" indent="0" marL="0">
+              <a:buNone/>
+            </a:pPr>
+            <a:r>
+              <a:rPr lang="en-US" sz="1100" b="1" dirty="0">
+                <a:solidFill>
+                  <a:schemeClr val="bg1"/>
+                </a:solidFill>
+              </a:rPr>
+              <a:t>(3개사)</a:t>
+            </a:r>
+            <a:endParaRPr lang="en-US" sz="1300" dirty="0"/>
+          </a:p>
+        </p:txBody>
+      </p:sp>
+      <p:sp>
+        <p:nvSpPr>
+          <p:cNvPr id="24" name="Text 22"/>
+          <p:cNvSpPr txBox="1"/>
+          <p:nvPr/>
+        </p:nvSpPr>
+        <p:spPr>
+          <a:xfrm>
+            <a:off x="1874520" y="3046258"/>
+            <a:ext cx="5715000" cy="522514"/>
+          </a:xfrm>
+          <a:prstGeom prst="rect">
+            <a:avLst/>
+          </a:prstGeom>
+          <a:noFill/>
+          <a:ln/>
+        </p:spPr>
+        <p:txBody>
+          <a:bodyPr wrap="square" lIns="0" tIns="0" rIns="0" bIns="0" rtlCol="0" anchor="ctr"/>
+          <a:lstStyle/>
+          <a:p>
+            <a:pPr marL="342900" indent="-342900">
+              <a:spcAft>
+                <a:spcPts val="200"/>
+              </a:spcAft>
+              <a:buSzPct val="100000"/>
+              <a:buChar char="▶"/>
+            </a:pPr>
+            <a:r>
+              <a:rPr lang="en-US" sz="1050" dirty="0">
+                <a:solidFill>
+                  <a:schemeClr val="tx1"/>
+                </a:solidFill>
+              </a:rPr>
+              <a:t>웰푸드·칠성·GRS: 그룹사 AI 컨설팅 ('24 과제점검 및 AI 추진과제 도출)</a:t>
+            </a:r>
+            <a:endParaRPr lang="en-US" sz="1050" dirty="0"/>
+          </a:p>
+          <a:p>
+            <a:pPr marL="342900" indent="-342900">
+              <a:spcAft>
+                <a:spcPts val="200"/>
+              </a:spcAft>
+              <a:buSzPct val="100000"/>
+              <a:buChar char="▶"/>
+            </a:pPr>
+            <a:r>
+              <a:rPr lang="en-US" sz="1050" dirty="0">
+                <a:solidFill>
+                  <a:schemeClr val="tx1"/>
+                </a:solidFill>
+              </a:rPr>
+              <a:t>GRS 임원 대상 AI 리터러시 및 실습 교육 外</a:t>
+            </a:r>
+            <a:endParaRPr lang="en-US" sz="1050" dirty="0"/>
+          </a:p>
+        </p:txBody>
+      </p:sp>
+      <p:sp>
+        <p:nvSpPr>
+          <p:cNvPr id="25" name="표시 식품·외식 1"/>
+          <p:cNvSpPr/>
+          <p:nvPr/>
+        </p:nvSpPr>
+        <p:spPr>
+          <a:xfrm>
+            <a:off x="7918704" y="3170355"/>
+            <a:ext cx="274320" cy="274320"/>
+          </a:xfrm>
+          <a:prstGeom prst="ellipse">
+            <a:avLst/>
+          </a:prstGeom>
+          <a:solidFill>
+            <a:srgbClr val="1F4E9A"/>
+          </a:solidFill>
+          <a:ln w="15875">
+            <a:solidFill>
+              <a:srgbClr val="1F4E9A"/>
+            </a:solidFill>
+            <a:prstDash val="solid"/>
+          </a:ln>
+        </p:spPr>
+      </p:sp>
+      <p:sp>
+        <p:nvSpPr>
+          <p:cNvPr id="26" name="표시 식품·외식 2"/>
+          <p:cNvSpPr/>
+          <p:nvPr/>
+        </p:nvSpPr>
+        <p:spPr>
+          <a:xfrm>
+            <a:off x="8759952" y="3170355"/>
+            <a:ext cx="274320" cy="274320"/>
+          </a:xfrm>
+          <a:prstGeom prst="ellipse">
+            <a:avLst/>
+          </a:prstGeom>
+          <a:solidFill>
+            <a:srgbClr val="FFFFFF"/>
+          </a:solidFill>
+          <a:ln w="15875">
+            <a:solidFill>
+              <a:srgbClr val="8A94A6"/>
+            </a:solidFill>
+            <a:prstDash val="solid"/>
+          </a:ln>
+        </p:spPr>
+      </p:sp>
+      <p:sp>
+        <p:nvSpPr>
+          <p:cNvPr id="27" name="표시 식품·외식 3"/>
+          <p:cNvSpPr/>
+          <p:nvPr/>
+        </p:nvSpPr>
+        <p:spPr>
+          <a:xfrm>
+            <a:off x="9601200" y="3170355"/>
+            <a:ext cx="274320" cy="274320"/>
+          </a:xfrm>
+          <a:prstGeom prst="ellipse">
+            <a:avLst/>
+          </a:prstGeom>
+          <a:solidFill>
+            <a:srgbClr val="FFFFFF"/>
+          </a:solidFill>
+          <a:ln w="15875">
+            <a:solidFill>
+              <a:srgbClr val="8A94A6"/>
+            </a:solidFill>
+            <a:prstDash val="solid"/>
+          </a:ln>
+        </p:spPr>
+      </p:sp>
+      <p:sp>
+        <p:nvSpPr>
+          <p:cNvPr id="28" name="표시 식품·외식 4"/>
+          <p:cNvSpPr/>
+          <p:nvPr/>
+        </p:nvSpPr>
+        <p:spPr>
+          <a:xfrm>
+            <a:off x="10442448" y="3170355"/>
+            <a:ext cx="274320" cy="274320"/>
+          </a:xfrm>
+          <a:prstGeom prst="ellipse">
+            <a:avLst/>
+          </a:prstGeom>
+          <a:solidFill>
+            <a:srgbClr val="1F4E9A"/>
+          </a:solidFill>
+          <a:ln w="15875">
+            <a:solidFill>
+              <a:srgbClr val="1F4E9A"/>
+            </a:solidFill>
+            <a:prstDash val="solid"/>
+          </a:ln>
+        </p:spPr>
+      </p:sp>
+      <p:sp>
+        <p:nvSpPr>
+          <p:cNvPr id="29" name="표시 식품·외식 5"/>
+          <p:cNvSpPr/>
+          <p:nvPr/>
+        </p:nvSpPr>
+        <p:spPr>
+          <a:xfrm>
+            <a:off x="11283696" y="3170355"/>
+            <a:ext cx="274320" cy="274320"/>
+          </a:xfrm>
+          <a:prstGeom prst="ellipse">
+            <a:avLst/>
+          </a:prstGeom>
+          <a:solidFill>
+            <a:srgbClr val="FFFFFF"/>
+          </a:solidFill>
+          <a:ln w="15875">
+            <a:solidFill>
+              <a:srgbClr val="8A94A6"/>
+            </a:solidFill>
+            <a:prstDash val="solid"/>
+          </a:ln>
+        </p:spPr>
+      </p:sp>
+      <p:sp>
+        <p:nvSpPr>
+          <p:cNvPr id="30" name="행 구분 3"/>
+          <p:cNvSpPr/>
+          <p:nvPr/>
+        </p:nvSpPr>
+        <p:spPr>
+          <a:xfrm>
+            <a:off x="365760" y="3587061"/>
+            <a:ext cx="11457432" cy="0"/>
+          </a:xfrm>
+          <a:prstGeom prst="line">
+            <a:avLst/>
+          </a:prstGeom>
+          <a:noFill/>
+          <a:ln w="12700">
+            <a:solidFill>
+              <a:srgbClr val="A6ADB8"/>
+            </a:solidFill>
+            <a:prstDash val="solid"/>
+          </a:ln>
+        </p:spPr>
+      </p:sp>
+      <p:sp>
+        <p:nvSpPr>
+          <p:cNvPr id="31" name="행 라벨 호텔·문화"/>
+          <p:cNvSpPr txBox="1"/>
+          <p:nvPr/>
+        </p:nvSpPr>
+        <p:spPr>
+          <a:xfrm>
+            <a:off x="365760" y="3623637"/>
+            <a:ext cx="1417320" cy="485938"/>
+          </a:xfrm>
+          <a:prstGeom prst="rect">
+            <a:avLst/>
+          </a:prstGeom>
+          <a:solidFill>
+            <a:schemeClr val="tx2"/>
+          </a:solidFill>
+          <a:ln/>
+        </p:spPr>
+        <p:txBody>
+          <a:bodyPr wrap="square" lIns="0" tIns="0" rIns="0" bIns="0" rtlCol="0" anchor="ctr"/>
+          <a:lstStyle/>
+          <a:p>
+            <a:pPr algn="ctr" indent="0" marL="0">
+              <a:buNone/>
+            </a:pPr>
+            <a:r>
+              <a:rPr lang="en-US" sz="1300" b="1" dirty="0">
+                <a:solidFill>
+                  <a:schemeClr val="bg1"/>
+                </a:solidFill>
+              </a:rPr>
+              <a:t>호텔·문화</a:t>
+            </a:r>
+            <a:endParaRPr lang="en-US" sz="1300" dirty="0"/>
+          </a:p>
+          <a:p>
+            <a:pPr algn="ctr" indent="0" marL="0">
+              <a:buNone/>
+            </a:pPr>
+            <a:r>
+              <a:rPr lang="en-US" sz="1100" b="1" dirty="0">
+                <a:solidFill>
+                  <a:schemeClr val="bg1"/>
+                </a:solidFill>
+              </a:rPr>
+              <a:t>(2개사)</a:t>
+            </a:r>
+            <a:endParaRPr lang="en-US" sz="1300" dirty="0"/>
+          </a:p>
+        </p:txBody>
+      </p:sp>
+      <p:sp>
+        <p:nvSpPr>
+          <p:cNvPr id="32" name="Text 30"/>
+          <p:cNvSpPr txBox="1"/>
+          <p:nvPr/>
+        </p:nvSpPr>
+        <p:spPr>
+          <a:xfrm>
+            <a:off x="1874520" y="3605349"/>
+            <a:ext cx="5715000" cy="522514"/>
+          </a:xfrm>
+          <a:prstGeom prst="rect">
+            <a:avLst/>
+          </a:prstGeom>
+          <a:noFill/>
+          <a:ln/>
+        </p:spPr>
+        <p:txBody>
+          <a:bodyPr wrap="square" lIns="0" tIns="0" rIns="0" bIns="0" rtlCol="0" anchor="ctr"/>
+          <a:lstStyle/>
+          <a:p>
+            <a:pPr marL="342900" indent="-342900">
+              <a:spcAft>
+                <a:spcPts val="200"/>
+              </a:spcAft>
+              <a:buSzPct val="100000"/>
+              <a:buChar char="▶"/>
+            </a:pPr>
+            <a:r>
+              <a:rPr lang="en-US" sz="1050" dirty="0">
+                <a:solidFill>
+                  <a:schemeClr val="tx1"/>
+                </a:solidFill>
+              </a:rPr>
+              <a:t>호텔: AI 추진과제 도출 → AI기반 객실 요금 최적화 구현 방안 수립·Pilot</a:t>
+            </a:r>
+            <a:endParaRPr lang="en-US" sz="1050" dirty="0"/>
+          </a:p>
+          <a:p>
+            <a:pPr marL="342900" indent="-342900">
+              <a:spcAft>
+                <a:spcPts val="200"/>
+              </a:spcAft>
+              <a:buSzPct val="100000"/>
+              <a:buChar char="▶"/>
+            </a:pPr>
+            <a:r>
+              <a:rPr lang="en-US" sz="1050" dirty="0">
+                <a:solidFill>
+                  <a:schemeClr val="tx1"/>
+                </a:solidFill>
+              </a:rPr>
+              <a:t>호텔 객실요금최적화시스템 구축(대표이사 보고 中), 컬처웍스 AI 과제 도출 外</a:t>
+            </a:r>
+            <a:endParaRPr lang="en-US" sz="1050" dirty="0"/>
+          </a:p>
+        </p:txBody>
+      </p:sp>
+      <p:sp>
+        <p:nvSpPr>
+          <p:cNvPr id="33" name="표시 호텔·문화 1"/>
+          <p:cNvSpPr/>
+          <p:nvPr/>
+        </p:nvSpPr>
+        <p:spPr>
+          <a:xfrm>
+            <a:off x="7918704" y="3729446"/>
+            <a:ext cx="274320" cy="274320"/>
+          </a:xfrm>
+          <a:prstGeom prst="ellipse">
+            <a:avLst/>
+          </a:prstGeom>
+          <a:solidFill>
+            <a:srgbClr val="1F4E9A"/>
+          </a:solidFill>
+          <a:ln w="15875">
+            <a:solidFill>
+              <a:srgbClr val="1F4E9A"/>
+            </a:solidFill>
+            <a:prstDash val="solid"/>
+          </a:ln>
+        </p:spPr>
+      </p:sp>
+      <p:sp>
+        <p:nvSpPr>
+          <p:cNvPr id="34" name="표시 호텔·문화 2"/>
+          <p:cNvSpPr/>
+          <p:nvPr/>
+        </p:nvSpPr>
+        <p:spPr>
+          <a:xfrm>
+            <a:off x="8759952" y="3729446"/>
+            <a:ext cx="274320" cy="274320"/>
+          </a:xfrm>
+          <a:prstGeom prst="ellipse">
+            <a:avLst/>
+          </a:prstGeom>
+          <a:solidFill>
+            <a:srgbClr val="FFFFFF"/>
+          </a:solidFill>
+          <a:ln w="15875">
+            <a:solidFill>
+              <a:srgbClr val="8A94A6"/>
+            </a:solidFill>
+            <a:prstDash val="solid"/>
+          </a:ln>
+        </p:spPr>
+      </p:sp>
+      <p:sp>
+        <p:nvSpPr>
+          <p:cNvPr id="35" name="표시 호텔·문화 3"/>
+          <p:cNvSpPr/>
+          <p:nvPr/>
+        </p:nvSpPr>
+        <p:spPr>
+          <a:xfrm>
+            <a:off x="9601200" y="3729446"/>
+            <a:ext cx="274320" cy="274320"/>
+          </a:xfrm>
+          <a:prstGeom prst="ellipse">
+            <a:avLst/>
+          </a:prstGeom>
+          <a:solidFill>
+            <a:srgbClr val="1F4E9A"/>
+          </a:solidFill>
+          <a:ln w="15875">
+            <a:solidFill>
+              <a:srgbClr val="1F4E9A"/>
+            </a:solidFill>
+            <a:prstDash val="solid"/>
+          </a:ln>
+        </p:spPr>
+      </p:sp>
+      <p:sp>
+        <p:nvSpPr>
+          <p:cNvPr id="36" name="표시 호텔·문화 4"/>
+          <p:cNvSpPr/>
+          <p:nvPr/>
+        </p:nvSpPr>
+        <p:spPr>
+          <a:xfrm>
+            <a:off x="10442448" y="3729446"/>
+            <a:ext cx="274320" cy="274320"/>
+          </a:xfrm>
+          <a:prstGeom prst="ellipse">
+            <a:avLst/>
+          </a:prstGeom>
+          <a:solidFill>
+            <a:srgbClr val="FFFFFF"/>
+          </a:solidFill>
+          <a:ln w="15875">
+            <a:solidFill>
+              <a:srgbClr val="8A94A6"/>
+            </a:solidFill>
+            <a:prstDash val="solid"/>
+          </a:ln>
+        </p:spPr>
+      </p:sp>
+      <p:sp>
+        <p:nvSpPr>
+          <p:cNvPr id="37" name="표시 호텔·문화 5"/>
+          <p:cNvSpPr/>
+          <p:nvPr/>
+        </p:nvSpPr>
+        <p:spPr>
+          <a:xfrm>
+            <a:off x="11283696" y="3729446"/>
+            <a:ext cx="274320" cy="274320"/>
+          </a:xfrm>
+          <a:prstGeom prst="ellipse">
+            <a:avLst/>
+          </a:prstGeom>
+          <a:solidFill>
+            <a:srgbClr val="1F4E9A"/>
+          </a:solidFill>
+          <a:ln w="15875">
+            <a:solidFill>
+              <a:srgbClr val="1F4E9A"/>
+            </a:solidFill>
+            <a:prstDash val="solid"/>
+          </a:ln>
+        </p:spPr>
+      </p:sp>
+      <p:sp>
+        <p:nvSpPr>
+          <p:cNvPr id="38" name="행 구분 4"/>
+          <p:cNvSpPr/>
+          <p:nvPr/>
+        </p:nvSpPr>
+        <p:spPr>
+          <a:xfrm>
+            <a:off x="365760" y="4146151"/>
+            <a:ext cx="11457432" cy="0"/>
+          </a:xfrm>
+          <a:prstGeom prst="line">
+            <a:avLst/>
+          </a:prstGeom>
+          <a:noFill/>
+          <a:ln w="12700">
+            <a:solidFill>
+              <a:srgbClr val="A6ADB8"/>
+            </a:solidFill>
+            <a:prstDash val="solid"/>
+          </a:ln>
+        </p:spPr>
+      </p:sp>
+      <p:sp>
+        <p:nvSpPr>
+          <p:cNvPr id="39" name="행 라벨 화학·건설·물류"/>
+          <p:cNvSpPr txBox="1"/>
+          <p:nvPr/>
+        </p:nvSpPr>
+        <p:spPr>
+          <a:xfrm>
+            <a:off x="365760" y="4182727"/>
+            <a:ext cx="1417320" cy="485938"/>
+          </a:xfrm>
+          <a:prstGeom prst="rect">
+            <a:avLst/>
+          </a:prstGeom>
+          <a:solidFill>
+            <a:schemeClr val="tx2"/>
+          </a:solidFill>
+          <a:ln/>
+        </p:spPr>
+        <p:txBody>
+          <a:bodyPr wrap="square" lIns="0" tIns="0" rIns="0" bIns="0" rtlCol="0" anchor="ctr"/>
+          <a:lstStyle/>
+          <a:p>
+            <a:pPr algn="ctr" indent="0" marL="0">
+              <a:buNone/>
+            </a:pPr>
+            <a:r>
+              <a:rPr lang="en-US" sz="1300" b="1" dirty="0">
+                <a:solidFill>
+                  <a:schemeClr val="bg1"/>
+                </a:solidFill>
+              </a:rPr>
+              <a:t>화학·건설·물류</a:t>
+            </a:r>
+            <a:endParaRPr lang="en-US" sz="1300" dirty="0"/>
+          </a:p>
+          <a:p>
+            <a:pPr algn="ctr" indent="0" marL="0">
+              <a:buNone/>
+            </a:pPr>
+            <a:r>
+              <a:rPr lang="en-US" sz="1100" b="1" dirty="0">
+                <a:solidFill>
+                  <a:schemeClr val="bg1"/>
+                </a:solidFill>
+              </a:rPr>
+              <a:t>(5개사)</a:t>
+            </a:r>
+            <a:endParaRPr lang="en-US" sz="1300" dirty="0"/>
+          </a:p>
+        </p:txBody>
+      </p:sp>
+      <p:sp>
+        <p:nvSpPr>
+          <p:cNvPr id="40" name="Text 38"/>
+          <p:cNvSpPr txBox="1"/>
+          <p:nvPr/>
+        </p:nvSpPr>
+        <p:spPr>
+          <a:xfrm>
+            <a:off x="1874520" y="4164439"/>
+            <a:ext cx="5715000" cy="522514"/>
+          </a:xfrm>
+          <a:prstGeom prst="rect">
+            <a:avLst/>
+          </a:prstGeom>
+          <a:noFill/>
+          <a:ln/>
+        </p:spPr>
+        <p:txBody>
+          <a:bodyPr wrap="square" lIns="0" tIns="0" rIns="0" bIns="0" rtlCol="0" anchor="ctr"/>
+          <a:lstStyle/>
+          <a:p>
+            <a:pPr marL="342900" indent="-342900">
+              <a:spcAft>
+                <a:spcPts val="200"/>
+              </a:spcAft>
+              <a:buSzPct val="100000"/>
+              <a:buChar char="▶"/>
+            </a:pPr>
+            <a:r>
+              <a:rPr lang="en-US" sz="1050" dirty="0">
+                <a:solidFill>
+                  <a:schemeClr val="tx1"/>
+                </a:solidFill>
+              </a:rPr>
+              <a:t>건설: SAP S4HANA 구축 사전진단 및 AI 추진과제 도출, 케미칼·LGL 과제 도출</a:t>
+            </a:r>
+            <a:endParaRPr lang="en-US" sz="1050" dirty="0"/>
+          </a:p>
+          <a:p>
+            <a:pPr marL="342900" indent="-342900">
+              <a:spcAft>
+                <a:spcPts val="200"/>
+              </a:spcAft>
+              <a:buSzPct val="100000"/>
+              <a:buChar char="▶"/>
+            </a:pPr>
+            <a:r>
+              <a:rPr lang="en-US" sz="1050" dirty="0">
+                <a:solidFill>
+                  <a:schemeClr val="tx1"/>
+                </a:solidFill>
+              </a:rPr>
+              <a:t>물산: AI 전략·과제 도출 → AI 문서탐색 플랫폼('27), 알미늄 임원 AI 교육 外</a:t>
+            </a:r>
+            <a:endParaRPr lang="en-US" sz="1050" dirty="0"/>
+          </a:p>
+        </p:txBody>
+      </p:sp>
+      <p:sp>
+        <p:nvSpPr>
+          <p:cNvPr id="41" name="표시 화학·건설·물류 1"/>
+          <p:cNvSpPr/>
+          <p:nvPr/>
+        </p:nvSpPr>
+        <p:spPr>
+          <a:xfrm>
+            <a:off x="7918704" y="4288536"/>
+            <a:ext cx="274320" cy="274320"/>
+          </a:xfrm>
+          <a:prstGeom prst="ellipse">
+            <a:avLst/>
+          </a:prstGeom>
+          <a:solidFill>
+            <a:srgbClr val="1F4E9A"/>
+          </a:solidFill>
+          <a:ln w="15875">
+            <a:solidFill>
+              <a:srgbClr val="1F4E9A"/>
+            </a:solidFill>
+            <a:prstDash val="solid"/>
+          </a:ln>
+        </p:spPr>
+      </p:sp>
+      <p:sp>
+        <p:nvSpPr>
+          <p:cNvPr id="42" name="표시 화학·건설·물류 2"/>
+          <p:cNvSpPr/>
+          <p:nvPr/>
+        </p:nvSpPr>
+        <p:spPr>
+          <a:xfrm>
+            <a:off x="8759952" y="4288536"/>
+            <a:ext cx="274320" cy="274320"/>
+          </a:xfrm>
+          <a:prstGeom prst="ellipse">
+            <a:avLst/>
+          </a:prstGeom>
+          <a:solidFill>
+            <a:srgbClr val="1F4E9A"/>
+          </a:solidFill>
+          <a:ln w="15875">
+            <a:solidFill>
+              <a:srgbClr val="1F4E9A"/>
+            </a:solidFill>
+            <a:prstDash val="solid"/>
+          </a:ln>
+        </p:spPr>
+      </p:sp>
+      <p:sp>
+        <p:nvSpPr>
+          <p:cNvPr id="43" name="표시 화학·건설·물류 3"/>
+          <p:cNvSpPr/>
+          <p:nvPr/>
+        </p:nvSpPr>
+        <p:spPr>
+          <a:xfrm>
+            <a:off x="9601200" y="4288536"/>
+            <a:ext cx="274320" cy="274320"/>
+          </a:xfrm>
+          <a:prstGeom prst="ellipse">
+            <a:avLst/>
+          </a:prstGeom>
+          <a:solidFill>
+            <a:srgbClr val="FFFFFF"/>
+          </a:solidFill>
+          <a:ln w="15875">
+            <a:solidFill>
+              <a:srgbClr val="8A94A6"/>
+            </a:solidFill>
+            <a:prstDash val="solid"/>
+          </a:ln>
+        </p:spPr>
+      </p:sp>
+      <p:sp>
+        <p:nvSpPr>
+          <p:cNvPr id="44" name="표시 화학·건설·물류 4"/>
+          <p:cNvSpPr/>
+          <p:nvPr/>
+        </p:nvSpPr>
+        <p:spPr>
+          <a:xfrm>
+            <a:off x="10442448" y="4288536"/>
+            <a:ext cx="274320" cy="274320"/>
+          </a:xfrm>
+          <a:prstGeom prst="ellipse">
+            <a:avLst/>
+          </a:prstGeom>
+          <a:solidFill>
+            <a:srgbClr val="1F4E9A"/>
+          </a:solidFill>
+          <a:ln w="15875">
+            <a:solidFill>
+              <a:srgbClr val="1F4E9A"/>
+            </a:solidFill>
+            <a:prstDash val="solid"/>
+          </a:ln>
+        </p:spPr>
+      </p:sp>
+      <p:sp>
+        <p:nvSpPr>
+          <p:cNvPr id="45" name="표시 화학·건설·물류 5"/>
+          <p:cNvSpPr/>
+          <p:nvPr/>
+        </p:nvSpPr>
+        <p:spPr>
+          <a:xfrm>
+            <a:off x="11283696" y="4288536"/>
+            <a:ext cx="274320" cy="274320"/>
+          </a:xfrm>
+          <a:prstGeom prst="ellipse">
+            <a:avLst/>
+          </a:prstGeom>
+          <a:solidFill>
+            <a:srgbClr val="1F4E9A"/>
+          </a:solidFill>
+          <a:ln w="15875">
+            <a:solidFill>
+              <a:srgbClr val="1F4E9A"/>
+            </a:solidFill>
+            <a:prstDash val="solid"/>
+          </a:ln>
+        </p:spPr>
+      </p:sp>
+      <p:sp>
+        <p:nvSpPr>
+          <p:cNvPr id="46" name="행 구분 5"/>
+          <p:cNvSpPr/>
+          <p:nvPr/>
+        </p:nvSpPr>
+        <p:spPr>
+          <a:xfrm>
+            <a:off x="365760" y="4705241"/>
+            <a:ext cx="11457432" cy="0"/>
+          </a:xfrm>
+          <a:prstGeom prst="line">
+            <a:avLst/>
+          </a:prstGeom>
+          <a:noFill/>
+          <a:ln w="12700">
+            <a:solidFill>
+              <a:srgbClr val="A6ADB8"/>
+            </a:solidFill>
+            <a:prstDash val="solid"/>
+          </a:ln>
+        </p:spPr>
+      </p:sp>
+      <p:sp>
+        <p:nvSpPr>
+          <p:cNvPr id="47" name="행 라벨 금융"/>
+          <p:cNvSpPr txBox="1"/>
+          <p:nvPr/>
+        </p:nvSpPr>
+        <p:spPr>
+          <a:xfrm>
+            <a:off x="365760" y="4741817"/>
+            <a:ext cx="1417320" cy="485938"/>
+          </a:xfrm>
+          <a:prstGeom prst="rect">
+            <a:avLst/>
+          </a:prstGeom>
+          <a:solidFill>
+            <a:schemeClr val="tx2"/>
+          </a:solidFill>
+          <a:ln/>
+        </p:spPr>
+        <p:txBody>
+          <a:bodyPr wrap="square" lIns="0" tIns="0" rIns="0" bIns="0" rtlCol="0" anchor="ctr"/>
+          <a:lstStyle/>
+          <a:p>
+            <a:pPr algn="ctr" indent="0" marL="0">
+              <a:buNone/>
+            </a:pPr>
+            <a:r>
+              <a:rPr lang="en-US" sz="1300" b="1" dirty="0">
+                <a:solidFill>
+                  <a:schemeClr val="bg1"/>
+                </a:solidFill>
+              </a:rPr>
+              <a:t>금융</a:t>
+            </a:r>
+            <a:endParaRPr lang="en-US" sz="1300" dirty="0"/>
+          </a:p>
+          <a:p>
+            <a:pPr algn="ctr" indent="0" marL="0">
+              <a:buNone/>
+            </a:pPr>
+            <a:r>
+              <a:rPr lang="en-US" sz="1100" b="1" dirty="0">
+                <a:solidFill>
+                  <a:schemeClr val="bg1"/>
+                </a:solidFill>
+              </a:rPr>
+              <a:t>(2개사)</a:t>
+            </a:r>
+            <a:endParaRPr lang="en-US" sz="1300" dirty="0"/>
+          </a:p>
+        </p:txBody>
+      </p:sp>
+      <p:sp>
+        <p:nvSpPr>
+          <p:cNvPr id="48" name="Text 46"/>
+          <p:cNvSpPr txBox="1"/>
+          <p:nvPr/>
+        </p:nvSpPr>
+        <p:spPr>
+          <a:xfrm>
+            <a:off x="1874520" y="4723529"/>
+            <a:ext cx="5715000" cy="522514"/>
+          </a:xfrm>
+          <a:prstGeom prst="rect">
+            <a:avLst/>
+          </a:prstGeom>
+          <a:noFill/>
+          <a:ln/>
+        </p:spPr>
+        <p:txBody>
+          <a:bodyPr wrap="square" lIns="0" tIns="0" rIns="0" bIns="0" rtlCol="0" anchor="ctr"/>
+          <a:lstStyle/>
+          <a:p>
+            <a:pPr marL="342900" indent="-342900">
+              <a:spcAft>
+                <a:spcPts val="200"/>
+              </a:spcAft>
+              <a:buSzPct val="100000"/>
+              <a:buChar char="▶"/>
+            </a:pPr>
+            <a:r>
+              <a:rPr lang="en-US" sz="1050" dirty="0">
+                <a:solidFill>
+                  <a:schemeClr val="tx1"/>
+                </a:solidFill>
+              </a:rPr>
+              <a:t>캐피탈: 본원적 AI 과제 발굴 컨설팅, 임원 대상 AI 리터러시 및 실습 교육</a:t>
+            </a:r>
+            <a:endParaRPr lang="en-US" sz="1050" dirty="0"/>
+          </a:p>
+          <a:p>
+            <a:pPr marL="342900" indent="-342900">
+              <a:spcAft>
+                <a:spcPts val="200"/>
+              </a:spcAft>
+              <a:buSzPct val="100000"/>
+              <a:buChar char="▶"/>
+            </a:pPr>
+            <a:r>
+              <a:rPr lang="en-US" sz="1050" dirty="0">
+                <a:solidFill>
+                  <a:schemeClr val="tx1"/>
+                </a:solidFill>
+              </a:rPr>
+              <a:t>군인공제회(대외): 차세대 시스템 구축 AI 전략 수립 및 과제 도출 外</a:t>
+            </a:r>
+            <a:endParaRPr lang="en-US" sz="1050" dirty="0"/>
+          </a:p>
+        </p:txBody>
+      </p:sp>
+      <p:sp>
+        <p:nvSpPr>
+          <p:cNvPr id="49" name="표시 금융 1"/>
+          <p:cNvSpPr/>
+          <p:nvPr/>
+        </p:nvSpPr>
+        <p:spPr>
+          <a:xfrm>
+            <a:off x="7918704" y="4847626"/>
+            <a:ext cx="274320" cy="274320"/>
+          </a:xfrm>
+          <a:prstGeom prst="ellipse">
+            <a:avLst/>
+          </a:prstGeom>
+          <a:solidFill>
+            <a:srgbClr val="1F4E9A"/>
+          </a:solidFill>
+          <a:ln w="15875">
+            <a:solidFill>
+              <a:srgbClr val="1F4E9A"/>
+            </a:solidFill>
+            <a:prstDash val="solid"/>
+          </a:ln>
+        </p:spPr>
+      </p:sp>
+      <p:sp>
+        <p:nvSpPr>
+          <p:cNvPr id="50" name="표시 금융 2"/>
+          <p:cNvSpPr/>
+          <p:nvPr/>
+        </p:nvSpPr>
+        <p:spPr>
+          <a:xfrm>
+            <a:off x="8759952" y="4847626"/>
+            <a:ext cx="274320" cy="274320"/>
+          </a:xfrm>
+          <a:prstGeom prst="ellipse">
+            <a:avLst/>
+          </a:prstGeom>
+          <a:solidFill>
+            <a:srgbClr val="FFFFFF"/>
+          </a:solidFill>
+          <a:ln w="15875">
+            <a:solidFill>
+              <a:srgbClr val="8A94A6"/>
+            </a:solidFill>
+            <a:prstDash val="solid"/>
+          </a:ln>
+        </p:spPr>
+      </p:sp>
+      <p:sp>
+        <p:nvSpPr>
+          <p:cNvPr id="51" name="표시 금융 3"/>
+          <p:cNvSpPr/>
+          <p:nvPr/>
+        </p:nvSpPr>
+        <p:spPr>
+          <a:xfrm>
+            <a:off x="9601200" y="4847626"/>
+            <a:ext cx="274320" cy="274320"/>
+          </a:xfrm>
+          <a:prstGeom prst="ellipse">
+            <a:avLst/>
+          </a:prstGeom>
+          <a:solidFill>
+            <a:srgbClr val="FFFFFF"/>
+          </a:solidFill>
+          <a:ln w="15875">
+            <a:solidFill>
+              <a:srgbClr val="8A94A6"/>
+            </a:solidFill>
+            <a:prstDash val="solid"/>
+          </a:ln>
+        </p:spPr>
+      </p:sp>
+      <p:sp>
+        <p:nvSpPr>
+          <p:cNvPr id="52" name="표시 금융 4"/>
+          <p:cNvSpPr/>
+          <p:nvPr/>
+        </p:nvSpPr>
+        <p:spPr>
+          <a:xfrm>
+            <a:off x="10442448" y="4847626"/>
+            <a:ext cx="274320" cy="274320"/>
+          </a:xfrm>
+          <a:prstGeom prst="ellipse">
+            <a:avLst/>
+          </a:prstGeom>
+          <a:solidFill>
+            <a:srgbClr val="1F4E9A"/>
+          </a:solidFill>
+          <a:ln w="15875">
+            <a:solidFill>
+              <a:srgbClr val="1F4E9A"/>
+            </a:solidFill>
+            <a:prstDash val="solid"/>
+          </a:ln>
+        </p:spPr>
+      </p:sp>
+      <p:sp>
+        <p:nvSpPr>
+          <p:cNvPr id="53" name="표시 금융 5"/>
+          <p:cNvSpPr/>
+          <p:nvPr/>
+        </p:nvSpPr>
+        <p:spPr>
+          <a:xfrm>
+            <a:off x="11283696" y="4847626"/>
+            <a:ext cx="274320" cy="274320"/>
+          </a:xfrm>
+          <a:prstGeom prst="ellipse">
+            <a:avLst/>
+          </a:prstGeom>
+          <a:solidFill>
+            <a:srgbClr val="FFFFFF"/>
+          </a:solidFill>
+          <a:ln w="15875">
+            <a:solidFill>
+              <a:srgbClr val="8A94A6"/>
+            </a:solidFill>
+            <a:prstDash val="solid"/>
+          </a:ln>
+        </p:spPr>
+      </p:sp>
+      <p:sp>
+        <p:nvSpPr>
+          <p:cNvPr id="54" name="행 구분 6"/>
+          <p:cNvSpPr/>
+          <p:nvPr/>
+        </p:nvSpPr>
+        <p:spPr>
+          <a:xfrm>
+            <a:off x="365760" y="5264331"/>
+            <a:ext cx="11457432" cy="0"/>
+          </a:xfrm>
+          <a:prstGeom prst="line">
+            <a:avLst/>
+          </a:prstGeom>
+          <a:noFill/>
+          <a:ln w="12700">
+            <a:solidFill>
+              <a:srgbClr val="A6ADB8"/>
+            </a:solidFill>
+            <a:prstDash val="solid"/>
+          </a:ln>
+        </p:spPr>
+      </p:sp>
+      <p:sp>
+        <p:nvSpPr>
+          <p:cNvPr id="55" name="행 라벨 공공·교통"/>
+          <p:cNvSpPr txBox="1"/>
+          <p:nvPr/>
+        </p:nvSpPr>
+        <p:spPr>
+          <a:xfrm>
+            <a:off x="365760" y="5300907"/>
+            <a:ext cx="1417320" cy="485938"/>
+          </a:xfrm>
+          <a:prstGeom prst="rect">
+            <a:avLst/>
+          </a:prstGeom>
+          <a:solidFill>
+            <a:schemeClr val="tx2"/>
+          </a:solidFill>
+          <a:ln/>
+        </p:spPr>
+        <p:txBody>
+          <a:bodyPr wrap="square" lIns="0" tIns="0" rIns="0" bIns="0" rtlCol="0" anchor="ctr"/>
+          <a:lstStyle/>
+          <a:p>
+            <a:pPr algn="ctr" indent="0" marL="0">
+              <a:buNone/>
+            </a:pPr>
+            <a:r>
+              <a:rPr lang="en-US" sz="1300" b="1" dirty="0">
+                <a:solidFill>
+                  <a:schemeClr val="bg1"/>
+                </a:solidFill>
+              </a:rPr>
+              <a:t>공공·교통</a:t>
+            </a:r>
+            <a:endParaRPr lang="en-US" sz="1300" dirty="0"/>
+          </a:p>
+          <a:p>
+            <a:pPr algn="ctr" indent="0" marL="0">
+              <a:buNone/>
+            </a:pPr>
+            <a:r>
+              <a:rPr lang="en-US" sz="1100" b="1" dirty="0">
+                <a:solidFill>
+                  <a:schemeClr val="bg1"/>
+                </a:solidFill>
+              </a:rPr>
+              <a:t>(대외 2개사)</a:t>
+            </a:r>
+            <a:endParaRPr lang="en-US" sz="1300" dirty="0"/>
+          </a:p>
+        </p:txBody>
+      </p:sp>
+      <p:sp>
+        <p:nvSpPr>
+          <p:cNvPr id="56" name="Text 54"/>
+          <p:cNvSpPr txBox="1"/>
+          <p:nvPr/>
+        </p:nvSpPr>
+        <p:spPr>
+          <a:xfrm>
+            <a:off x="1874520" y="5282619"/>
+            <a:ext cx="5715000" cy="522514"/>
+          </a:xfrm>
+          <a:prstGeom prst="rect">
+            <a:avLst/>
+          </a:prstGeom>
+          <a:noFill/>
+          <a:ln/>
+        </p:spPr>
+        <p:txBody>
+          <a:bodyPr wrap="square" lIns="0" tIns="0" rIns="0" bIns="0" rtlCol="0" anchor="ctr"/>
+          <a:lstStyle/>
+          <a:p>
+            <a:pPr marL="342900" indent="-342900">
+              <a:spcAft>
+                <a:spcPts val="200"/>
+              </a:spcAft>
+              <a:buSzPct val="100000"/>
+              <a:buChar char="▶"/>
+            </a:pPr>
+            <a:r>
+              <a:rPr lang="en-US" sz="1050" dirty="0">
+                <a:solidFill>
+                  <a:schemeClr val="tx1"/>
+                </a:solidFill>
+              </a:rPr>
+              <a:t>공항철도: AI 전략수립 및 과제 도출 → AX과제 이행 프로젝트('27, 5.71억)</a:t>
+            </a:r>
+            <a:endParaRPr lang="en-US" sz="1050" dirty="0"/>
+          </a:p>
+          <a:p>
+            <a:pPr marL="342900" indent="-342900">
+              <a:spcAft>
+                <a:spcPts val="200"/>
+              </a:spcAft>
+              <a:buSzPct val="100000"/>
+              <a:buChar char="▶"/>
+            </a:pPr>
+            <a:r>
+              <a:rPr lang="en-US" sz="1050" dirty="0">
+                <a:solidFill>
+                  <a:schemeClr val="tx1"/>
+                </a:solidFill>
+              </a:rPr>
+              <a:t>신분당선: 차세대 Pre컨설팅 → 차세대통합정보시스템 수주(129억) 外</a:t>
+            </a:r>
+            <a:endParaRPr lang="en-US" sz="1050" dirty="0"/>
+          </a:p>
+        </p:txBody>
+      </p:sp>
+      <p:sp>
+        <p:nvSpPr>
+          <p:cNvPr id="57" name="표시 공공·교통 1"/>
+          <p:cNvSpPr/>
+          <p:nvPr/>
+        </p:nvSpPr>
+        <p:spPr>
+          <a:xfrm>
+            <a:off x="7918704" y="5406717"/>
+            <a:ext cx="274320" cy="274320"/>
+          </a:xfrm>
+          <a:prstGeom prst="ellipse">
+            <a:avLst/>
+          </a:prstGeom>
+          <a:solidFill>
+            <a:srgbClr val="1F4E9A"/>
+          </a:solidFill>
+          <a:ln w="15875">
+            <a:solidFill>
+              <a:srgbClr val="1F4E9A"/>
+            </a:solidFill>
+            <a:prstDash val="solid"/>
+          </a:ln>
+        </p:spPr>
+      </p:sp>
+      <p:sp>
+        <p:nvSpPr>
+          <p:cNvPr id="58" name="표시 공공·교통 2"/>
+          <p:cNvSpPr/>
+          <p:nvPr/>
+        </p:nvSpPr>
+        <p:spPr>
+          <a:xfrm>
+            <a:off x="8759952" y="5406717"/>
+            <a:ext cx="274320" cy="274320"/>
+          </a:xfrm>
+          <a:prstGeom prst="ellipse">
+            <a:avLst/>
+          </a:prstGeom>
+          <a:solidFill>
+            <a:srgbClr val="1F4E9A"/>
+          </a:solidFill>
+          <a:ln w="15875">
+            <a:solidFill>
+              <a:srgbClr val="1F4E9A"/>
+            </a:solidFill>
+            <a:prstDash val="solid"/>
+          </a:ln>
+        </p:spPr>
+      </p:sp>
+      <p:sp>
+        <p:nvSpPr>
+          <p:cNvPr id="59" name="표시 공공·교통 3"/>
+          <p:cNvSpPr/>
+          <p:nvPr/>
+        </p:nvSpPr>
+        <p:spPr>
+          <a:xfrm>
+            <a:off x="9601200" y="5406717"/>
+            <a:ext cx="274320" cy="274320"/>
+          </a:xfrm>
+          <a:prstGeom prst="ellipse">
+            <a:avLst/>
+          </a:prstGeom>
+          <a:solidFill>
+            <a:srgbClr val="FFFFFF"/>
+          </a:solidFill>
+          <a:ln w="15875">
+            <a:solidFill>
+              <a:srgbClr val="8A94A6"/>
+            </a:solidFill>
+            <a:prstDash val="solid"/>
+          </a:ln>
+        </p:spPr>
+      </p:sp>
+      <p:sp>
+        <p:nvSpPr>
+          <p:cNvPr id="60" name="표시 공공·교통 4"/>
+          <p:cNvSpPr/>
+          <p:nvPr/>
+        </p:nvSpPr>
+        <p:spPr>
+          <a:xfrm>
+            <a:off x="10442448" y="5406717"/>
+            <a:ext cx="274320" cy="274320"/>
+          </a:xfrm>
+          <a:prstGeom prst="ellipse">
+            <a:avLst/>
+          </a:prstGeom>
+          <a:solidFill>
+            <a:srgbClr val="FFFFFF"/>
+          </a:solidFill>
+          <a:ln w="15875">
+            <a:solidFill>
+              <a:srgbClr val="8A94A6"/>
+            </a:solidFill>
+            <a:prstDash val="solid"/>
+          </a:ln>
+        </p:spPr>
+      </p:sp>
+      <p:sp>
+        <p:nvSpPr>
+          <p:cNvPr id="61" name="표시 공공·교통 5"/>
+          <p:cNvSpPr/>
+          <p:nvPr/>
+        </p:nvSpPr>
+        <p:spPr>
+          <a:xfrm>
+            <a:off x="11283696" y="5406717"/>
+            <a:ext cx="274320" cy="274320"/>
+          </a:xfrm>
+          <a:prstGeom prst="ellipse">
+            <a:avLst/>
+          </a:prstGeom>
+          <a:solidFill>
+            <a:srgbClr val="1F4E9A"/>
+          </a:solidFill>
+          <a:ln w="15875">
+            <a:solidFill>
+              <a:srgbClr val="1F4E9A"/>
+            </a:solidFill>
+            <a:prstDash val="solid"/>
+          </a:ln>
+        </p:spPr>
+      </p:sp>
+      <p:sp>
+        <p:nvSpPr>
+          <p:cNvPr id="62" name="행 구분 7"/>
+          <p:cNvSpPr/>
+          <p:nvPr/>
+        </p:nvSpPr>
+        <p:spPr>
+          <a:xfrm>
+            <a:off x="365760" y="5823422"/>
+            <a:ext cx="11457432" cy="0"/>
+          </a:xfrm>
+          <a:prstGeom prst="line">
+            <a:avLst/>
+          </a:prstGeom>
+          <a:noFill/>
+          <a:ln w="12700">
+            <a:solidFill>
+              <a:srgbClr val="A6ADB8"/>
+            </a:solidFill>
+            <a:prstDash val="solid"/>
+          </a:ln>
+        </p:spPr>
+      </p:sp>
+      <p:sp>
+        <p:nvSpPr>
+          <p:cNvPr id="63" name="행 라벨 제조"/>
+          <p:cNvSpPr txBox="1"/>
+          <p:nvPr/>
+        </p:nvSpPr>
+        <p:spPr>
+          <a:xfrm>
+            <a:off x="365760" y="5859998"/>
+            <a:ext cx="1417320" cy="485938"/>
+          </a:xfrm>
+          <a:prstGeom prst="rect">
+            <a:avLst/>
+          </a:prstGeom>
+          <a:solidFill>
+            <a:schemeClr val="tx2"/>
+          </a:solidFill>
+          <a:ln/>
+        </p:spPr>
+        <p:txBody>
+          <a:bodyPr wrap="square" lIns="0" tIns="0" rIns="0" bIns="0" rtlCol="0" anchor="ctr"/>
+          <a:lstStyle/>
+          <a:p>
+            <a:pPr algn="ctr" indent="0" marL="0">
+              <a:buNone/>
+            </a:pPr>
+            <a:r>
+              <a:rPr lang="en-US" sz="1300" b="1" dirty="0">
+                <a:solidFill>
+                  <a:schemeClr val="bg1"/>
+                </a:solidFill>
+              </a:rPr>
+              <a:t>제조</a:t>
+            </a:r>
+            <a:endParaRPr lang="en-US" sz="1300" dirty="0"/>
+          </a:p>
+          <a:p>
+            <a:pPr algn="ctr" indent="0" marL="0">
+              <a:buNone/>
+            </a:pPr>
+            <a:r>
+              <a:rPr lang="en-US" sz="1100" b="1" dirty="0">
+                <a:solidFill>
+                  <a:schemeClr val="bg1"/>
+                </a:solidFill>
+              </a:rPr>
+              <a:t>(대외 2개사)</a:t>
+            </a:r>
+            <a:endParaRPr lang="en-US" sz="1300" dirty="0"/>
+          </a:p>
+        </p:txBody>
+      </p:sp>
+      <p:sp>
+        <p:nvSpPr>
+          <p:cNvPr id="64" name="Text 62"/>
+          <p:cNvSpPr txBox="1"/>
+          <p:nvPr/>
+        </p:nvSpPr>
+        <p:spPr>
+          <a:xfrm>
+            <a:off x="1874520" y="5841710"/>
+            <a:ext cx="5715000" cy="522514"/>
+          </a:xfrm>
+          <a:prstGeom prst="rect">
+            <a:avLst/>
+          </a:prstGeom>
+          <a:noFill/>
+          <a:ln/>
+        </p:spPr>
+        <p:txBody>
+          <a:bodyPr wrap="square" lIns="0" tIns="0" rIns="0" bIns="0" rtlCol="0" anchor="ctr"/>
+          <a:lstStyle/>
+          <a:p>
+            <a:pPr marL="342900" indent="-342900">
+              <a:spcAft>
+                <a:spcPts val="200"/>
+              </a:spcAft>
+              <a:buSzPct val="100000"/>
+              <a:buChar char="▶"/>
+            </a:pPr>
+            <a:r>
+              <a:rPr lang="en-US" sz="1050" dirty="0">
+                <a:solidFill>
+                  <a:schemeClr val="tx1"/>
+                </a:solidFill>
+              </a:rPr>
+              <a:t>KT&amp;G: 차세대 Pre컨설팅, AI 기반 PLM 고도화 방안 수립 → AI과제 실행('27)</a:t>
+            </a:r>
+            <a:endParaRPr lang="en-US" sz="1050" dirty="0"/>
+          </a:p>
+          <a:p>
+            <a:pPr marL="342900" indent="-342900">
+              <a:spcAft>
+                <a:spcPts val="200"/>
+              </a:spcAft>
+              <a:buSzPct val="100000"/>
+              <a:buChar char="▶"/>
+            </a:pPr>
+            <a:r>
+              <a:rPr lang="en-US" sz="1050" dirty="0">
+                <a:solidFill>
+                  <a:schemeClr val="tx1"/>
+                </a:solidFill>
+              </a:rPr>
+              <a:t>씨텍: 임원·실무자 대상 AI 리터러시·실습 및 과제 도출 교육 外</a:t>
+            </a:r>
+            <a:endParaRPr lang="en-US" sz="1050" dirty="0"/>
+          </a:p>
+        </p:txBody>
+      </p:sp>
+      <p:sp>
+        <p:nvSpPr>
+          <p:cNvPr id="65" name="표시 제조 1"/>
+          <p:cNvSpPr/>
+          <p:nvPr/>
+        </p:nvSpPr>
+        <p:spPr>
+          <a:xfrm>
+            <a:off x="7918704" y="5965807"/>
+            <a:ext cx="274320" cy="274320"/>
+          </a:xfrm>
+          <a:prstGeom prst="ellipse">
+            <a:avLst/>
+          </a:prstGeom>
+          <a:solidFill>
+            <a:srgbClr val="1F4E9A"/>
+          </a:solidFill>
+          <a:ln w="15875">
+            <a:solidFill>
+              <a:srgbClr val="1F4E9A"/>
+            </a:solidFill>
+            <a:prstDash val="solid"/>
+          </a:ln>
+        </p:spPr>
+      </p:sp>
+      <p:sp>
+        <p:nvSpPr>
+          <p:cNvPr id="66" name="표시 제조 2"/>
+          <p:cNvSpPr/>
+          <p:nvPr/>
+        </p:nvSpPr>
+        <p:spPr>
+          <a:xfrm>
+            <a:off x="8759952" y="5965807"/>
+            <a:ext cx="274320" cy="274320"/>
+          </a:xfrm>
+          <a:prstGeom prst="ellipse">
+            <a:avLst/>
+          </a:prstGeom>
+          <a:solidFill>
+            <a:srgbClr val="1F4E9A"/>
+          </a:solidFill>
+          <a:ln w="15875">
+            <a:solidFill>
+              <a:srgbClr val="1F4E9A"/>
+            </a:solidFill>
+            <a:prstDash val="solid"/>
+          </a:ln>
+        </p:spPr>
+      </p:sp>
+      <p:sp>
+        <p:nvSpPr>
+          <p:cNvPr id="67" name="표시 제조 3"/>
+          <p:cNvSpPr/>
+          <p:nvPr/>
+        </p:nvSpPr>
+        <p:spPr>
+          <a:xfrm>
+            <a:off x="9601200" y="5965807"/>
+            <a:ext cx="274320" cy="274320"/>
+          </a:xfrm>
+          <a:prstGeom prst="ellipse">
+            <a:avLst/>
+          </a:prstGeom>
+          <a:solidFill>
+            <a:srgbClr val="FFFFFF"/>
+          </a:solidFill>
+          <a:ln w="15875">
+            <a:solidFill>
+              <a:srgbClr val="8A94A6"/>
+            </a:solidFill>
+            <a:prstDash val="solid"/>
+          </a:ln>
+        </p:spPr>
+      </p:sp>
+      <p:sp>
+        <p:nvSpPr>
+          <p:cNvPr id="68" name="표시 제조 4"/>
+          <p:cNvSpPr/>
+          <p:nvPr/>
+        </p:nvSpPr>
+        <p:spPr>
+          <a:xfrm>
+            <a:off x="10442448" y="5965807"/>
+            <a:ext cx="274320" cy="274320"/>
+          </a:xfrm>
+          <a:prstGeom prst="ellipse">
+            <a:avLst/>
+          </a:prstGeom>
+          <a:solidFill>
+            <a:srgbClr val="1F4E9A"/>
+          </a:solidFill>
+          <a:ln w="15875">
+            <a:solidFill>
+              <a:srgbClr val="1F4E9A"/>
+            </a:solidFill>
+            <a:prstDash val="solid"/>
+          </a:ln>
+        </p:spPr>
+      </p:sp>
+      <p:sp>
+        <p:nvSpPr>
+          <p:cNvPr id="69" name="표시 제조 5"/>
+          <p:cNvSpPr/>
+          <p:nvPr/>
+        </p:nvSpPr>
+        <p:spPr>
+          <a:xfrm>
+            <a:off x="11283696" y="5965807"/>
+            <a:ext cx="274320" cy="274320"/>
+          </a:xfrm>
+          <a:prstGeom prst="ellipse">
+            <a:avLst/>
+          </a:prstGeom>
+          <a:solidFill>
+            <a:srgbClr val="1F4E9A"/>
+          </a:solidFill>
+          <a:ln w="15875">
+            <a:solidFill>
+              <a:srgbClr val="1F4E9A"/>
+            </a:solidFill>
+            <a:prstDash val="solid"/>
+          </a:ln>
+        </p:spPr>
+      </p:sp>
+      <p:sp>
+        <p:nvSpPr>
+          <p:cNvPr id="70" name="행 구분 끝"/>
+          <p:cNvSpPr/>
+          <p:nvPr/>
+        </p:nvSpPr>
+        <p:spPr>
+          <a:xfrm>
+            <a:off x="365760" y="6382512"/>
+            <a:ext cx="11457432" cy="0"/>
+          </a:xfrm>
+          <a:prstGeom prst="line">
+            <a:avLst/>
+          </a:prstGeom>
+          <a:noFill/>
+          <a:ln w="12700">
+            <a:solidFill>
+              <a:srgbClr val="A6ADB8"/>
+            </a:solidFill>
+            <a:prstDash val="solid"/>
+          </a:ln>
+        </p:spPr>
+      </p:sp>
+      <p:sp>
+        <p:nvSpPr>
+          <p:cNvPr id="71" name="실적 요약"/>
+          <p:cNvSpPr txBox="1"/>
+          <p:nvPr/>
+        </p:nvSpPr>
+        <p:spPr>
+          <a:xfrm>
+            <a:off x="365760" y="6455664"/>
+            <a:ext cx="6858000" cy="274320"/>
+          </a:xfrm>
+          <a:prstGeom prst="rect">
+            <a:avLst/>
+          </a:prstGeom>
+          <a:noFill/>
+          <a:ln/>
+        </p:spPr>
+        <p:txBody>
+          <a:bodyPr wrap="square" lIns="0" tIns="0" rIns="0" bIns="0" rtlCol="0" anchor="ctr"/>
+          <a:lstStyle/>
+          <a:p>
+            <a:pPr indent="0" marL="0">
+              <a:buNone/>
+            </a:pPr>
+            <a:r>
+              <a:rPr lang="en-US" sz="1050" b="1" dirty="0">
+                <a:solidFill>
+                  <a:schemeClr val="tx2"/>
+                </a:solidFill>
+              </a:rPr>
+              <a:t>프로젝트 27건 (컨설팅 21 · 교육 6)</a:t>
+            </a:r>
+            <a:pPr indent="0" marL="0">
+              <a:buNone/>
+            </a:pPr>
+            <a:r>
+              <a:rPr lang="en-US" sz="1050" b="1" dirty="0">
+                <a:solidFill>
+                  <a:schemeClr val="accent1"/>
+                </a:solidFill>
+              </a:rPr>
+              <a:t>   |   AI과제 발굴 108건   |   AI 사업 연계 21.1억</a:t>
+            </a:r>
+            <a:endParaRPr lang="en-US" sz="1050" dirty="0"/>
+          </a:p>
+        </p:txBody>
+      </p:sp>
+      <p:sp>
+        <p:nvSpPr>
+          <p:cNvPr id="72" name="범례 수행"/>
+          <p:cNvSpPr/>
+          <p:nvPr/>
+        </p:nvSpPr>
+        <p:spPr>
+          <a:xfrm>
+            <a:off x="7680960" y="6519672"/>
+            <a:ext cx="146304" cy="146304"/>
+          </a:xfrm>
+          <a:prstGeom prst="ellipse">
+            <a:avLst/>
+          </a:prstGeom>
+          <a:solidFill>
+            <a:srgbClr val="1F4E9A"/>
+          </a:solidFill>
+          <a:ln w="12700">
+            <a:solidFill>
+              <a:srgbClr val="1F4E9A"/>
+            </a:solidFill>
+            <a:prstDash val="solid"/>
+          </a:ln>
+        </p:spPr>
+      </p:sp>
+      <p:sp>
+        <p:nvSpPr>
+          <p:cNvPr id="73" name="Text 71"/>
+          <p:cNvSpPr txBox="1"/>
+          <p:nvPr/>
+        </p:nvSpPr>
+        <p:spPr>
+          <a:xfrm>
+            <a:off x="7863840" y="6455664"/>
+            <a:ext cx="457200" cy="274320"/>
+          </a:xfrm>
+          <a:prstGeom prst="rect">
+            <a:avLst/>
+          </a:prstGeom>
+          <a:noFill/>
+          <a:ln/>
+        </p:spPr>
+        <p:txBody>
+          <a:bodyPr wrap="square" lIns="0" tIns="0" rIns="0" bIns="0" rtlCol="0" anchor="ctr"/>
+          <a:lstStyle/>
+          <a:p>
+            <a:pPr indent="0" marL="0">
+              <a:buNone/>
+            </a:pPr>
+            <a:r>
+              <a:rPr lang="en-US" sz="950" dirty="0">
+                <a:solidFill>
+                  <a:schemeClr val="tx1"/>
+                </a:solidFill>
+              </a:rPr>
+              <a:t>수행</a:t>
+            </a:r>
+            <a:endParaRPr lang="en-US" sz="950" dirty="0"/>
+          </a:p>
+        </p:txBody>
+      </p:sp>
+      <p:sp>
+        <p:nvSpPr>
+          <p:cNvPr id="74" name="범례 미수행"/>
+          <p:cNvSpPr/>
+          <p:nvPr/>
+        </p:nvSpPr>
+        <p:spPr>
+          <a:xfrm>
+            <a:off x="8366760" y="6519672"/>
+            <a:ext cx="146304" cy="146304"/>
+          </a:xfrm>
+          <a:prstGeom prst="ellipse">
+            <a:avLst/>
+          </a:prstGeom>
+          <a:solidFill>
+            <a:srgbClr val="FFFFFF"/>
+          </a:solidFill>
+          <a:ln w="12700">
+            <a:solidFill>
+              <a:srgbClr val="8A94A6"/>
+            </a:solidFill>
+            <a:prstDash val="solid"/>
+          </a:ln>
+        </p:spPr>
+      </p:sp>
+      <p:sp>
+        <p:nvSpPr>
+          <p:cNvPr id="75" name="Text 73"/>
+          <p:cNvSpPr txBox="1"/>
+          <p:nvPr/>
+        </p:nvSpPr>
+        <p:spPr>
+          <a:xfrm>
+            <a:off x="8549640" y="6455664"/>
+            <a:ext cx="822960" cy="274320"/>
+          </a:xfrm>
+          <a:prstGeom prst="rect">
+            <a:avLst/>
+          </a:prstGeom>
+          <a:noFill/>
+          <a:ln/>
+        </p:spPr>
+        <p:txBody>
+          <a:bodyPr wrap="square" lIns="0" tIns="0" rIns="0" bIns="0" rtlCol="0" anchor="ctr"/>
+          <a:lstStyle/>
+          <a:p>
+            <a:pPr indent="0" marL="0">
+              <a:buNone/>
+            </a:pPr>
+            <a:r>
+              <a:rPr lang="en-US" sz="950" dirty="0">
+                <a:solidFill>
+                  <a:schemeClr val="tx1"/>
+                </a:solidFill>
+              </a:rPr>
+              <a:t>해당 없음</a:t>
+            </a:r>
+            <a:endParaRPr lang="en-US" sz="950" dirty="0"/>
           </a:p>
         </p:txBody>
       </p:sp>

</xml_diff>